<commit_message>
Short brief: model-family diagram, repeatability, human-judgement channel, evidence kept over time
Co-Authored-By: Claude Fable 5.1 <noreply@anthropic.com>
</commit_message>
<xml_diff>
--- a/docs/FedCast_Fullerton_short.pptx
+++ b/docs/FedCast_Fullerton_short.pptx
@@ -109,7 +109,7 @@
   <p:extLst>
     <p:ext uri="{521415D9-36F7-43E2-AB2F-B90AF26B5E84}">
       <p14:sectionLst xmlns:p14="http://schemas.microsoft.com/office/powerpoint/2010/main">
-        <p14:section name="Brief" id="{9dc658d5-145d-479c-b52c-c5ffdaed3965}">
+        <p14:section name="Brief" id="{d0666e98-9957-50a5-37c3-4adf743b8f7b}">
           <p14:sldIdLst>
             <p14:sldId id="256"/>
             <p14:sldId id="257"/>
@@ -696,7 +696,7 @@
           <a:p>
             <a:r>
               <a:rPr lang="en-US" dirty="0"/>
-              <a:t>Left: what it is in five lines and today's number. Right: the four reasons, with the honest framing that at five weeks the market is the anchor and the claim is a checkable number, a reusable harness and a method for deciding when a language model may be trusted inside a process. Close on the last line: the first live decision is scored this week.</a:t>
+              <a:t>Thirty seconds on the top line, then the diagram: four families of input, pooled by code with fixed weights, into one number. Then the three panels: how repeatability is enforced, why human judgement has a typed channel even though none is active today, and that every piece of evidence is frozen so the number's path over time can be read back.</a:t>
             </a:r>
             <a:endParaRPr lang="en-US" dirty="0"/>
           </a:p>
@@ -2499,18 +2499,926 @@
       </p:sp>
       <p:sp>
         <p:nvSpPr>
-          <p:cNvPr id="4" name="Shape 1"/>
+          <p:cNvPr id="4" name="Text 1"/>
+          <p:cNvSpPr txBox="1"/>
+          <p:nvPr/>
+        </p:nvSpPr>
+        <p:spPr>
+          <a:xfrm>
+            <a:off x="548640" y="1280160"/>
+            <a:ext cx="11091672" cy="548640"/>
+          </a:xfrm>
+          <a:prstGeom prst="rect">
+            <a:avLst/>
+          </a:prstGeom>
+          <a:noFill/>
+          <a:ln/>
+        </p:spPr>
+        <p:txBody>
+          <a:bodyPr wrap="square" lIns="0" tIns="0" rIns="0" bIns="0" rtlCol="0" anchor="t"/>
+          <a:lstStyle/>
+          <a:p>
+            <a:pPr indent="0" marL="0">
+              <a:buNone/>
+            </a:pPr>
+            <a:r>
+              <a:rPr lang="en-US" sz="1400" dirty="0">
+                <a:solidFill>
+                  <a:schemeClr val="tx1"/>
+                </a:solidFill>
+              </a:rPr>
+              <a:t>A forecast of the next FOMC decision as probabilities over five outcomes, from one frozen snapshot of evidence. Today, for 28 October 2026: no change 71%, +25 bps 23%.</a:t>
+            </a:r>
+            <a:endParaRPr lang="en-US" sz="1400" dirty="0"/>
+          </a:p>
+        </p:txBody>
+      </p:sp>
+      <p:sp>
+        <p:nvSpPr>
+          <p:cNvPr id="5" name="Shape 2"/>
           <p:cNvSpPr/>
           <p:nvPr/>
         </p:nvSpPr>
         <p:spPr>
           <a:xfrm>
-            <a:off x="548640" y="1371600"/>
-            <a:ext cx="5120640" cy="4846320"/>
+            <a:off x="548640" y="2011680"/>
+            <a:ext cx="2103120" cy="960120"/>
           </a:xfrm>
           <a:prstGeom prst="roundRect">
             <a:avLst>
-              <a:gd name="adj" fmla="val 2264"/>
+              <a:gd name="adj" fmla="val 9524"/>
+            </a:avLst>
+          </a:prstGeom>
+          <a:solidFill>
+            <a:srgbClr val="1E2761"/>
+          </a:solidFill>
+          <a:ln w="12700">
+            <a:solidFill>
+              <a:srgbClr val="1E2761"/>
+            </a:solidFill>
+            <a:prstDash val="solid"/>
+          </a:ln>
+        </p:spPr>
+      </p:sp>
+      <p:sp>
+        <p:nvSpPr>
+          <p:cNvPr id="6" name="Text 3"/>
+          <p:cNvSpPr txBox="1"/>
+          <p:nvPr/>
+        </p:nvSpPr>
+        <p:spPr>
+          <a:xfrm>
+            <a:off x="685800" y="2084832"/>
+            <a:ext cx="1828800" cy="292608"/>
+          </a:xfrm>
+          <a:prstGeom prst="rect">
+            <a:avLst/>
+          </a:prstGeom>
+          <a:noFill/>
+          <a:ln/>
+        </p:spPr>
+        <p:txBody>
+          <a:bodyPr wrap="square" lIns="0" tIns="0" rIns="0" bIns="0" rtlCol="0" anchor="t"/>
+          <a:lstStyle/>
+          <a:p>
+            <a:pPr indent="0" marL="0">
+              <a:buNone/>
+            </a:pPr>
+            <a:r>
+              <a:rPr lang="en-US" sz="1300" b="1" dirty="0">
+                <a:solidFill>
+                  <a:schemeClr val="bg1"/>
+                </a:solidFill>
+              </a:rPr>
+              <a:t>Economic predictors</a:t>
+            </a:r>
+            <a:endParaRPr lang="en-US" sz="1300" dirty="0"/>
+          </a:p>
+        </p:txBody>
+      </p:sp>
+      <p:sp>
+        <p:nvSpPr>
+          <p:cNvPr id="7" name="Text 4"/>
+          <p:cNvSpPr txBox="1"/>
+          <p:nvPr/>
+        </p:nvSpPr>
+        <p:spPr>
+          <a:xfrm>
+            <a:off x="685800" y="2377440"/>
+            <a:ext cx="1828800" cy="566928"/>
+          </a:xfrm>
+          <a:prstGeom prst="rect">
+            <a:avLst/>
+          </a:prstGeom>
+          <a:noFill/>
+          <a:ln/>
+        </p:spPr>
+        <p:txBody>
+          <a:bodyPr wrap="square" lIns="0" tIns="0" rIns="0" bIns="0" rtlCol="0" anchor="t"/>
+          <a:lstStyle/>
+          <a:p>
+            <a:pPr indent="0" marL="0">
+              <a:buNone/>
+            </a:pPr>
+            <a:r>
+              <a:rPr lang="en-US" sz="950" dirty="0">
+                <a:solidFill>
+                  <a:schemeClr val="bg1"/>
+                </a:solidFill>
+              </a:rPr>
+              <a:t>Fed funds futures, the Fed's Taylor rules, prediction-market odds</a:t>
+            </a:r>
+            <a:endParaRPr lang="en-US" sz="950" dirty="0"/>
+          </a:p>
+        </p:txBody>
+      </p:sp>
+      <p:sp>
+        <p:nvSpPr>
+          <p:cNvPr id="8" name="Text 5"/>
+          <p:cNvSpPr txBox="1"/>
+          <p:nvPr/>
+        </p:nvSpPr>
+        <p:spPr>
+          <a:xfrm>
+            <a:off x="2761488" y="2240280"/>
+            <a:ext cx="1325880" cy="548640"/>
+          </a:xfrm>
+          <a:prstGeom prst="rect">
+            <a:avLst/>
+          </a:prstGeom>
+          <a:noFill/>
+          <a:ln/>
+        </p:spPr>
+        <p:txBody>
+          <a:bodyPr wrap="square" lIns="0" tIns="0" rIns="0" bIns="0" rtlCol="0" anchor="ctr"/>
+          <a:lstStyle/>
+          <a:p>
+            <a:pPr indent="0" marL="0">
+              <a:buNone/>
+            </a:pPr>
+            <a:r>
+              <a:rPr lang="en-US" sz="900" dirty="0">
+                <a:solidFill>
+                  <a:schemeClr val="accent4"/>
+                </a:solidFill>
+              </a:rPr>
+              <a:t>weights 0.6 · 0.2 · 0.1</a:t>
+            </a:r>
+            <a:endParaRPr lang="en-US" sz="900" dirty="0"/>
+          </a:p>
+        </p:txBody>
+      </p:sp>
+      <p:sp>
+        <p:nvSpPr>
+          <p:cNvPr id="9" name="Shape 6"/>
+          <p:cNvSpPr/>
+          <p:nvPr/>
+        </p:nvSpPr>
+        <p:spPr>
+          <a:xfrm>
+            <a:off x="4114800" y="2491740"/>
+            <a:ext cx="411480" cy="0"/>
+          </a:xfrm>
+          <a:prstGeom prst="line">
+            <a:avLst/>
+          </a:prstGeom>
+          <a:noFill/>
+          <a:ln w="19050">
+            <a:solidFill>
+              <a:srgbClr val="6B7280"/>
+            </a:solidFill>
+            <a:prstDash val="solid"/>
+            <a:tailEnd type="triangle"/>
+          </a:ln>
+        </p:spPr>
+      </p:sp>
+      <p:sp>
+        <p:nvSpPr>
+          <p:cNvPr id="10" name="Shape 7"/>
+          <p:cNvSpPr/>
+          <p:nvPr/>
+        </p:nvSpPr>
+        <p:spPr>
+          <a:xfrm>
+            <a:off x="548640" y="3081528"/>
+            <a:ext cx="2103120" cy="960120"/>
+          </a:xfrm>
+          <a:prstGeom prst="roundRect">
+            <a:avLst>
+              <a:gd name="adj" fmla="val 9524"/>
+            </a:avLst>
+          </a:prstGeom>
+          <a:solidFill>
+            <a:srgbClr val="1E2761"/>
+          </a:solidFill>
+          <a:ln w="12700">
+            <a:solidFill>
+              <a:srgbClr val="1E2761"/>
+            </a:solidFill>
+            <a:prstDash val="solid"/>
+          </a:ln>
+        </p:spPr>
+      </p:sp>
+      <p:sp>
+        <p:nvSpPr>
+          <p:cNvPr id="11" name="Text 8"/>
+          <p:cNvSpPr txBox="1"/>
+          <p:nvPr/>
+        </p:nvSpPr>
+        <p:spPr>
+          <a:xfrm>
+            <a:off x="685800" y="3154680"/>
+            <a:ext cx="1828800" cy="292608"/>
+          </a:xfrm>
+          <a:prstGeom prst="rect">
+            <a:avLst/>
+          </a:prstGeom>
+          <a:noFill/>
+          <a:ln/>
+        </p:spPr>
+        <p:txBody>
+          <a:bodyPr wrap="square" lIns="0" tIns="0" rIns="0" bIns="0" rtlCol="0" anchor="t"/>
+          <a:lstStyle/>
+          <a:p>
+            <a:pPr indent="0" marL="0">
+              <a:buNone/>
+            </a:pPr>
+            <a:r>
+              <a:rPr lang="en-US" sz="1300" b="1" dirty="0">
+                <a:solidFill>
+                  <a:schemeClr val="bg1"/>
+                </a:solidFill>
+              </a:rPr>
+              <a:t>Empirical data</a:t>
+            </a:r>
+            <a:endParaRPr lang="en-US" sz="1300" dirty="0"/>
+          </a:p>
+        </p:txBody>
+      </p:sp>
+      <p:sp>
+        <p:nvSpPr>
+          <p:cNvPr id="12" name="Text 9"/>
+          <p:cNvSpPr txBox="1"/>
+          <p:nvPr/>
+        </p:nvSpPr>
+        <p:spPr>
+          <a:xfrm>
+            <a:off x="685800" y="3447288"/>
+            <a:ext cx="1828800" cy="566928"/>
+          </a:xfrm>
+          <a:prstGeom prst="rect">
+            <a:avLst/>
+          </a:prstGeom>
+          <a:noFill/>
+          <a:ln/>
+        </p:spPr>
+        <p:txBody>
+          <a:bodyPr wrap="square" lIns="0" tIns="0" rIns="0" bIns="0" rtlCol="0" anchor="t"/>
+          <a:lstStyle/>
+          <a:p>
+            <a:pPr indent="0" marL="0">
+              <a:buNone/>
+            </a:pPr>
+            <a:r>
+              <a:rPr lang="en-US" sz="950" dirty="0">
+                <a:solidFill>
+                  <a:schemeClr val="bg1"/>
+                </a:solidFill>
+              </a:rPr>
+              <a:t>What followed each kind of decision over 32 years of FOMC history</a:t>
+            </a:r>
+            <a:endParaRPr lang="en-US" sz="950" dirty="0"/>
+          </a:p>
+        </p:txBody>
+      </p:sp>
+      <p:sp>
+        <p:nvSpPr>
+          <p:cNvPr id="13" name="Text 10"/>
+          <p:cNvSpPr txBox="1"/>
+          <p:nvPr/>
+        </p:nvSpPr>
+        <p:spPr>
+          <a:xfrm>
+            <a:off x="2761488" y="3310128"/>
+            <a:ext cx="1325880" cy="548640"/>
+          </a:xfrm>
+          <a:prstGeom prst="rect">
+            <a:avLst/>
+          </a:prstGeom>
+          <a:noFill/>
+          <a:ln/>
+        </p:spPr>
+        <p:txBody>
+          <a:bodyPr wrap="square" lIns="0" tIns="0" rIns="0" bIns="0" rtlCol="0" anchor="ctr"/>
+          <a:lstStyle/>
+          <a:p>
+            <a:pPr indent="0" marL="0">
+              <a:buNone/>
+            </a:pPr>
+            <a:r>
+              <a:rPr lang="en-US" sz="900" dirty="0">
+                <a:solidFill>
+                  <a:schemeClr val="accent4"/>
+                </a:solidFill>
+              </a:rPr>
+              <a:t>weight 0.1</a:t>
+            </a:r>
+            <a:endParaRPr lang="en-US" sz="900" dirty="0"/>
+          </a:p>
+        </p:txBody>
+      </p:sp>
+      <p:sp>
+        <p:nvSpPr>
+          <p:cNvPr id="14" name="Shape 11"/>
+          <p:cNvSpPr/>
+          <p:nvPr/>
+        </p:nvSpPr>
+        <p:spPr>
+          <a:xfrm>
+            <a:off x="4114800" y="3561588"/>
+            <a:ext cx="411480" cy="0"/>
+          </a:xfrm>
+          <a:prstGeom prst="line">
+            <a:avLst/>
+          </a:prstGeom>
+          <a:noFill/>
+          <a:ln w="19050">
+            <a:solidFill>
+              <a:srgbClr val="6B7280"/>
+            </a:solidFill>
+            <a:prstDash val="solid"/>
+            <a:tailEnd type="triangle"/>
+          </a:ln>
+        </p:spPr>
+      </p:sp>
+      <p:sp>
+        <p:nvSpPr>
+          <p:cNvPr id="15" name="Shape 12"/>
+          <p:cNvSpPr/>
+          <p:nvPr/>
+        </p:nvSpPr>
+        <p:spPr>
+          <a:xfrm>
+            <a:off x="548640" y="4151376"/>
+            <a:ext cx="2103120" cy="960120"/>
+          </a:xfrm>
+          <a:prstGeom prst="roundRect">
+            <a:avLst>
+              <a:gd name="adj" fmla="val 9524"/>
+            </a:avLst>
+          </a:prstGeom>
+          <a:solidFill>
+            <a:srgbClr val="6B7280"/>
+          </a:solidFill>
+          <a:ln w="12700">
+            <a:solidFill>
+              <a:srgbClr val="6B7280"/>
+            </a:solidFill>
+            <a:prstDash val="solid"/>
+          </a:ln>
+        </p:spPr>
+      </p:sp>
+      <p:sp>
+        <p:nvSpPr>
+          <p:cNvPr id="16" name="Text 13"/>
+          <p:cNvSpPr txBox="1"/>
+          <p:nvPr/>
+        </p:nvSpPr>
+        <p:spPr>
+          <a:xfrm>
+            <a:off x="685800" y="4224528"/>
+            <a:ext cx="1828800" cy="292608"/>
+          </a:xfrm>
+          <a:prstGeom prst="rect">
+            <a:avLst/>
+          </a:prstGeom>
+          <a:noFill/>
+          <a:ln/>
+        </p:spPr>
+        <p:txBody>
+          <a:bodyPr wrap="square" lIns="0" tIns="0" rIns="0" bIns="0" rtlCol="0" anchor="t"/>
+          <a:lstStyle/>
+          <a:p>
+            <a:pPr indent="0" marL="0">
+              <a:buNone/>
+            </a:pPr>
+            <a:r>
+              <a:rPr lang="en-US" sz="1300" b="1" dirty="0">
+                <a:solidFill>
+                  <a:schemeClr val="bg1"/>
+                </a:solidFill>
+              </a:rPr>
+              <a:t>Classic ML</a:t>
+            </a:r>
+            <a:endParaRPr lang="en-US" sz="1300" dirty="0"/>
+          </a:p>
+        </p:txBody>
+      </p:sp>
+      <p:sp>
+        <p:nvSpPr>
+          <p:cNvPr id="17" name="Text 14"/>
+          <p:cNvSpPr txBox="1"/>
+          <p:nvPr/>
+        </p:nvSpPr>
+        <p:spPr>
+          <a:xfrm>
+            <a:off x="685800" y="4517136"/>
+            <a:ext cx="1828800" cy="566928"/>
+          </a:xfrm>
+          <a:prstGeom prst="rect">
+            <a:avLst/>
+          </a:prstGeom>
+          <a:noFill/>
+          <a:ln/>
+        </p:spPr>
+        <p:txBody>
+          <a:bodyPr wrap="square" lIns="0" tIns="0" rIns="0" bIns="0" rtlCol="0" anchor="t"/>
+          <a:lstStyle/>
+          <a:p>
+            <a:pPr indent="0" marL="0">
+              <a:buNone/>
+            </a:pPr>
+            <a:r>
+              <a:rPr lang="en-US" sz="950" dirty="0">
+                <a:solidFill>
+                  <a:schemeClr val="bg1"/>
+                </a:solidFill>
+              </a:rPr>
+              <a:t>An ordered probit fitted on data as first published</a:t>
+            </a:r>
+            <a:endParaRPr lang="en-US" sz="950" dirty="0"/>
+          </a:p>
+        </p:txBody>
+      </p:sp>
+      <p:sp>
+        <p:nvSpPr>
+          <p:cNvPr id="18" name="Text 15"/>
+          <p:cNvSpPr txBox="1"/>
+          <p:nvPr/>
+        </p:nvSpPr>
+        <p:spPr>
+          <a:xfrm>
+            <a:off x="2761488" y="4379976"/>
+            <a:ext cx="1325880" cy="548640"/>
+          </a:xfrm>
+          <a:prstGeom prst="rect">
+            <a:avLst/>
+          </a:prstGeom>
+          <a:noFill/>
+          <a:ln/>
+        </p:spPr>
+        <p:txBody>
+          <a:bodyPr wrap="square" lIns="0" tIns="0" rIns="0" bIns="0" rtlCol="0" anchor="ctr"/>
+          <a:lstStyle/>
+          <a:p>
+            <a:pPr indent="0" marL="0">
+              <a:buNone/>
+            </a:pPr>
+            <a:r>
+              <a:rPr lang="en-US" sz="900" dirty="0">
+                <a:solidFill>
+                  <a:schemeClr val="accent4"/>
+                </a:solidFill>
+              </a:rPr>
+              <a:t>computed, weight 0 until it has a live record</a:t>
+            </a:r>
+            <a:endParaRPr lang="en-US" sz="900" dirty="0"/>
+          </a:p>
+        </p:txBody>
+      </p:sp>
+      <p:sp>
+        <p:nvSpPr>
+          <p:cNvPr id="19" name="Shape 16"/>
+          <p:cNvSpPr/>
+          <p:nvPr/>
+        </p:nvSpPr>
+        <p:spPr>
+          <a:xfrm>
+            <a:off x="4114800" y="4631436"/>
+            <a:ext cx="411480" cy="0"/>
+          </a:xfrm>
+          <a:prstGeom prst="line">
+            <a:avLst/>
+          </a:prstGeom>
+          <a:noFill/>
+          <a:ln w="19050">
+            <a:solidFill>
+              <a:srgbClr val="6B7280"/>
+            </a:solidFill>
+            <a:prstDash val="solid"/>
+            <a:tailEnd type="triangle"/>
+          </a:ln>
+        </p:spPr>
+      </p:sp>
+      <p:sp>
+        <p:nvSpPr>
+          <p:cNvPr id="20" name="Shape 17"/>
+          <p:cNvSpPr/>
+          <p:nvPr/>
+        </p:nvSpPr>
+        <p:spPr>
+          <a:xfrm>
+            <a:off x="548640" y="5221224"/>
+            <a:ext cx="2103120" cy="960120"/>
+          </a:xfrm>
+          <a:prstGeom prst="roundRect">
+            <a:avLst>
+              <a:gd name="adj" fmla="val 9524"/>
+            </a:avLst>
+          </a:prstGeom>
+          <a:solidFill>
+            <a:srgbClr val="C8553D"/>
+          </a:solidFill>
+          <a:ln w="12700">
+            <a:solidFill>
+              <a:srgbClr val="C8553D"/>
+            </a:solidFill>
+            <a:prstDash val="solid"/>
+          </a:ln>
+        </p:spPr>
+      </p:sp>
+      <p:sp>
+        <p:nvSpPr>
+          <p:cNvPr id="21" name="Text 18"/>
+          <p:cNvSpPr txBox="1"/>
+          <p:nvPr/>
+        </p:nvSpPr>
+        <p:spPr>
+          <a:xfrm>
+            <a:off x="685800" y="5294376"/>
+            <a:ext cx="1828800" cy="292608"/>
+          </a:xfrm>
+          <a:prstGeom prst="rect">
+            <a:avLst/>
+          </a:prstGeom>
+          <a:noFill/>
+          <a:ln/>
+        </p:spPr>
+        <p:txBody>
+          <a:bodyPr wrap="square" lIns="0" tIns="0" rIns="0" bIns="0" rtlCol="0" anchor="t"/>
+          <a:lstStyle/>
+          <a:p>
+            <a:pPr indent="0" marL="0">
+              <a:buNone/>
+            </a:pPr>
+            <a:r>
+              <a:rPr lang="en-US" sz="1300" b="1" dirty="0">
+                <a:solidFill>
+                  <a:schemeClr val="bg1"/>
+                </a:solidFill>
+              </a:rPr>
+              <a:t>LLM-derived</a:t>
+            </a:r>
+            <a:endParaRPr lang="en-US" sz="1300" dirty="0"/>
+          </a:p>
+        </p:txBody>
+      </p:sp>
+      <p:sp>
+        <p:nvSpPr>
+          <p:cNvPr id="22" name="Text 19"/>
+          <p:cNvSpPr txBox="1"/>
+          <p:nvPr/>
+        </p:nvSpPr>
+        <p:spPr>
+          <a:xfrm>
+            <a:off x="685800" y="5586984"/>
+            <a:ext cx="1828800" cy="566928"/>
+          </a:xfrm>
+          <a:prstGeom prst="rect">
+            <a:avLst/>
+          </a:prstGeom>
+          <a:noFill/>
+          <a:ln/>
+        </p:spPr>
+        <p:txBody>
+          <a:bodyPr wrap="square" lIns="0" tIns="0" rIns="0" bIns="0" rtlCol="0" anchor="t"/>
+          <a:lstStyle/>
+          <a:p>
+            <a:pPr indent="0" marL="0">
+              <a:buNone/>
+            </a:pPr>
+            <a:r>
+              <a:rPr lang="en-US" sz="950" dirty="0">
+                <a:solidFill>
+                  <a:schemeClr val="bg1"/>
+                </a:solidFill>
+              </a:rPr>
+              <a:t>Five specialist analysts reading the Fed's own words, every claim quoted and verified by code</a:t>
+            </a:r>
+            <a:endParaRPr lang="en-US" sz="950" dirty="0"/>
+          </a:p>
+        </p:txBody>
+      </p:sp>
+      <p:sp>
+        <p:nvSpPr>
+          <p:cNvPr id="23" name="Text 20"/>
+          <p:cNvSpPr txBox="1"/>
+          <p:nvPr/>
+        </p:nvSpPr>
+        <p:spPr>
+          <a:xfrm>
+            <a:off x="2761488" y="5449824"/>
+            <a:ext cx="1325880" cy="548640"/>
+          </a:xfrm>
+          <a:prstGeom prst="rect">
+            <a:avLst/>
+          </a:prstGeom>
+          <a:noFill/>
+          <a:ln/>
+        </p:spPr>
+        <p:txBody>
+          <a:bodyPr wrap="square" lIns="0" tIns="0" rIns="0" bIns="0" rtlCol="0" anchor="ctr"/>
+          <a:lstStyle/>
+          <a:p>
+            <a:pPr indent="0" marL="0">
+              <a:buNone/>
+            </a:pPr>
+            <a:r>
+              <a:rPr lang="en-US" sz="900" dirty="0">
+                <a:solidFill>
+                  <a:schemeClr val="accent4"/>
+                </a:solidFill>
+              </a:rPr>
+              <a:t>a lean of at most 10 points</a:t>
+            </a:r>
+            <a:endParaRPr lang="en-US" sz="900" dirty="0"/>
+          </a:p>
+        </p:txBody>
+      </p:sp>
+      <p:sp>
+        <p:nvSpPr>
+          <p:cNvPr id="24" name="Shape 21"/>
+          <p:cNvSpPr/>
+          <p:nvPr/>
+        </p:nvSpPr>
+        <p:spPr>
+          <a:xfrm>
+            <a:off x="4114800" y="5701284"/>
+            <a:ext cx="411480" cy="0"/>
+          </a:xfrm>
+          <a:prstGeom prst="line">
+            <a:avLst/>
+          </a:prstGeom>
+          <a:noFill/>
+          <a:ln w="19050">
+            <a:solidFill>
+              <a:srgbClr val="6B7280"/>
+            </a:solidFill>
+            <a:prstDash val="solid"/>
+            <a:tailEnd type="triangle"/>
+          </a:ln>
+        </p:spPr>
+      </p:sp>
+      <p:sp>
+        <p:nvSpPr>
+          <p:cNvPr id="25" name="Shape 22"/>
+          <p:cNvSpPr/>
+          <p:nvPr/>
+        </p:nvSpPr>
+        <p:spPr>
+          <a:xfrm>
+            <a:off x="4572000" y="2011680"/>
+            <a:ext cx="1188720" cy="4169664"/>
+          </a:xfrm>
+          <a:prstGeom prst="roundRect">
+            <a:avLst>
+              <a:gd name="adj" fmla="val 7692"/>
+            </a:avLst>
+          </a:prstGeom>
+          <a:solidFill>
+            <a:srgbClr val="EEF2F7"/>
+          </a:solidFill>
+          <a:ln w="12700">
+            <a:solidFill>
+              <a:srgbClr val="CADCFC"/>
+            </a:solidFill>
+            <a:prstDash val="solid"/>
+          </a:ln>
+        </p:spPr>
+      </p:sp>
+      <p:sp>
+        <p:nvSpPr>
+          <p:cNvPr id="26" name="Text 23"/>
+          <p:cNvSpPr txBox="1"/>
+          <p:nvPr/>
+        </p:nvSpPr>
+        <p:spPr>
+          <a:xfrm>
+            <a:off x="4572000" y="2286000"/>
+            <a:ext cx="1188720" cy="365760"/>
+          </a:xfrm>
+          <a:prstGeom prst="rect">
+            <a:avLst/>
+          </a:prstGeom>
+          <a:noFill/>
+          <a:ln/>
+        </p:spPr>
+        <p:txBody>
+          <a:bodyPr wrap="square" lIns="0" tIns="0" rIns="0" bIns="0" rtlCol="0" anchor="t"/>
+          <a:lstStyle/>
+          <a:p>
+            <a:pPr algn="ctr" indent="0" marL="0">
+              <a:buNone/>
+            </a:pPr>
+            <a:r>
+              <a:rPr lang="en-US" sz="1500" b="1" dirty="0">
+                <a:solidFill>
+                  <a:schemeClr val="tx2"/>
+                </a:solidFill>
+              </a:rPr>
+              <a:t>Pool</a:t>
+            </a:r>
+            <a:endParaRPr lang="en-US" sz="1500" dirty="0"/>
+          </a:p>
+        </p:txBody>
+      </p:sp>
+      <p:sp>
+        <p:nvSpPr>
+          <p:cNvPr id="27" name="Text 24"/>
+          <p:cNvSpPr txBox="1"/>
+          <p:nvPr/>
+        </p:nvSpPr>
+        <p:spPr>
+          <a:xfrm>
+            <a:off x="4663440" y="2743200"/>
+            <a:ext cx="1005840" cy="3200400"/>
+          </a:xfrm>
+          <a:prstGeom prst="rect">
+            <a:avLst/>
+          </a:prstGeom>
+          <a:noFill/>
+          <a:ln/>
+        </p:spPr>
+        <p:txBody>
+          <a:bodyPr wrap="square" lIns="0" tIns="0" rIns="0" bIns="0" rtlCol="0" anchor="t"/>
+          <a:lstStyle/>
+          <a:p>
+            <a:pPr algn="ctr" indent="0" marL="0">
+              <a:buNone/>
+            </a:pPr>
+            <a:r>
+              <a:rPr lang="en-US" sz="900" dirty="0">
+                <a:solidFill>
+                  <a:schemeClr val="tx1"/>
+                </a:solidFill>
+              </a:rPr>
+              <a:t>Fixed, recorded weights. A floor of 1.5% on every outcome. Then the analysts' lean. Code does this; no model writes the number.</a:t>
+            </a:r>
+            <a:endParaRPr lang="en-US" sz="900" dirty="0"/>
+          </a:p>
+        </p:txBody>
+      </p:sp>
+      <p:sp>
+        <p:nvSpPr>
+          <p:cNvPr id="28" name="Shape 25"/>
+          <p:cNvSpPr/>
+          <p:nvPr/>
+        </p:nvSpPr>
+        <p:spPr>
+          <a:xfrm>
+            <a:off x="5806440" y="4096512"/>
+            <a:ext cx="365760" cy="0"/>
+          </a:xfrm>
+          <a:prstGeom prst="line">
+            <a:avLst/>
+          </a:prstGeom>
+          <a:noFill/>
+          <a:ln w="19050">
+            <a:solidFill>
+              <a:srgbClr val="6B7280"/>
+            </a:solidFill>
+            <a:prstDash val="solid"/>
+            <a:tailEnd type="triangle"/>
+          </a:ln>
+        </p:spPr>
+      </p:sp>
+      <p:sp>
+        <p:nvSpPr>
+          <p:cNvPr id="29" name="Shape 26"/>
+          <p:cNvSpPr/>
+          <p:nvPr/>
+        </p:nvSpPr>
+        <p:spPr>
+          <a:xfrm>
+            <a:off x="6263640" y="3410712"/>
+            <a:ext cx="1234440" cy="1371600"/>
+          </a:xfrm>
+          <a:prstGeom prst="roundRect">
+            <a:avLst>
+              <a:gd name="adj" fmla="val 7407"/>
+            </a:avLst>
+          </a:prstGeom>
+          <a:solidFill>
+            <a:srgbClr val="1E2761"/>
+          </a:solidFill>
+          <a:ln w="12700">
+            <a:solidFill>
+              <a:srgbClr val="1E2761"/>
+            </a:solidFill>
+            <a:prstDash val="solid"/>
+          </a:ln>
+        </p:spPr>
+      </p:sp>
+      <p:sp>
+        <p:nvSpPr>
+          <p:cNvPr id="30" name="Text 27"/>
+          <p:cNvSpPr txBox="1"/>
+          <p:nvPr/>
+        </p:nvSpPr>
+        <p:spPr>
+          <a:xfrm>
+            <a:off x="6263640" y="3502152"/>
+            <a:ext cx="1234440" cy="365760"/>
+          </a:xfrm>
+          <a:prstGeom prst="rect">
+            <a:avLst/>
+          </a:prstGeom>
+          <a:noFill/>
+          <a:ln/>
+        </p:spPr>
+        <p:txBody>
+          <a:bodyPr wrap="square" lIns="0" tIns="0" rIns="0" bIns="0" rtlCol="0" anchor="t"/>
+          <a:lstStyle/>
+          <a:p>
+            <a:pPr algn="ctr" indent="0" marL="0">
+              <a:buNone/>
+            </a:pPr>
+            <a:r>
+              <a:rPr lang="en-US" sz="1400" b="1" dirty="0">
+                <a:solidFill>
+                  <a:schemeClr val="bg1"/>
+                </a:solidFill>
+              </a:rPr>
+              <a:t>Forecast</a:t>
+            </a:r>
+            <a:endParaRPr lang="en-US" sz="1400" dirty="0"/>
+          </a:p>
+        </p:txBody>
+      </p:sp>
+      <p:sp>
+        <p:nvSpPr>
+          <p:cNvPr id="31" name="Text 28"/>
+          <p:cNvSpPr txBox="1"/>
+          <p:nvPr/>
+        </p:nvSpPr>
+        <p:spPr>
+          <a:xfrm>
+            <a:off x="6263640" y="3913632"/>
+            <a:ext cx="1234440" cy="822960"/>
+          </a:xfrm>
+          <a:prstGeom prst="rect">
+            <a:avLst/>
+          </a:prstGeom>
+          <a:noFill/>
+          <a:ln/>
+        </p:spPr>
+        <p:txBody>
+          <a:bodyPr wrap="square" lIns="0" tIns="0" rIns="0" bIns="0" rtlCol="0" anchor="t"/>
+          <a:lstStyle/>
+          <a:p>
+            <a:pPr algn="ctr" indent="0" marL="0">
+              <a:buNone/>
+            </a:pPr>
+            <a:r>
+              <a:rPr lang="en-US" sz="1100" dirty="0">
+                <a:solidFill>
+                  <a:schemeClr val="bg1"/>
+                </a:solidFill>
+              </a:rPr>
+              <a:t>no change 71%</a:t>
+            </a:r>
+            <a:endParaRPr lang="en-US" sz="1100" dirty="0"/>
+          </a:p>
+          <a:p>
+            <a:pPr algn="ctr" indent="0" marL="0">
+              <a:buNone/>
+            </a:pPr>
+            <a:r>
+              <a:rPr lang="en-US" sz="1100" dirty="0">
+                <a:solidFill>
+                  <a:schemeClr val="bg1"/>
+                </a:solidFill>
+              </a:rPr>
+              <a:t>+25 bps 23%</a:t>
+            </a:r>
+            <a:endParaRPr lang="en-US" sz="1100" dirty="0"/>
+          </a:p>
+        </p:txBody>
+      </p:sp>
+      <p:sp>
+        <p:nvSpPr>
+          <p:cNvPr id="32" name="Shape 29"/>
+          <p:cNvSpPr/>
+          <p:nvPr/>
+        </p:nvSpPr>
+        <p:spPr>
+          <a:xfrm>
+            <a:off x="7909560" y="2011680"/>
+            <a:ext cx="3730752" cy="1353312"/>
+          </a:xfrm>
+          <a:prstGeom prst="roundRect">
+            <a:avLst>
+              <a:gd name="adj" fmla="val 8108"/>
             </a:avLst>
           </a:prstGeom>
           <a:solidFill>
@@ -2533,14 +3441,14 @@
       </p:sp>
       <p:sp>
         <p:nvSpPr>
-          <p:cNvPr id="5" name="Text 2"/>
-          <p:cNvSpPr txBox="1"/>
-          <p:nvPr/>
-        </p:nvSpPr>
-        <p:spPr>
-          <a:xfrm>
-            <a:off x="868680" y="1554480"/>
-            <a:ext cx="4572000" cy="411480"/>
+          <p:cNvPr id="33" name="Text 30"/>
+          <p:cNvSpPr txBox="1"/>
+          <p:nvPr/>
+        </p:nvSpPr>
+        <p:spPr>
+          <a:xfrm>
+            <a:off x="8110728" y="2121408"/>
+            <a:ext cx="3328416" cy="320040"/>
           </a:xfrm>
           <a:prstGeom prst="rect">
             <a:avLst/>
@@ -2556,27 +3464,27 @@
               <a:buNone/>
             </a:pPr>
             <a:r>
-              <a:rPr lang="en-US" sz="1800" b="1" dirty="0">
+              <a:rPr lang="en-US" sz="1200" b="1" dirty="0">
                 <a:solidFill>
                   <a:schemeClr val="tx2"/>
                 </a:solidFill>
               </a:rPr>
-              <a:t>What it is</a:t>
-            </a:r>
-            <a:endParaRPr lang="en-US" sz="1800" dirty="0"/>
-          </a:p>
-        </p:txBody>
-      </p:sp>
-      <p:sp>
-        <p:nvSpPr>
-          <p:cNvPr id="6" name="Text 3"/>
-          <p:cNvSpPr txBox="1"/>
-          <p:nvPr/>
-        </p:nvSpPr>
-        <p:spPr>
-          <a:xfrm>
-            <a:off x="868680" y="2011680"/>
-            <a:ext cx="4526280" cy="3291840"/>
+              <a:t>Repeatability is enforced, then measured</a:t>
+            </a:r>
+            <a:endParaRPr lang="en-US" sz="1200" dirty="0"/>
+          </a:p>
+        </p:txBody>
+      </p:sp>
+      <p:sp>
+        <p:nvSpPr>
+          <p:cNvPr id="34" name="Text 31"/>
+          <p:cNvSpPr txBox="1"/>
+          <p:nvPr/>
+        </p:nvSpPr>
+        <p:spPr>
+          <a:xfrm>
+            <a:off x="8110728" y="2441448"/>
+            <a:ext cx="3328416" cy="914400"/>
           </a:xfrm>
           <a:prstGeom prst="rect">
             <a:avLst/>
@@ -2588,240 +3496,65 @@
           <a:bodyPr wrap="square" lIns="0" tIns="0" rIns="0" bIns="0" rtlCol="0" anchor="t"/>
           <a:lstStyle/>
           <a:p>
-            <a:pPr marL="342900" indent="-342900">
-              <a:spcAft>
-                <a:spcPts val="600"/>
-              </a:spcAft>
-              <a:buSzPct val="100000"/>
-              <a:buChar char="•"/>
-            </a:pPr>
-            <a:r>
-              <a:rPr lang="en-US" sz="1200" dirty="0">
+            <a:pPr indent="0" marL="0">
+              <a:buNone/>
+            </a:pPr>
+            <a:r>
+              <a:rPr lang="en-US" sz="950" dirty="0">
                 <a:solidFill>
                   <a:schemeClr val="tx1"/>
                 </a:solidFill>
               </a:rPr>
-              <a:t>A forecast of the next FOMC decision as probabilities over five outcomes, from one frozen, fingerprinted snapshot of evidence: futures, FRED series as first published, statements, minutes, transcript, projections, speeches, 32 years of decisions, prediction-market odds.</a:t>
-            </a:r>
-            <a:endParaRPr lang="en-US" sz="1200" dirty="0"/>
-          </a:p>
-          <a:p>
-            <a:pPr marL="342900" indent="-342900">
-              <a:spcAft>
-                <a:spcPts val="600"/>
-              </a:spcAft>
-              <a:buSzPct val="100000"/>
-              <a:buChar char="•"/>
-            </a:pPr>
-            <a:r>
-              <a:rPr lang="en-US" sz="1200" dirty="0">
-                <a:solidFill>
-                  <a:schemeClr val="tx1"/>
-                </a:solidFill>
-              </a:rPr>
-              <a:t>Code computes the signals and pools four models with fixed weights: market-implied 0.6, the Fed's own Taylor rules 0.2, prediction-market odds 0.1, historical base rates 0.1.</a:t>
-            </a:r>
-            <a:endParaRPr lang="en-US" sz="1200" dirty="0"/>
-          </a:p>
-          <a:p>
-            <a:pPr marL="342900" indent="-342900">
-              <a:spcAft>
-                <a:spcPts val="600"/>
-              </a:spcAft>
-              <a:buSzPct val="100000"/>
-              <a:buChar char="•"/>
-            </a:pPr>
-            <a:r>
-              <a:rPr lang="en-US" sz="1200" dirty="0">
-                <a:solidFill>
-                  <a:schemeClr val="tx1"/>
-                </a:solidFill>
-              </a:rPr>
-              <a:t>A language model is used only to read text: five specialist analysts, tools off, every claim quoted and verified by code, whose combined lean can tilt the number by at most 10 points and never write it.</a:t>
-            </a:r>
-            <a:endParaRPr lang="en-US" sz="1200" dirty="0"/>
-          </a:p>
-          <a:p>
-            <a:pPr marL="342900" indent="-342900">
-              <a:spcAft>
-                <a:spcPts val="600"/>
-              </a:spcAft>
-              <a:buSzPct val="100000"/>
-              <a:buChar char="•"/>
-            </a:pPr>
-            <a:r>
-              <a:rPr lang="en-US" sz="1200" dirty="0">
-                <a:solidFill>
-                  <a:schemeClr val="tx1"/>
-                </a:solidFill>
-              </a:rPr>
-              <a:t>Human judgement enters only through typed, bounded, recorded channels: views, watch-outs, documents, odds.</a:t>
-            </a:r>
-            <a:endParaRPr lang="en-US" sz="1200" dirty="0"/>
-          </a:p>
-          <a:p>
-            <a:pPr marL="342900" indent="-342900">
-              <a:spcAft>
-                <a:spcPts val="600"/>
-              </a:spcAft>
-              <a:buSzPct val="100000"/>
-              <a:buChar char="•"/>
-            </a:pPr>
-            <a:r>
-              <a:rPr lang="en-US" sz="1200" dirty="0">
-                <a:solidFill>
-                  <a:schemeClr val="tx1"/>
-                </a:solidFill>
-              </a:rPr>
-              <a:t>Every forecast goes into a hash-chained ledger that recomputes exactly from its snapshot.</a:t>
-            </a:r>
-            <a:endParaRPr lang="en-US" sz="1200" dirty="0"/>
-          </a:p>
-        </p:txBody>
-      </p:sp>
-      <p:sp>
-        <p:nvSpPr>
-          <p:cNvPr id="7" name="Text 4"/>
-          <p:cNvSpPr txBox="1"/>
-          <p:nvPr/>
-        </p:nvSpPr>
-        <p:spPr>
-          <a:xfrm>
-            <a:off x="868680" y="5440680"/>
-            <a:ext cx="4526280" cy="640080"/>
-          </a:xfrm>
-          <a:prstGeom prst="rect">
-            <a:avLst/>
-          </a:prstGeom>
-          <a:noFill/>
-          <a:ln/>
-        </p:spPr>
-        <p:txBody>
-          <a:bodyPr wrap="square" lIns="0" tIns="0" rIns="0" bIns="0" rtlCol="0" anchor="t"/>
-          <a:lstStyle/>
-          <a:p>
-            <a:pPr indent="0" marL="0">
-              <a:buNone/>
-            </a:pPr>
-            <a:r>
-              <a:rPr lang="en-US" sz="1300" b="1" dirty="0">
-                <a:solidFill>
-                  <a:schemeClr val="tx2"/>
-                </a:solidFill>
-              </a:rPr>
-              <a:t>Today, for 28 October 2026: no change 71%, +25 bps 23%</a:t>
-            </a:r>
-            <a:endParaRPr lang="en-US" sz="1300" dirty="0"/>
-          </a:p>
-        </p:txBody>
-      </p:sp>
-      <p:sp>
-        <p:nvSpPr>
-          <p:cNvPr id="8" name="Text 5"/>
-          <p:cNvSpPr txBox="1"/>
-          <p:nvPr/>
-        </p:nvSpPr>
-        <p:spPr>
-          <a:xfrm>
-            <a:off x="6126480" y="1417320"/>
-            <a:ext cx="5486400" cy="411480"/>
-          </a:xfrm>
-          <a:prstGeom prst="rect">
-            <a:avLst/>
-          </a:prstGeom>
-          <a:noFill/>
-          <a:ln/>
-        </p:spPr>
-        <p:txBody>
-          <a:bodyPr wrap="square" lIns="0" tIns="0" rIns="0" bIns="0" rtlCol="0" anchor="t"/>
-          <a:lstStyle/>
-          <a:p>
-            <a:pPr indent="0" marL="0">
-              <a:buNone/>
-            </a:pPr>
-            <a:r>
-              <a:rPr lang="en-US" sz="1800" b="1" dirty="0">
-                <a:solidFill>
-                  <a:schemeClr val="tx2"/>
-                </a:solidFill>
-              </a:rPr>
-              <a:t>Why we built it</a:t>
-            </a:r>
-            <a:endParaRPr lang="en-US" sz="1800" dirty="0"/>
-          </a:p>
-        </p:txBody>
-      </p:sp>
-      <p:sp>
-        <p:nvSpPr>
-          <p:cNvPr id="9" name="Shape 6"/>
+              <a:t>One frozen, fingerprinted snapshot per forecast; code pools the models; each analyst is run five times on identical inputs with every tool off and every quote checked by code. A ten-dimension scorecard, fixed before any code existed, is measured on every snapshot, so drift shows as a red cell.</a:t>
+            </a:r>
+            <a:endParaRPr lang="en-US" sz="950" dirty="0"/>
+          </a:p>
+        </p:txBody>
+      </p:sp>
+      <p:sp>
+        <p:nvSpPr>
+          <p:cNvPr id="35" name="Shape 32"/>
           <p:cNvSpPr/>
           <p:nvPr/>
         </p:nvSpPr>
         <p:spPr>
           <a:xfrm>
-            <a:off x="6126480" y="1947672"/>
-            <a:ext cx="384048" cy="384048"/>
-          </a:xfrm>
-          <a:prstGeom prst="ellipse">
-            <a:avLst/>
+            <a:off x="7909560" y="3474720"/>
+            <a:ext cx="3730752" cy="1353312"/>
+          </a:xfrm>
+          <a:prstGeom prst="roundRect">
+            <a:avLst>
+              <a:gd name="adj" fmla="val 8108"/>
+            </a:avLst>
           </a:prstGeom>
           <a:solidFill>
-            <a:srgbClr val="1E2761"/>
+            <a:srgbClr val="EEF2F7"/>
           </a:solidFill>
           <a:ln w="12700">
             <a:solidFill>
-              <a:srgbClr val="1E2761"/>
+              <a:srgbClr val="EEF2F7"/>
             </a:solidFill>
             <a:prstDash val="solid"/>
           </a:ln>
-        </p:spPr>
-      </p:sp>
-      <p:sp>
-        <p:nvSpPr>
-          <p:cNvPr id="10" name="Text 7"/>
-          <p:cNvSpPr txBox="1"/>
-          <p:nvPr/>
-        </p:nvSpPr>
-        <p:spPr>
-          <a:xfrm>
-            <a:off x="6126480" y="1947672"/>
-            <a:ext cx="384048" cy="384048"/>
-          </a:xfrm>
-          <a:prstGeom prst="rect">
-            <a:avLst/>
-          </a:prstGeom>
-          <a:noFill/>
-          <a:ln/>
-        </p:spPr>
-        <p:txBody>
-          <a:bodyPr wrap="square" lIns="0" tIns="0" rIns="0" bIns="0" rtlCol="0" anchor="ctr"/>
-          <a:lstStyle/>
-          <a:p>
-            <a:pPr algn="ctr" indent="0" marL="0">
-              <a:buNone/>
-            </a:pPr>
-            <a:r>
-              <a:rPr lang="en-US" sz="1400" b="1" dirty="0">
-                <a:solidFill>
-                  <a:schemeClr val="bg1"/>
-                </a:solidFill>
-              </a:rPr>
-              <a:t>1</a:t>
-            </a:r>
-            <a:endParaRPr lang="en-US" sz="1400" dirty="0"/>
-          </a:p>
-        </p:txBody>
-      </p:sp>
-      <p:sp>
-        <p:nvSpPr>
-          <p:cNvPr id="11" name="Text 8"/>
-          <p:cNvSpPr txBox="1"/>
-          <p:nvPr/>
-        </p:nvSpPr>
-        <p:spPr>
-          <a:xfrm>
-            <a:off x="6629400" y="1920240"/>
-            <a:ext cx="5029200" cy="320040"/>
+          <a:effectLst>
+            <a:outerShdw sx="100000" sy="100000" kx="0" ky="0" algn="bl" rotWithShape="0" blurRad="50800" dist="12700" dir="5400000">
+              <a:srgbClr val="000000">
+                <a:alpha val="8000"/>
+              </a:srgbClr>
+            </a:outerShdw>
+          </a:effectLst>
+        </p:spPr>
+      </p:sp>
+      <p:sp>
+        <p:nvSpPr>
+          <p:cNvPr id="36" name="Text 33"/>
+          <p:cNvSpPr txBox="1"/>
+          <p:nvPr/>
+        </p:nvSpPr>
+        <p:spPr>
+          <a:xfrm>
+            <a:off x="8110728" y="3584448"/>
+            <a:ext cx="3328416" cy="320040"/>
           </a:xfrm>
           <a:prstGeom prst="rect">
             <a:avLst/>
@@ -2837,27 +3570,27 @@
               <a:buNone/>
             </a:pPr>
             <a:r>
-              <a:rPr lang="en-US" sz="1300" b="1" dirty="0">
+              <a:rPr lang="en-US" sz="1200" b="1" dirty="0">
                 <a:solidFill>
                   <a:schemeClr val="tx2"/>
                 </a:solidFill>
               </a:rPr>
-              <a:t>Accuracy is the wrong yardstick at this horizon</a:t>
-            </a:r>
-            <a:endParaRPr lang="en-US" sz="1300" dirty="0"/>
-          </a:p>
-        </p:txBody>
-      </p:sp>
-      <p:sp>
-        <p:nvSpPr>
-          <p:cNvPr id="12" name="Text 9"/>
-          <p:cNvSpPr txBox="1"/>
-          <p:nvPr/>
-        </p:nvSpPr>
-        <p:spPr>
-          <a:xfrm>
-            <a:off x="6629400" y="2240280"/>
-            <a:ext cx="5029200" cy="777240"/>
+              <a:t>Human judgement has a typed channel</a:t>
+            </a:r>
+            <a:endParaRPr lang="en-US" sz="1200" dirty="0"/>
+          </a:p>
+        </p:txBody>
+      </p:sp>
+      <p:sp>
+        <p:nvSpPr>
+          <p:cNvPr id="37" name="Text 34"/>
+          <p:cNvSpPr txBox="1"/>
+          <p:nvPr/>
+        </p:nvSpPr>
+        <p:spPr>
+          <a:xfrm>
+            <a:off x="8110728" y="3904488"/>
+            <a:ext cx="3328416" cy="914400"/>
           </a:xfrm>
           <a:prstGeom prst="rect">
             <a:avLst/>
@@ -2873,88 +3606,61 @@
               <a:buNone/>
             </a:pPr>
             <a:r>
-              <a:rPr lang="en-US" sz="1050" dirty="0">
+              <a:rPr lang="en-US" sz="950" dirty="0">
                 <a:solidFill>
                   <a:schemeClr val="tx1"/>
                 </a:solidFill>
               </a:rPr>
-              <a:t>Eight decisions a year, and the futures market already calls about 88% of them a month out. A good year proves nothing. So the system is judged on a ten-dimension process scorecard fixed before any code existed, measured by code on every snapshot, and outcomes are logged but never used to tune.</a:t>
-            </a:r>
-            <a:endParaRPr lang="en-US" sz="1050" dirty="0"/>
-          </a:p>
-        </p:txBody>
-      </p:sp>
-      <p:sp>
-        <p:nvSpPr>
-          <p:cNvPr id="13" name="Shape 10"/>
+              <a:t>None is active today. The channel exists because a desk's judgement belongs in the number, but only where it can be seen, bounded and scored afterwards: a view tilts the number by at most 10 points and expires; a watch-out must be answered by every analyst; a document or an odds entry becomes evidence.</a:t>
+            </a:r>
+            <a:endParaRPr lang="en-US" sz="950" dirty="0"/>
+          </a:p>
+        </p:txBody>
+      </p:sp>
+      <p:sp>
+        <p:nvSpPr>
+          <p:cNvPr id="38" name="Shape 35"/>
           <p:cNvSpPr/>
           <p:nvPr/>
         </p:nvSpPr>
         <p:spPr>
           <a:xfrm>
-            <a:off x="6126480" y="3026664"/>
-            <a:ext cx="384048" cy="384048"/>
-          </a:xfrm>
-          <a:prstGeom prst="ellipse">
-            <a:avLst/>
+            <a:off x="7909560" y="4937760"/>
+            <a:ext cx="3730752" cy="1353312"/>
+          </a:xfrm>
+          <a:prstGeom prst="roundRect">
+            <a:avLst>
+              <a:gd name="adj" fmla="val 8108"/>
+            </a:avLst>
           </a:prstGeom>
           <a:solidFill>
-            <a:srgbClr val="1E2761"/>
+            <a:srgbClr val="EEF2F7"/>
           </a:solidFill>
           <a:ln w="12700">
             <a:solidFill>
-              <a:srgbClr val="1E2761"/>
+              <a:srgbClr val="EEF2F7"/>
             </a:solidFill>
             <a:prstDash val="solid"/>
           </a:ln>
-        </p:spPr>
-      </p:sp>
-      <p:sp>
-        <p:nvSpPr>
-          <p:cNvPr id="14" name="Text 11"/>
-          <p:cNvSpPr txBox="1"/>
-          <p:nvPr/>
-        </p:nvSpPr>
-        <p:spPr>
-          <a:xfrm>
-            <a:off x="6126480" y="3026664"/>
-            <a:ext cx="384048" cy="384048"/>
-          </a:xfrm>
-          <a:prstGeom prst="rect">
-            <a:avLst/>
-          </a:prstGeom>
-          <a:noFill/>
-          <a:ln/>
-        </p:spPr>
-        <p:txBody>
-          <a:bodyPr wrap="square" lIns="0" tIns="0" rIns="0" bIns="0" rtlCol="0" anchor="ctr"/>
-          <a:lstStyle/>
-          <a:p>
-            <a:pPr algn="ctr" indent="0" marL="0">
-              <a:buNone/>
-            </a:pPr>
-            <a:r>
-              <a:rPr lang="en-US" sz="1400" b="1" dirty="0">
-                <a:solidFill>
-                  <a:schemeClr val="bg1"/>
-                </a:solidFill>
-              </a:rPr>
-              <a:t>2</a:t>
-            </a:r>
-            <a:endParaRPr lang="en-US" sz="1400" dirty="0"/>
-          </a:p>
-        </p:txBody>
-      </p:sp>
-      <p:sp>
-        <p:nvSpPr>
-          <p:cNvPr id="15" name="Text 12"/>
-          <p:cNvSpPr txBox="1"/>
-          <p:nvPr/>
-        </p:nvSpPr>
-        <p:spPr>
-          <a:xfrm>
-            <a:off x="6629400" y="2999232"/>
-            <a:ext cx="5029200" cy="320040"/>
+          <a:effectLst>
+            <a:outerShdw sx="100000" sy="100000" kx="0" ky="0" algn="bl" rotWithShape="0" blurRad="50800" dist="12700" dir="5400000">
+              <a:srgbClr val="000000">
+                <a:alpha val="8000"/>
+              </a:srgbClr>
+            </a:outerShdw>
+          </a:effectLst>
+        </p:spPr>
+      </p:sp>
+      <p:sp>
+        <p:nvSpPr>
+          <p:cNvPr id="39" name="Text 36"/>
+          <p:cNvSpPr txBox="1"/>
+          <p:nvPr/>
+        </p:nvSpPr>
+        <p:spPr>
+          <a:xfrm>
+            <a:off x="8110728" y="5047488"/>
+            <a:ext cx="3328416" cy="320040"/>
           </a:xfrm>
           <a:prstGeom prst="rect">
             <a:avLst/>
@@ -2970,27 +3676,27 @@
               <a:buNone/>
             </a:pPr>
             <a:r>
-              <a:rPr lang="en-US" sz="1300" b="1" dirty="0">
+              <a:rPr lang="en-US" sz="1200" b="1" dirty="0">
                 <a:solidFill>
                   <a:schemeClr val="tx2"/>
                 </a:solidFill>
               </a:rPr>
-              <a:t>A desk needs a number it can challenge</a:t>
-            </a:r>
-            <a:endParaRPr lang="en-US" sz="1300" dirty="0"/>
-          </a:p>
-        </p:txBody>
-      </p:sp>
-      <p:sp>
-        <p:nvSpPr>
-          <p:cNvPr id="16" name="Text 13"/>
-          <p:cNvSpPr txBox="1"/>
-          <p:nvPr/>
-        </p:nvSpPr>
-        <p:spPr>
-          <a:xfrm>
-            <a:off x="6629400" y="3319272"/>
-            <a:ext cx="5029200" cy="777240"/>
+              <a:t>All evidence is kept, so the path can be read back</a:t>
+            </a:r>
+            <a:endParaRPr lang="en-US" sz="1200" dirty="0"/>
+          </a:p>
+        </p:txBody>
+      </p:sp>
+      <p:sp>
+        <p:nvSpPr>
+          <p:cNvPr id="40" name="Text 37"/>
+          <p:cNvSpPr txBox="1"/>
+          <p:nvPr/>
+        </p:nvSpPr>
+        <p:spPr>
+          <a:xfrm>
+            <a:off x="8110728" y="5367528"/>
+            <a:ext cx="3328416" cy="914400"/>
           </a:xfrm>
           <a:prstGeom prst="rect">
             <a:avLst/>
@@ -3006,280 +3712,14 @@
               <a:buNone/>
             </a:pPr>
             <a:r>
-              <a:rPr lang="en-US" sz="1050" dirty="0">
+              <a:rPr lang="en-US" sz="950" dirty="0">
                 <a:solidFill>
                   <a:schemeClr val="tx1"/>
                 </a:solidFill>
               </a:rPr>
-              <a:t>Every input is visible, every analyst claim carries a quote code has matched, every ledger entry replays. When the number moves, you can see which input moved it and by how much.</a:t>
-            </a:r>
-            <a:endParaRPr lang="en-US" sz="1050" dirty="0"/>
-          </a:p>
-        </p:txBody>
-      </p:sp>
-      <p:sp>
-        <p:nvSpPr>
-          <p:cNvPr id="17" name="Shape 14"/>
-          <p:cNvSpPr/>
-          <p:nvPr/>
-        </p:nvSpPr>
-        <p:spPr>
-          <a:xfrm>
-            <a:off x="6126480" y="4105656"/>
-            <a:ext cx="384048" cy="384048"/>
-          </a:xfrm>
-          <a:prstGeom prst="ellipse">
-            <a:avLst/>
-          </a:prstGeom>
-          <a:solidFill>
-            <a:srgbClr val="1E2761"/>
-          </a:solidFill>
-          <a:ln w="12700">
-            <a:solidFill>
-              <a:srgbClr val="1E2761"/>
-            </a:solidFill>
-            <a:prstDash val="solid"/>
-          </a:ln>
-        </p:spPr>
-      </p:sp>
-      <p:sp>
-        <p:nvSpPr>
-          <p:cNvPr id="18" name="Text 15"/>
-          <p:cNvSpPr txBox="1"/>
-          <p:nvPr/>
-        </p:nvSpPr>
-        <p:spPr>
-          <a:xfrm>
-            <a:off x="6126480" y="4105656"/>
-            <a:ext cx="384048" cy="384048"/>
-          </a:xfrm>
-          <a:prstGeom prst="rect">
-            <a:avLst/>
-          </a:prstGeom>
-          <a:noFill/>
-          <a:ln/>
-        </p:spPr>
-        <p:txBody>
-          <a:bodyPr wrap="square" lIns="0" tIns="0" rIns="0" bIns="0" rtlCol="0" anchor="ctr"/>
-          <a:lstStyle/>
-          <a:p>
-            <a:pPr algn="ctr" indent="0" marL="0">
-              <a:buNone/>
-            </a:pPr>
-            <a:r>
-              <a:rPr lang="en-US" sz="1400" b="1" dirty="0">
-                <a:solidFill>
-                  <a:schemeClr val="bg1"/>
-                </a:solidFill>
-              </a:rPr>
-              <a:t>3</a:t>
-            </a:r>
-            <a:endParaRPr lang="en-US" sz="1400" dirty="0"/>
-          </a:p>
-        </p:txBody>
-      </p:sp>
-      <p:sp>
-        <p:nvSpPr>
-          <p:cNvPr id="19" name="Text 16"/>
-          <p:cNvSpPr txBox="1"/>
-          <p:nvPr/>
-        </p:nvSpPr>
-        <p:spPr>
-          <a:xfrm>
-            <a:off x="6629400" y="4078224"/>
-            <a:ext cx="5029200" cy="320040"/>
-          </a:xfrm>
-          <a:prstGeom prst="rect">
-            <a:avLst/>
-          </a:prstGeom>
-          <a:noFill/>
-          <a:ln/>
-        </p:spPr>
-        <p:txBody>
-          <a:bodyPr wrap="square" lIns="0" tIns="0" rIns="0" bIns="0" rtlCol="0" anchor="t"/>
-          <a:lstStyle/>
-          <a:p>
-            <a:pPr indent="0" marL="0">
-              <a:buNone/>
-            </a:pPr>
-            <a:r>
-              <a:rPr lang="en-US" sz="1300" b="1" dirty="0">
-                <a:solidFill>
-                  <a:schemeClr val="tx2"/>
-                </a:solidFill>
-              </a:rPr>
-              <a:t>Language models are entering this work unchecked</a:t>
-            </a:r>
-            <a:endParaRPr lang="en-US" sz="1300" dirty="0"/>
-          </a:p>
-        </p:txBody>
-      </p:sp>
-      <p:sp>
-        <p:nvSpPr>
-          <p:cNvPr id="20" name="Text 17"/>
-          <p:cNvSpPr txBox="1"/>
-          <p:nvPr/>
-        </p:nvSpPr>
-        <p:spPr>
-          <a:xfrm>
-            <a:off x="6629400" y="4398264"/>
-            <a:ext cx="5029200" cy="777240"/>
-          </a:xfrm>
-          <a:prstGeom prst="rect">
-            <a:avLst/>
-          </a:prstGeom>
-          <a:noFill/>
-          <a:ln/>
-        </p:spPr>
-        <p:txBody>
-          <a:bodyPr wrap="square" lIns="0" tIns="0" rIns="0" bIns="0" rtlCol="0" anchor="t"/>
-          <a:lstStyle/>
-          <a:p>
-            <a:pPr indent="0" marL="0">
-              <a:buNone/>
-            </a:pPr>
-            <a:r>
-              <a:rPr lang="en-US" sz="1050" dirty="0">
-                <a:solidFill>
-                  <a:schemeClr val="tx1"/>
-                </a:solidFill>
-              </a:rPr>
-              <a:t>Recent papers report 90%+ accuracy from models that read Fed text, on sixteen meetings, with no frozen evidence, no verification and no control. We built the control: the same model with no harness, with evidence only, with structure and verification, with specialisation, so the value of each technique is measured, not asserted.</a:t>
-            </a:r>
-            <a:endParaRPr lang="en-US" sz="1050" dirty="0"/>
-          </a:p>
-        </p:txBody>
-      </p:sp>
-      <p:sp>
-        <p:nvSpPr>
-          <p:cNvPr id="21" name="Shape 18"/>
-          <p:cNvSpPr/>
-          <p:nvPr/>
-        </p:nvSpPr>
-        <p:spPr>
-          <a:xfrm>
-            <a:off x="6126480" y="5184648"/>
-            <a:ext cx="384048" cy="384048"/>
-          </a:xfrm>
-          <a:prstGeom prst="ellipse">
-            <a:avLst/>
-          </a:prstGeom>
-          <a:solidFill>
-            <a:srgbClr val="1E2761"/>
-          </a:solidFill>
-          <a:ln w="12700">
-            <a:solidFill>
-              <a:srgbClr val="1E2761"/>
-            </a:solidFill>
-            <a:prstDash val="solid"/>
-          </a:ln>
-        </p:spPr>
-      </p:sp>
-      <p:sp>
-        <p:nvSpPr>
-          <p:cNvPr id="22" name="Text 19"/>
-          <p:cNvSpPr txBox="1"/>
-          <p:nvPr/>
-        </p:nvSpPr>
-        <p:spPr>
-          <a:xfrm>
-            <a:off x="6126480" y="5184648"/>
-            <a:ext cx="384048" cy="384048"/>
-          </a:xfrm>
-          <a:prstGeom prst="rect">
-            <a:avLst/>
-          </a:prstGeom>
-          <a:noFill/>
-          <a:ln/>
-        </p:spPr>
-        <p:txBody>
-          <a:bodyPr wrap="square" lIns="0" tIns="0" rIns="0" bIns="0" rtlCol="0" anchor="ctr"/>
-          <a:lstStyle/>
-          <a:p>
-            <a:pPr algn="ctr" indent="0" marL="0">
-              <a:buNone/>
-            </a:pPr>
-            <a:r>
-              <a:rPr lang="en-US" sz="1400" b="1" dirty="0">
-                <a:solidFill>
-                  <a:schemeClr val="bg1"/>
-                </a:solidFill>
-              </a:rPr>
-              <a:t>4</a:t>
-            </a:r>
-            <a:endParaRPr lang="en-US" sz="1400" dirty="0"/>
-          </a:p>
-        </p:txBody>
-      </p:sp>
-      <p:sp>
-        <p:nvSpPr>
-          <p:cNvPr id="23" name="Text 20"/>
-          <p:cNvSpPr txBox="1"/>
-          <p:nvPr/>
-        </p:nvSpPr>
-        <p:spPr>
-          <a:xfrm>
-            <a:off x="6629400" y="5157216"/>
-            <a:ext cx="5029200" cy="320040"/>
-          </a:xfrm>
-          <a:prstGeom prst="rect">
-            <a:avLst/>
-          </a:prstGeom>
-          <a:noFill/>
-          <a:ln/>
-        </p:spPr>
-        <p:txBody>
-          <a:bodyPr wrap="square" lIns="0" tIns="0" rIns="0" bIns="0" rtlCol="0" anchor="t"/>
-          <a:lstStyle/>
-          <a:p>
-            <a:pPr indent="0" marL="0">
-              <a:buNone/>
-            </a:pPr>
-            <a:r>
-              <a:rPr lang="en-US" sz="1300" b="1" dirty="0">
-                <a:solidFill>
-                  <a:schemeClr val="tx2"/>
-                </a:solidFill>
-              </a:rPr>
-              <a:t>The harness is the asset</a:t>
-            </a:r>
-            <a:endParaRPr lang="en-US" sz="1300" dirty="0"/>
-          </a:p>
-        </p:txBody>
-      </p:sp>
-      <p:sp>
-        <p:nvSpPr>
-          <p:cNvPr id="24" name="Text 21"/>
-          <p:cNvSpPr txBox="1"/>
-          <p:nvPr/>
-        </p:nvSpPr>
-        <p:spPr>
-          <a:xfrm>
-            <a:off x="6629400" y="5477256"/>
-            <a:ext cx="5029200" cy="777240"/>
-          </a:xfrm>
-          <a:prstGeom prst="rect">
-            <a:avLst/>
-          </a:prstGeom>
-          <a:noFill/>
-          <a:ln/>
-        </p:spPr>
-        <p:txBody>
-          <a:bodyPr wrap="square" lIns="0" tIns="0" rIns="0" bIns="0" rtlCol="0" anchor="t"/>
-          <a:lstStyle/>
-          <a:p>
-            <a:pPr indent="0" marL="0">
-              <a:buNone/>
-            </a:pPr>
-            <a:r>
-              <a:rPr lang="en-US" sz="1050" dirty="0">
-                <a:solidFill>
-                  <a:schemeClr val="tx1"/>
-                </a:solidFill>
-              </a:rPr>
-              <a:t>The same chain can target the December meeting, the year-end rate or another central bank. The first live decision is scored this week, and the record starts there.</a:t>
-            </a:r>
-            <a:endParaRPr lang="en-US" sz="1050" dirty="0"/>
+              <a:t>Each pull is frozen and hash-chained to the forecast it produced. As new information arrives, the number and each model's contribution move, and the ledger shows exactly which input moved it: 62/33 on 15 October, 65/30 on 24 October, 71/23 on 26 October after the market odds were refreshed.</a:t>
+            </a:r>
+            <a:endParaRPr lang="en-US" sz="950" dirty="0"/>
           </a:p>
         </p:txBody>
       </p:sp>

</xml_diff>

<commit_message>
Short brief: what it does and the three reasons we built it
Co-Authored-By: Claude Fable 5.1 <noreply@anthropic.com>
</commit_message>
<xml_diff>
--- a/docs/FedCast_Fullerton_short.pptx
+++ b/docs/FedCast_Fullerton_short.pptx
@@ -109,7 +109,7 @@
   <p:extLst>
     <p:ext uri="{521415D9-36F7-43E2-AB2F-B90AF26B5E84}">
       <p14:sectionLst xmlns:p14="http://schemas.microsoft.com/office/powerpoint/2010/main">
-        <p14:section name="Brief" id="{d0666e98-9957-50a5-37c3-4adf743b8f7b}">
+        <p14:section name="Brief" id="{cce3a166-3062-b012-acba-5b1b5710b73f}">
           <p14:sldIdLst>
             <p14:sldId id="256"/>
             <p14:sldId id="257"/>
@@ -696,7 +696,7 @@
           <a:p>
             <a:r>
               <a:rPr lang="en-US" dirty="0"/>
-              <a:t>Thirty seconds on the top line, then the diagram: four families of input, pooled by code with fixed weights, into one number. Then the three panels: how repeatability is enforced, why human judgement has a typed channel even though none is active today, and that every piece of evidence is frozen so the number's path over time can be read back.</a:t>
+              <a:t>Left: what it is, in one line, the diagram, and four things it does. Right: the three reasons we built it. Spend the time on the right-hand side; the diagram is there so the room can see the four families and that code, not a model, combines them.</a:t>
             </a:r>
             <a:endParaRPr lang="en-US" dirty="0"/>
           </a:p>
@@ -2505,7 +2505,7 @@
         </p:nvSpPr>
         <p:spPr>
           <a:xfrm>
-            <a:off x="548640" y="1280160"/>
+            <a:off x="548640" y="1234440"/>
             <a:ext cx="11091672" cy="548640"/>
           </a:xfrm>
           <a:prstGeom prst="rect">
@@ -2522,14 +2522,14 @@
               <a:buNone/>
             </a:pPr>
             <a:r>
-              <a:rPr lang="en-US" sz="1400" dirty="0">
+              <a:rPr lang="en-US" sz="1350" dirty="0">
                 <a:solidFill>
                   <a:schemeClr val="tx1"/>
                 </a:solidFill>
               </a:rPr>
               <a:t>A forecast of the next FOMC decision as probabilities over five outcomes, from one frozen snapshot of evidence. Today, for 28 October 2026: no change 71%, +25 bps 23%.</a:t>
             </a:r>
-            <a:endParaRPr lang="en-US" sz="1400" dirty="0"/>
+            <a:endParaRPr lang="en-US" sz="1350" dirty="0"/>
           </a:p>
         </p:txBody>
       </p:sp>
@@ -2541,12 +2541,12 @@
         </p:nvSpPr>
         <p:spPr>
           <a:xfrm>
-            <a:off x="548640" y="2011680"/>
-            <a:ext cx="2103120" cy="960120"/>
+            <a:off x="548640" y="1874520"/>
+            <a:ext cx="2514600" cy="676656"/>
           </a:xfrm>
           <a:prstGeom prst="roundRect">
             <a:avLst>
-              <a:gd name="adj" fmla="val 9524"/>
+              <a:gd name="adj" fmla="val 10811"/>
             </a:avLst>
           </a:prstGeom>
           <a:solidFill>
@@ -2568,8 +2568,8 @@
         </p:nvSpPr>
         <p:spPr>
           <a:xfrm>
-            <a:off x="685800" y="2084832"/>
-            <a:ext cx="1828800" cy="292608"/>
+            <a:off x="676656" y="1929384"/>
+            <a:ext cx="2258568" cy="274320"/>
           </a:xfrm>
           <a:prstGeom prst="rect">
             <a:avLst/>
@@ -2585,14 +2585,14 @@
               <a:buNone/>
             </a:pPr>
             <a:r>
-              <a:rPr lang="en-US" sz="1300" b="1" dirty="0">
+              <a:rPr lang="en-US" sz="1200" b="1" dirty="0">
                 <a:solidFill>
                   <a:schemeClr val="bg1"/>
                 </a:solidFill>
               </a:rPr>
               <a:t>Economic predictors</a:t>
             </a:r>
-            <a:endParaRPr lang="en-US" sz="1300" dirty="0"/>
+            <a:endParaRPr lang="en-US" sz="1200" dirty="0"/>
           </a:p>
         </p:txBody>
       </p:sp>
@@ -2604,8 +2604,8 @@
         </p:nvSpPr>
         <p:spPr>
           <a:xfrm>
-            <a:off x="685800" y="2377440"/>
-            <a:ext cx="1828800" cy="566928"/>
+            <a:off x="676656" y="2176272"/>
+            <a:ext cx="2258568" cy="365760"/>
           </a:xfrm>
           <a:prstGeom prst="rect">
             <a:avLst/>
@@ -2621,63 +2621,27 @@
               <a:buNone/>
             </a:pPr>
             <a:r>
-              <a:rPr lang="en-US" sz="950" dirty="0">
+              <a:rPr lang="en-US" sz="850" dirty="0">
                 <a:solidFill>
                   <a:schemeClr val="bg1"/>
                 </a:solidFill>
               </a:rPr>
-              <a:t>Fed funds futures, the Fed's Taylor rules, prediction-market odds</a:t>
-            </a:r>
-            <a:endParaRPr lang="en-US" sz="950" dirty="0"/>
-          </a:p>
-        </p:txBody>
-      </p:sp>
-      <p:sp>
-        <p:nvSpPr>
-          <p:cNvPr id="8" name="Text 5"/>
-          <p:cNvSpPr txBox="1"/>
-          <p:nvPr/>
-        </p:nvSpPr>
-        <p:spPr>
-          <a:xfrm>
-            <a:off x="2761488" y="2240280"/>
-            <a:ext cx="1325880" cy="548640"/>
-          </a:xfrm>
-          <a:prstGeom prst="rect">
-            <a:avLst/>
-          </a:prstGeom>
-          <a:noFill/>
-          <a:ln/>
-        </p:spPr>
-        <p:txBody>
-          <a:bodyPr wrap="square" lIns="0" tIns="0" rIns="0" bIns="0" rtlCol="0" anchor="ctr"/>
-          <a:lstStyle/>
-          <a:p>
-            <a:pPr indent="0" marL="0">
-              <a:buNone/>
-            </a:pPr>
-            <a:r>
-              <a:rPr lang="en-US" sz="900" dirty="0">
-                <a:solidFill>
-                  <a:schemeClr val="accent4"/>
-                </a:solidFill>
-              </a:rPr>
-              <a:t>weights 0.6 · 0.2 · 0.1</a:t>
-            </a:r>
-            <a:endParaRPr lang="en-US" sz="900" dirty="0"/>
-          </a:p>
-        </p:txBody>
-      </p:sp>
-      <p:sp>
-        <p:nvSpPr>
-          <p:cNvPr id="9" name="Shape 6"/>
+              <a:t>Fed funds futures, the Fed's own Taylor rules, prediction-market odds</a:t>
+            </a:r>
+            <a:endParaRPr lang="en-US" sz="850" dirty="0"/>
+          </a:p>
+        </p:txBody>
+      </p:sp>
+      <p:sp>
+        <p:nvSpPr>
+          <p:cNvPr id="8" name="Shape 5"/>
           <p:cNvSpPr/>
           <p:nvPr/>
         </p:nvSpPr>
         <p:spPr>
           <a:xfrm>
-            <a:off x="4114800" y="2491740"/>
-            <a:ext cx="411480" cy="0"/>
+            <a:off x="3136392" y="2212848"/>
+            <a:ext cx="365760" cy="0"/>
           </a:xfrm>
           <a:prstGeom prst="line">
             <a:avLst/>
@@ -2694,18 +2658,18 @@
       </p:sp>
       <p:sp>
         <p:nvSpPr>
-          <p:cNvPr id="10" name="Shape 7"/>
+          <p:cNvPr id="9" name="Shape 6"/>
           <p:cNvSpPr/>
           <p:nvPr/>
         </p:nvSpPr>
         <p:spPr>
           <a:xfrm>
-            <a:off x="548640" y="3081528"/>
-            <a:ext cx="2103120" cy="960120"/>
+            <a:off x="548640" y="2624328"/>
+            <a:ext cx="2514600" cy="676656"/>
           </a:xfrm>
           <a:prstGeom prst="roundRect">
             <a:avLst>
-              <a:gd name="adj" fmla="val 9524"/>
+              <a:gd name="adj" fmla="val 10811"/>
             </a:avLst>
           </a:prstGeom>
           <a:solidFill>
@@ -2721,14 +2685,50 @@
       </p:sp>
       <p:sp>
         <p:nvSpPr>
+          <p:cNvPr id="10" name="Text 7"/>
+          <p:cNvSpPr txBox="1"/>
+          <p:nvPr/>
+        </p:nvSpPr>
+        <p:spPr>
+          <a:xfrm>
+            <a:off x="676656" y="2679192"/>
+            <a:ext cx="2258568" cy="274320"/>
+          </a:xfrm>
+          <a:prstGeom prst="rect">
+            <a:avLst/>
+          </a:prstGeom>
+          <a:noFill/>
+          <a:ln/>
+        </p:spPr>
+        <p:txBody>
+          <a:bodyPr wrap="square" lIns="0" tIns="0" rIns="0" bIns="0" rtlCol="0" anchor="t"/>
+          <a:lstStyle/>
+          <a:p>
+            <a:pPr indent="0" marL="0">
+              <a:buNone/>
+            </a:pPr>
+            <a:r>
+              <a:rPr lang="en-US" sz="1200" b="1" dirty="0">
+                <a:solidFill>
+                  <a:schemeClr val="bg1"/>
+                </a:solidFill>
+              </a:rPr>
+              <a:t>Empirical data</a:t>
+            </a:r>
+            <a:endParaRPr lang="en-US" sz="1200" dirty="0"/>
+          </a:p>
+        </p:txBody>
+      </p:sp>
+      <p:sp>
+        <p:nvSpPr>
           <p:cNvPr id="11" name="Text 8"/>
           <p:cNvSpPr txBox="1"/>
           <p:nvPr/>
         </p:nvSpPr>
         <p:spPr>
           <a:xfrm>
-            <a:off x="685800" y="3154680"/>
-            <a:ext cx="1828800" cy="292608"/>
+            <a:off x="676656" y="2926080"/>
+            <a:ext cx="2258568" cy="365760"/>
           </a:xfrm>
           <a:prstGeom prst="rect">
             <a:avLst/>
@@ -2744,99 +2744,27 @@
               <a:buNone/>
             </a:pPr>
             <a:r>
-              <a:rPr lang="en-US" sz="1300" b="1" dirty="0">
+              <a:rPr lang="en-US" sz="850" dirty="0">
                 <a:solidFill>
                   <a:schemeClr val="bg1"/>
                 </a:solidFill>
               </a:rPr>
-              <a:t>Empirical data</a:t>
-            </a:r>
-            <a:endParaRPr lang="en-US" sz="1300" dirty="0"/>
-          </a:p>
-        </p:txBody>
-      </p:sp>
-      <p:sp>
-        <p:nvSpPr>
-          <p:cNvPr id="12" name="Text 9"/>
-          <p:cNvSpPr txBox="1"/>
-          <p:nvPr/>
-        </p:nvSpPr>
-        <p:spPr>
-          <a:xfrm>
-            <a:off x="685800" y="3447288"/>
-            <a:ext cx="1828800" cy="566928"/>
-          </a:xfrm>
-          <a:prstGeom prst="rect">
-            <a:avLst/>
-          </a:prstGeom>
-          <a:noFill/>
-          <a:ln/>
-        </p:spPr>
-        <p:txBody>
-          <a:bodyPr wrap="square" lIns="0" tIns="0" rIns="0" bIns="0" rtlCol="0" anchor="t"/>
-          <a:lstStyle/>
-          <a:p>
-            <a:pPr indent="0" marL="0">
-              <a:buNone/>
-            </a:pPr>
-            <a:r>
-              <a:rPr lang="en-US" sz="950" dirty="0">
-                <a:solidFill>
-                  <a:schemeClr val="bg1"/>
-                </a:solidFill>
-              </a:rPr>
               <a:t>What followed each kind of decision over 32 years of FOMC history</a:t>
             </a:r>
-            <a:endParaRPr lang="en-US" sz="950" dirty="0"/>
-          </a:p>
-        </p:txBody>
-      </p:sp>
-      <p:sp>
-        <p:nvSpPr>
-          <p:cNvPr id="13" name="Text 10"/>
-          <p:cNvSpPr txBox="1"/>
-          <p:nvPr/>
-        </p:nvSpPr>
-        <p:spPr>
-          <a:xfrm>
-            <a:off x="2761488" y="3310128"/>
-            <a:ext cx="1325880" cy="548640"/>
-          </a:xfrm>
-          <a:prstGeom prst="rect">
-            <a:avLst/>
-          </a:prstGeom>
-          <a:noFill/>
-          <a:ln/>
-        </p:spPr>
-        <p:txBody>
-          <a:bodyPr wrap="square" lIns="0" tIns="0" rIns="0" bIns="0" rtlCol="0" anchor="ctr"/>
-          <a:lstStyle/>
-          <a:p>
-            <a:pPr indent="0" marL="0">
-              <a:buNone/>
-            </a:pPr>
-            <a:r>
-              <a:rPr lang="en-US" sz="900" dirty="0">
-                <a:solidFill>
-                  <a:schemeClr val="accent4"/>
-                </a:solidFill>
-              </a:rPr>
-              <a:t>weight 0.1</a:t>
-            </a:r>
-            <a:endParaRPr lang="en-US" sz="900" dirty="0"/>
-          </a:p>
-        </p:txBody>
-      </p:sp>
-      <p:sp>
-        <p:nvSpPr>
-          <p:cNvPr id="14" name="Shape 11"/>
+            <a:endParaRPr lang="en-US" sz="850" dirty="0"/>
+          </a:p>
+        </p:txBody>
+      </p:sp>
+      <p:sp>
+        <p:nvSpPr>
+          <p:cNvPr id="12" name="Shape 9"/>
           <p:cNvSpPr/>
           <p:nvPr/>
         </p:nvSpPr>
         <p:spPr>
           <a:xfrm>
-            <a:off x="4114800" y="3561588"/>
-            <a:ext cx="411480" cy="0"/>
+            <a:off x="3136392" y="2962656"/>
+            <a:ext cx="365760" cy="0"/>
           </a:xfrm>
           <a:prstGeom prst="line">
             <a:avLst/>
@@ -2853,18 +2781,18 @@
       </p:sp>
       <p:sp>
         <p:nvSpPr>
-          <p:cNvPr id="15" name="Shape 12"/>
+          <p:cNvPr id="13" name="Shape 10"/>
           <p:cNvSpPr/>
           <p:nvPr/>
         </p:nvSpPr>
         <p:spPr>
           <a:xfrm>
-            <a:off x="548640" y="4151376"/>
-            <a:ext cx="2103120" cy="960120"/>
+            <a:off x="548640" y="3374136"/>
+            <a:ext cx="2514600" cy="676656"/>
           </a:xfrm>
           <a:prstGeom prst="roundRect">
             <a:avLst>
-              <a:gd name="adj" fmla="val 9524"/>
+              <a:gd name="adj" fmla="val 10811"/>
             </a:avLst>
           </a:prstGeom>
           <a:solidFill>
@@ -2880,14 +2808,14 @@
       </p:sp>
       <p:sp>
         <p:nvSpPr>
-          <p:cNvPr id="16" name="Text 13"/>
-          <p:cNvSpPr txBox="1"/>
-          <p:nvPr/>
-        </p:nvSpPr>
-        <p:spPr>
-          <a:xfrm>
-            <a:off x="685800" y="4224528"/>
-            <a:ext cx="1828800" cy="292608"/>
+          <p:cNvPr id="14" name="Text 11"/>
+          <p:cNvSpPr txBox="1"/>
+          <p:nvPr/>
+        </p:nvSpPr>
+        <p:spPr>
+          <a:xfrm>
+            <a:off x="676656" y="3429000"/>
+            <a:ext cx="2258568" cy="274320"/>
           </a:xfrm>
           <a:prstGeom prst="rect">
             <a:avLst/>
@@ -2903,27 +2831,27 @@
               <a:buNone/>
             </a:pPr>
             <a:r>
-              <a:rPr lang="en-US" sz="1300" b="1" dirty="0">
+              <a:rPr lang="en-US" sz="1200" b="1" dirty="0">
                 <a:solidFill>
                   <a:schemeClr val="bg1"/>
                 </a:solidFill>
               </a:rPr>
               <a:t>Classic ML</a:t>
             </a:r>
-            <a:endParaRPr lang="en-US" sz="1300" dirty="0"/>
-          </a:p>
-        </p:txBody>
-      </p:sp>
-      <p:sp>
-        <p:nvSpPr>
-          <p:cNvPr id="17" name="Text 14"/>
-          <p:cNvSpPr txBox="1"/>
-          <p:nvPr/>
-        </p:nvSpPr>
-        <p:spPr>
-          <a:xfrm>
-            <a:off x="685800" y="4517136"/>
-            <a:ext cx="1828800" cy="566928"/>
+            <a:endParaRPr lang="en-US" sz="1200" dirty="0"/>
+          </a:p>
+        </p:txBody>
+      </p:sp>
+      <p:sp>
+        <p:nvSpPr>
+          <p:cNvPr id="15" name="Text 12"/>
+          <p:cNvSpPr txBox="1"/>
+          <p:nvPr/>
+        </p:nvSpPr>
+        <p:spPr>
+          <a:xfrm>
+            <a:off x="676656" y="3675888"/>
+            <a:ext cx="2258568" cy="365760"/>
           </a:xfrm>
           <a:prstGeom prst="rect">
             <a:avLst/>
@@ -2939,63 +2867,27 @@
               <a:buNone/>
             </a:pPr>
             <a:r>
-              <a:rPr lang="en-US" sz="950" dirty="0">
+              <a:rPr lang="en-US" sz="850" dirty="0">
                 <a:solidFill>
                   <a:schemeClr val="bg1"/>
                 </a:solidFill>
               </a:rPr>
-              <a:t>An ordered probit fitted on data as first published</a:t>
-            </a:r>
-            <a:endParaRPr lang="en-US" sz="950" dirty="0"/>
-          </a:p>
-        </p:txBody>
-      </p:sp>
-      <p:sp>
-        <p:nvSpPr>
-          <p:cNvPr id="18" name="Text 15"/>
-          <p:cNvSpPr txBox="1"/>
-          <p:nvPr/>
-        </p:nvSpPr>
-        <p:spPr>
-          <a:xfrm>
-            <a:off x="2761488" y="4379976"/>
-            <a:ext cx="1325880" cy="548640"/>
-          </a:xfrm>
-          <a:prstGeom prst="rect">
-            <a:avLst/>
-          </a:prstGeom>
-          <a:noFill/>
-          <a:ln/>
-        </p:spPr>
-        <p:txBody>
-          <a:bodyPr wrap="square" lIns="0" tIns="0" rIns="0" bIns="0" rtlCol="0" anchor="ctr"/>
-          <a:lstStyle/>
-          <a:p>
-            <a:pPr indent="0" marL="0">
-              <a:buNone/>
-            </a:pPr>
-            <a:r>
-              <a:rPr lang="en-US" sz="900" dirty="0">
-                <a:solidFill>
-                  <a:schemeClr val="accent4"/>
-                </a:solidFill>
-              </a:rPr>
-              <a:t>computed, weight 0 until it has a live record</a:t>
-            </a:r>
-            <a:endParaRPr lang="en-US" sz="900" dirty="0"/>
-          </a:p>
-        </p:txBody>
-      </p:sp>
-      <p:sp>
-        <p:nvSpPr>
-          <p:cNvPr id="19" name="Shape 16"/>
+              <a:t>An ordered probit fitted on data as first published; shown, not yet in the number</a:t>
+            </a:r>
+            <a:endParaRPr lang="en-US" sz="850" dirty="0"/>
+          </a:p>
+        </p:txBody>
+      </p:sp>
+      <p:sp>
+        <p:nvSpPr>
+          <p:cNvPr id="16" name="Shape 13"/>
           <p:cNvSpPr/>
           <p:nvPr/>
         </p:nvSpPr>
         <p:spPr>
           <a:xfrm>
-            <a:off x="4114800" y="4631436"/>
-            <a:ext cx="411480" cy="0"/>
+            <a:off x="3136392" y="3712464"/>
+            <a:ext cx="365760" cy="0"/>
           </a:xfrm>
           <a:prstGeom prst="line">
             <a:avLst/>
@@ -3012,18 +2904,18 @@
       </p:sp>
       <p:sp>
         <p:nvSpPr>
-          <p:cNvPr id="20" name="Shape 17"/>
+          <p:cNvPr id="17" name="Shape 14"/>
           <p:cNvSpPr/>
           <p:nvPr/>
         </p:nvSpPr>
         <p:spPr>
           <a:xfrm>
-            <a:off x="548640" y="5221224"/>
-            <a:ext cx="2103120" cy="960120"/>
+            <a:off x="548640" y="4123944"/>
+            <a:ext cx="2514600" cy="676656"/>
           </a:xfrm>
           <a:prstGeom prst="roundRect">
             <a:avLst>
-              <a:gd name="adj" fmla="val 9524"/>
+              <a:gd name="adj" fmla="val 10811"/>
             </a:avLst>
           </a:prstGeom>
           <a:solidFill>
@@ -3039,14 +2931,14 @@
       </p:sp>
       <p:sp>
         <p:nvSpPr>
-          <p:cNvPr id="21" name="Text 18"/>
-          <p:cNvSpPr txBox="1"/>
-          <p:nvPr/>
-        </p:nvSpPr>
-        <p:spPr>
-          <a:xfrm>
-            <a:off x="685800" y="5294376"/>
-            <a:ext cx="1828800" cy="292608"/>
+          <p:cNvPr id="18" name="Text 15"/>
+          <p:cNvSpPr txBox="1"/>
+          <p:nvPr/>
+        </p:nvSpPr>
+        <p:spPr>
+          <a:xfrm>
+            <a:off x="676656" y="4178808"/>
+            <a:ext cx="2258568" cy="274320"/>
           </a:xfrm>
           <a:prstGeom prst="rect">
             <a:avLst/>
@@ -3062,27 +2954,27 @@
               <a:buNone/>
             </a:pPr>
             <a:r>
-              <a:rPr lang="en-US" sz="1300" b="1" dirty="0">
+              <a:rPr lang="en-US" sz="1200" b="1" dirty="0">
                 <a:solidFill>
                   <a:schemeClr val="bg1"/>
                 </a:solidFill>
               </a:rPr>
               <a:t>LLM-derived</a:t>
             </a:r>
-            <a:endParaRPr lang="en-US" sz="1300" dirty="0"/>
-          </a:p>
-        </p:txBody>
-      </p:sp>
-      <p:sp>
-        <p:nvSpPr>
-          <p:cNvPr id="22" name="Text 19"/>
-          <p:cNvSpPr txBox="1"/>
-          <p:nvPr/>
-        </p:nvSpPr>
-        <p:spPr>
-          <a:xfrm>
-            <a:off x="685800" y="5586984"/>
-            <a:ext cx="1828800" cy="566928"/>
+            <a:endParaRPr lang="en-US" sz="1200" dirty="0"/>
+          </a:p>
+        </p:txBody>
+      </p:sp>
+      <p:sp>
+        <p:nvSpPr>
+          <p:cNvPr id="19" name="Text 16"/>
+          <p:cNvSpPr txBox="1"/>
+          <p:nvPr/>
+        </p:nvSpPr>
+        <p:spPr>
+          <a:xfrm>
+            <a:off x="676656" y="4425696"/>
+            <a:ext cx="2258568" cy="365760"/>
           </a:xfrm>
           <a:prstGeom prst="rect">
             <a:avLst/>
@@ -3098,63 +2990,27 @@
               <a:buNone/>
             </a:pPr>
             <a:r>
-              <a:rPr lang="en-US" sz="950" dirty="0">
+              <a:rPr lang="en-US" sz="850" dirty="0">
                 <a:solidFill>
                   <a:schemeClr val="bg1"/>
                 </a:solidFill>
               </a:rPr>
-              <a:t>Five specialist analysts reading the Fed's own words, every claim quoted and verified by code</a:t>
-            </a:r>
-            <a:endParaRPr lang="en-US" sz="950" dirty="0"/>
-          </a:p>
-        </p:txBody>
-      </p:sp>
-      <p:sp>
-        <p:nvSpPr>
-          <p:cNvPr id="23" name="Text 20"/>
-          <p:cNvSpPr txBox="1"/>
-          <p:nvPr/>
-        </p:nvSpPr>
-        <p:spPr>
-          <a:xfrm>
-            <a:off x="2761488" y="5449824"/>
-            <a:ext cx="1325880" cy="548640"/>
-          </a:xfrm>
-          <a:prstGeom prst="rect">
-            <a:avLst/>
-          </a:prstGeom>
-          <a:noFill/>
-          <a:ln/>
-        </p:spPr>
-        <p:txBody>
-          <a:bodyPr wrap="square" lIns="0" tIns="0" rIns="0" bIns="0" rtlCol="0" anchor="ctr"/>
-          <a:lstStyle/>
-          <a:p>
-            <a:pPr indent="0" marL="0">
-              <a:buNone/>
-            </a:pPr>
-            <a:r>
-              <a:rPr lang="en-US" sz="900" dirty="0">
-                <a:solidFill>
-                  <a:schemeClr val="accent4"/>
-                </a:solidFill>
-              </a:rPr>
-              <a:t>a lean of at most 10 points</a:t>
-            </a:r>
-            <a:endParaRPr lang="en-US" sz="900" dirty="0"/>
-          </a:p>
-        </p:txBody>
-      </p:sp>
-      <p:sp>
-        <p:nvSpPr>
-          <p:cNvPr id="24" name="Shape 21"/>
+              <a:t>Five specialist analysts reading the Fed's own words; every claim quoted and verified by code</a:t>
+            </a:r>
+            <a:endParaRPr lang="en-US" sz="850" dirty="0"/>
+          </a:p>
+        </p:txBody>
+      </p:sp>
+      <p:sp>
+        <p:nvSpPr>
+          <p:cNvPr id="20" name="Shape 17"/>
           <p:cNvSpPr/>
           <p:nvPr/>
         </p:nvSpPr>
         <p:spPr>
           <a:xfrm>
-            <a:off x="4114800" y="5701284"/>
-            <a:ext cx="411480" cy="0"/>
+            <a:off x="3136392" y="4462272"/>
+            <a:ext cx="365760" cy="0"/>
           </a:xfrm>
           <a:prstGeom prst="line">
             <a:avLst/>
@@ -3171,18 +3027,18 @@
       </p:sp>
       <p:sp>
         <p:nvSpPr>
-          <p:cNvPr id="25" name="Shape 22"/>
+          <p:cNvPr id="21" name="Shape 18"/>
           <p:cNvSpPr/>
           <p:nvPr/>
         </p:nvSpPr>
         <p:spPr>
           <a:xfrm>
-            <a:off x="4572000" y="2011680"/>
-            <a:ext cx="1188720" cy="4169664"/>
+            <a:off x="3566160" y="1874520"/>
+            <a:ext cx="1234440" cy="2926080"/>
           </a:xfrm>
           <a:prstGeom prst="roundRect">
             <a:avLst>
-              <a:gd name="adj" fmla="val 7692"/>
+              <a:gd name="adj" fmla="val 7407"/>
             </a:avLst>
           </a:prstGeom>
           <a:solidFill>
@@ -3198,14 +3054,14 @@
       </p:sp>
       <p:sp>
         <p:nvSpPr>
-          <p:cNvPr id="26" name="Text 23"/>
-          <p:cNvSpPr txBox="1"/>
-          <p:nvPr/>
-        </p:nvSpPr>
-        <p:spPr>
-          <a:xfrm>
-            <a:off x="4572000" y="2286000"/>
-            <a:ext cx="1188720" cy="365760"/>
+          <p:cNvPr id="22" name="Text 19"/>
+          <p:cNvSpPr txBox="1"/>
+          <p:nvPr/>
+        </p:nvSpPr>
+        <p:spPr>
+          <a:xfrm>
+            <a:off x="3566160" y="2103120"/>
+            <a:ext cx="1234440" cy="365760"/>
           </a:xfrm>
           <a:prstGeom prst="rect">
             <a:avLst/>
@@ -3221,27 +3077,27 @@
               <a:buNone/>
             </a:pPr>
             <a:r>
-              <a:rPr lang="en-US" sz="1500" b="1" dirty="0">
+              <a:rPr lang="en-US" sz="1400" b="1" dirty="0">
                 <a:solidFill>
                   <a:schemeClr val="tx2"/>
                 </a:solidFill>
               </a:rPr>
               <a:t>Pool</a:t>
             </a:r>
-            <a:endParaRPr lang="en-US" sz="1500" dirty="0"/>
-          </a:p>
-        </p:txBody>
-      </p:sp>
-      <p:sp>
-        <p:nvSpPr>
-          <p:cNvPr id="27" name="Text 24"/>
-          <p:cNvSpPr txBox="1"/>
-          <p:nvPr/>
-        </p:nvSpPr>
-        <p:spPr>
-          <a:xfrm>
-            <a:off x="4663440" y="2743200"/>
-            <a:ext cx="1005840" cy="3200400"/>
+            <a:endParaRPr lang="en-US" sz="1400" dirty="0"/>
+          </a:p>
+        </p:txBody>
+      </p:sp>
+      <p:sp>
+        <p:nvSpPr>
+          <p:cNvPr id="23" name="Text 20"/>
+          <p:cNvSpPr txBox="1"/>
+          <p:nvPr/>
+        </p:nvSpPr>
+        <p:spPr>
+          <a:xfrm>
+            <a:off x="3657600" y="2560320"/>
+            <a:ext cx="1051560" cy="2560320"/>
           </a:xfrm>
           <a:prstGeom prst="rect">
             <a:avLst/>
@@ -3262,7 +3118,7 @@
                   <a:schemeClr val="tx1"/>
                 </a:solidFill>
               </a:rPr>
-              <a:t>Fixed, recorded weights. A floor of 1.5% on every outcome. Then the analysts' lean. Code does this; no model writes the number.</a:t>
+              <a:t>Combined by code with fixed, published weights. No model writes the number.</a:t>
             </a:r>
             <a:endParaRPr lang="en-US" sz="900" dirty="0"/>
           </a:p>
@@ -3270,13 +3126,13 @@
       </p:sp>
       <p:sp>
         <p:nvSpPr>
-          <p:cNvPr id="28" name="Shape 25"/>
+          <p:cNvPr id="24" name="Shape 21"/>
           <p:cNvSpPr/>
           <p:nvPr/>
         </p:nvSpPr>
         <p:spPr>
           <a:xfrm>
-            <a:off x="5806440" y="4096512"/>
+            <a:off x="4864608" y="3337560"/>
             <a:ext cx="365760" cy="0"/>
           </a:xfrm>
           <a:prstGeom prst="line">
@@ -3294,18 +3150,18 @@
       </p:sp>
       <p:sp>
         <p:nvSpPr>
-          <p:cNvPr id="29" name="Shape 26"/>
+          <p:cNvPr id="25" name="Shape 22"/>
           <p:cNvSpPr/>
           <p:nvPr/>
         </p:nvSpPr>
         <p:spPr>
           <a:xfrm>
-            <a:off x="6263640" y="3410712"/>
-            <a:ext cx="1234440" cy="1371600"/>
+            <a:off x="5303520" y="2697480"/>
+            <a:ext cx="1280160" cy="1280160"/>
           </a:xfrm>
           <a:prstGeom prst="roundRect">
             <a:avLst>
-              <a:gd name="adj" fmla="val 7407"/>
+              <a:gd name="adj" fmla="val 7143"/>
             </a:avLst>
           </a:prstGeom>
           <a:solidFill>
@@ -3321,14 +3177,230 @@
       </p:sp>
       <p:sp>
         <p:nvSpPr>
+          <p:cNvPr id="26" name="Text 23"/>
+          <p:cNvSpPr txBox="1"/>
+          <p:nvPr/>
+        </p:nvSpPr>
+        <p:spPr>
+          <a:xfrm>
+            <a:off x="5303520" y="2788920"/>
+            <a:ext cx="1280160" cy="365760"/>
+          </a:xfrm>
+          <a:prstGeom prst="rect">
+            <a:avLst/>
+          </a:prstGeom>
+          <a:noFill/>
+          <a:ln/>
+        </p:spPr>
+        <p:txBody>
+          <a:bodyPr wrap="square" lIns="0" tIns="0" rIns="0" bIns="0" rtlCol="0" anchor="t"/>
+          <a:lstStyle/>
+          <a:p>
+            <a:pPr algn="ctr" indent="0" marL="0">
+              <a:buNone/>
+            </a:pPr>
+            <a:r>
+              <a:rPr lang="en-US" sz="1300" b="1" dirty="0">
+                <a:solidFill>
+                  <a:schemeClr val="bg1"/>
+                </a:solidFill>
+              </a:rPr>
+              <a:t>Forecast</a:t>
+            </a:r>
+            <a:endParaRPr lang="en-US" sz="1300" dirty="0"/>
+          </a:p>
+        </p:txBody>
+      </p:sp>
+      <p:sp>
+        <p:nvSpPr>
+          <p:cNvPr id="27" name="Text 24"/>
+          <p:cNvSpPr txBox="1"/>
+          <p:nvPr/>
+        </p:nvSpPr>
+        <p:spPr>
+          <a:xfrm>
+            <a:off x="5303520" y="3200400"/>
+            <a:ext cx="1280160" cy="731520"/>
+          </a:xfrm>
+          <a:prstGeom prst="rect">
+            <a:avLst/>
+          </a:prstGeom>
+          <a:noFill/>
+          <a:ln/>
+        </p:spPr>
+        <p:txBody>
+          <a:bodyPr wrap="square" lIns="0" tIns="0" rIns="0" bIns="0" rtlCol="0" anchor="t"/>
+          <a:lstStyle/>
+          <a:p>
+            <a:pPr algn="ctr" indent="0" marL="0">
+              <a:buNone/>
+            </a:pPr>
+            <a:r>
+              <a:rPr lang="en-US" sz="1050" dirty="0">
+                <a:solidFill>
+                  <a:schemeClr val="bg1"/>
+                </a:solidFill>
+              </a:rPr>
+              <a:t>no change 71%</a:t>
+            </a:r>
+            <a:endParaRPr lang="en-US" sz="1050" dirty="0"/>
+          </a:p>
+          <a:p>
+            <a:pPr algn="ctr" indent="0" marL="0">
+              <a:buNone/>
+            </a:pPr>
+            <a:r>
+              <a:rPr lang="en-US" sz="1050" dirty="0">
+                <a:solidFill>
+                  <a:schemeClr val="bg1"/>
+                </a:solidFill>
+              </a:rPr>
+              <a:t>+25 bps 23%</a:t>
+            </a:r>
+            <a:endParaRPr lang="en-US" sz="1050" dirty="0"/>
+          </a:p>
+        </p:txBody>
+      </p:sp>
+      <p:sp>
+        <p:nvSpPr>
+          <p:cNvPr id="28" name="Text 25"/>
+          <p:cNvSpPr txBox="1"/>
+          <p:nvPr/>
+        </p:nvSpPr>
+        <p:spPr>
+          <a:xfrm>
+            <a:off x="548640" y="4983480"/>
+            <a:ext cx="6400800" cy="274320"/>
+          </a:xfrm>
+          <a:prstGeom prst="rect">
+            <a:avLst/>
+          </a:prstGeom>
+          <a:noFill/>
+          <a:ln/>
+        </p:spPr>
+        <p:txBody>
+          <a:bodyPr wrap="square" lIns="0" tIns="0" rIns="0" bIns="0" rtlCol="0" anchor="t"/>
+          <a:lstStyle/>
+          <a:p>
+            <a:pPr indent="0" marL="0">
+              <a:buNone/>
+            </a:pPr>
+            <a:r>
+              <a:rPr lang="en-US" sz="1200" b="1" dirty="0">
+                <a:solidFill>
+                  <a:schemeClr val="tx2"/>
+                </a:solidFill>
+              </a:rPr>
+              <a:t>What it does</a:t>
+            </a:r>
+            <a:endParaRPr lang="en-US" sz="1200" dirty="0"/>
+          </a:p>
+        </p:txBody>
+      </p:sp>
+      <p:sp>
+        <p:nvSpPr>
+          <p:cNvPr id="29" name="Text 26"/>
+          <p:cNvSpPr txBox="1"/>
+          <p:nvPr/>
+        </p:nvSpPr>
+        <p:spPr>
+          <a:xfrm>
+            <a:off x="548640" y="5257800"/>
+            <a:ext cx="6492240" cy="1097280"/>
+          </a:xfrm>
+          <a:prstGeom prst="rect">
+            <a:avLst/>
+          </a:prstGeom>
+          <a:noFill/>
+          <a:ln/>
+        </p:spPr>
+        <p:txBody>
+          <a:bodyPr wrap="square" lIns="0" tIns="0" rIns="0" bIns="0" rtlCol="0" anchor="t"/>
+          <a:lstStyle/>
+          <a:p>
+            <a:pPr marL="342900" indent="-342900">
+              <a:spcAft>
+                <a:spcPts val="200"/>
+              </a:spcAft>
+              <a:buSzPct val="100000"/>
+              <a:buChar char="•"/>
+            </a:pPr>
+            <a:r>
+              <a:rPr lang="en-US" sz="950" dirty="0">
+                <a:solidFill>
+                  <a:schemeClr val="tx1"/>
+                </a:solidFill>
+              </a:rPr>
+              <a:t>Freezes one fingerprinted snapshot of evidence per forecast; nothing outside it may be read.</a:t>
+            </a:r>
+            <a:endParaRPr lang="en-US" sz="950" dirty="0"/>
+          </a:p>
+          <a:p>
+            <a:pPr marL="342900" indent="-342900">
+              <a:spcAft>
+                <a:spcPts val="200"/>
+              </a:spcAft>
+              <a:buSzPct val="100000"/>
+              <a:buChar char="•"/>
+            </a:pPr>
+            <a:r>
+              <a:rPr lang="en-US" sz="950" dirty="0">
+                <a:solidFill>
+                  <a:schemeClr val="tx1"/>
+                </a:solidFill>
+              </a:rPr>
+              <a:t>Enforces repeatability: five identical runs per analyst, tools off, every quote checked by code, a pre-registered scorecard on every snapshot.</a:t>
+            </a:r>
+            <a:endParaRPr lang="en-US" sz="950" dirty="0"/>
+          </a:p>
+          <a:p>
+            <a:pPr marL="342900" indent="-342900">
+              <a:spcAft>
+                <a:spcPts val="200"/>
+              </a:spcAft>
+              <a:buSzPct val="100000"/>
+              <a:buChar char="•"/>
+            </a:pPr>
+            <a:r>
+              <a:rPr lang="en-US" sz="950" dirty="0">
+                <a:solidFill>
+                  <a:schemeClr val="tx1"/>
+                </a:solidFill>
+              </a:rPr>
+              <a:t>Offers typed channels for human judgement (views, watch-outs, documents, odds): bounded, recorded, scored afterwards. None active today.</a:t>
+            </a:r>
+            <a:endParaRPr lang="en-US" sz="950" dirty="0"/>
+          </a:p>
+          <a:p>
+            <a:pPr marL="342900" indent="-342900">
+              <a:spcAft>
+                <a:spcPts val="200"/>
+              </a:spcAft>
+              <a:buSzPct val="100000"/>
+              <a:buChar char="•"/>
+            </a:pPr>
+            <a:r>
+              <a:rPr lang="en-US" sz="950" dirty="0">
+                <a:solidFill>
+                  <a:schemeClr val="tx1"/>
+                </a:solidFill>
+              </a:rPr>
+              <a:t>Keeps every snapshot and forecast in a hash-chained ledger, so the number's path can be read back as information arrived.</a:t>
+            </a:r>
+            <a:endParaRPr lang="en-US" sz="950" dirty="0"/>
+          </a:p>
+        </p:txBody>
+      </p:sp>
+      <p:sp>
+        <p:nvSpPr>
           <p:cNvPr id="30" name="Text 27"/>
           <p:cNvSpPr txBox="1"/>
           <p:nvPr/>
         </p:nvSpPr>
         <p:spPr>
           <a:xfrm>
-            <a:off x="6263640" y="3502152"/>
-            <a:ext cx="1234440" cy="365760"/>
+            <a:off x="7315200" y="1828800"/>
+            <a:ext cx="4325112" cy="365760"/>
           </a:xfrm>
           <a:prstGeom prst="rect">
             <a:avLst/>
@@ -3340,104 +3412,81 @@
           <a:bodyPr wrap="square" lIns="0" tIns="0" rIns="0" bIns="0" rtlCol="0" anchor="t"/>
           <a:lstStyle/>
           <a:p>
-            <a:pPr algn="ctr" indent="0" marL="0">
-              <a:buNone/>
-            </a:pPr>
-            <a:r>
-              <a:rPr lang="en-US" sz="1400" b="1" dirty="0">
-                <a:solidFill>
-                  <a:schemeClr val="bg1"/>
-                </a:solidFill>
-              </a:rPr>
-              <a:t>Forecast</a:t>
-            </a:r>
-            <a:endParaRPr lang="en-US" sz="1400" dirty="0"/>
-          </a:p>
-        </p:txBody>
-      </p:sp>
-      <p:sp>
-        <p:nvSpPr>
-          <p:cNvPr id="31" name="Text 28"/>
-          <p:cNvSpPr txBox="1"/>
-          <p:nvPr/>
-        </p:nvSpPr>
-        <p:spPr>
-          <a:xfrm>
-            <a:off x="6263640" y="3913632"/>
-            <a:ext cx="1234440" cy="822960"/>
-          </a:xfrm>
-          <a:prstGeom prst="rect">
-            <a:avLst/>
-          </a:prstGeom>
-          <a:noFill/>
-          <a:ln/>
-        </p:spPr>
-        <p:txBody>
-          <a:bodyPr wrap="square" lIns="0" tIns="0" rIns="0" bIns="0" rtlCol="0" anchor="t"/>
-          <a:lstStyle/>
-          <a:p>
-            <a:pPr algn="ctr" indent="0" marL="0">
-              <a:buNone/>
-            </a:pPr>
-            <a:r>
-              <a:rPr lang="en-US" sz="1100" dirty="0">
-                <a:solidFill>
-                  <a:schemeClr val="bg1"/>
-                </a:solidFill>
-              </a:rPr>
-              <a:t>no change 71%</a:t>
-            </a:r>
-            <a:endParaRPr lang="en-US" sz="1100" dirty="0"/>
-          </a:p>
-          <a:p>
-            <a:pPr algn="ctr" indent="0" marL="0">
-              <a:buNone/>
-            </a:pPr>
-            <a:r>
-              <a:rPr lang="en-US" sz="1100" dirty="0">
-                <a:solidFill>
-                  <a:schemeClr val="bg1"/>
-                </a:solidFill>
-              </a:rPr>
-              <a:t>+25 bps 23%</a:t>
-            </a:r>
-            <a:endParaRPr lang="en-US" sz="1100" dirty="0"/>
-          </a:p>
-        </p:txBody>
-      </p:sp>
-      <p:sp>
-        <p:nvSpPr>
-          <p:cNvPr id="32" name="Shape 29"/>
+            <a:pPr indent="0" marL="0">
+              <a:buNone/>
+            </a:pPr>
+            <a:r>
+              <a:rPr lang="en-US" sz="1700" b="1" dirty="0">
+                <a:solidFill>
+                  <a:schemeClr val="tx2"/>
+                </a:solidFill>
+              </a:rPr>
+              <a:t>Why we built it</a:t>
+            </a:r>
+            <a:endParaRPr lang="en-US" sz="1700" dirty="0"/>
+          </a:p>
+        </p:txBody>
+      </p:sp>
+      <p:sp>
+        <p:nvSpPr>
+          <p:cNvPr id="31" name="Shape 28"/>
           <p:cNvSpPr/>
           <p:nvPr/>
         </p:nvSpPr>
         <p:spPr>
           <a:xfrm>
-            <a:off x="7909560" y="2011680"/>
-            <a:ext cx="3730752" cy="1353312"/>
-          </a:xfrm>
-          <a:prstGeom prst="roundRect">
-            <a:avLst>
-              <a:gd name="adj" fmla="val 8108"/>
-            </a:avLst>
+            <a:off x="7315200" y="2304288"/>
+            <a:ext cx="384048" cy="384048"/>
+          </a:xfrm>
+          <a:prstGeom prst="ellipse">
+            <a:avLst/>
           </a:prstGeom>
           <a:solidFill>
-            <a:srgbClr val="EEF2F7"/>
+            <a:srgbClr val="1E2761"/>
           </a:solidFill>
           <a:ln w="12700">
             <a:solidFill>
-              <a:srgbClr val="EEF2F7"/>
+              <a:srgbClr val="1E2761"/>
             </a:solidFill>
             <a:prstDash val="solid"/>
           </a:ln>
-          <a:effectLst>
-            <a:outerShdw sx="100000" sy="100000" kx="0" ky="0" algn="bl" rotWithShape="0" blurRad="50800" dist="12700" dir="5400000">
-              <a:srgbClr val="000000">
-                <a:alpha val="8000"/>
-              </a:srgbClr>
-            </a:outerShdw>
-          </a:effectLst>
-        </p:spPr>
+        </p:spPr>
+      </p:sp>
+      <p:sp>
+        <p:nvSpPr>
+          <p:cNvPr id="32" name="Text 29"/>
+          <p:cNvSpPr txBox="1"/>
+          <p:nvPr/>
+        </p:nvSpPr>
+        <p:spPr>
+          <a:xfrm>
+            <a:off x="7315200" y="2304288"/>
+            <a:ext cx="384048" cy="384048"/>
+          </a:xfrm>
+          <a:prstGeom prst="rect">
+            <a:avLst/>
+          </a:prstGeom>
+          <a:noFill/>
+          <a:ln/>
+        </p:spPr>
+        <p:txBody>
+          <a:bodyPr wrap="square" lIns="0" tIns="0" rIns="0" bIns="0" rtlCol="0" anchor="ctr"/>
+          <a:lstStyle/>
+          <a:p>
+            <a:pPr algn="ctr" indent="0" marL="0">
+              <a:buNone/>
+            </a:pPr>
+            <a:r>
+              <a:rPr lang="en-US" sz="1400" b="1" dirty="0">
+                <a:solidFill>
+                  <a:schemeClr val="bg1"/>
+                </a:solidFill>
+              </a:rPr>
+              <a:t>1</a:t>
+            </a:r>
+            <a:endParaRPr lang="en-US" sz="1400" dirty="0"/>
+          </a:p>
+        </p:txBody>
       </p:sp>
       <p:sp>
         <p:nvSpPr>
@@ -3447,8 +3496,8 @@
         </p:nvSpPr>
         <p:spPr>
           <a:xfrm>
-            <a:off x="8110728" y="2121408"/>
-            <a:ext cx="3328416" cy="320040"/>
+            <a:off x="7818120" y="2267712"/>
+            <a:ext cx="3822192" cy="365760"/>
           </a:xfrm>
           <a:prstGeom prst="rect">
             <a:avLst/>
@@ -3469,7 +3518,7 @@
                   <a:schemeClr val="tx2"/>
                 </a:solidFill>
               </a:rPr>
-              <a:t>Repeatability is enforced, then measured</a:t>
+              <a:t>Fed prediction tools are judged on outcomes, which cannot be repeated</a:t>
             </a:r>
             <a:endParaRPr lang="en-US" sz="1200" dirty="0"/>
           </a:p>
@@ -3483,8 +3532,8 @@
         </p:nvSpPr>
         <p:spPr>
           <a:xfrm>
-            <a:off x="8110728" y="2441448"/>
-            <a:ext cx="3328416" cy="914400"/>
+            <a:off x="7818120" y="2670048"/>
+            <a:ext cx="3822192" cy="960120"/>
           </a:xfrm>
           <a:prstGeom prst="rect">
             <a:avLst/>
@@ -3505,7 +3554,7 @@
                   <a:schemeClr val="tx1"/>
                 </a:solidFill>
               </a:rPr>
-              <a:t>One frozen, fingerprinted snapshot per forecast; code pools the models; each analyst is run five times on identical inputs with every tool off and every quote checked by code. A ten-dimension scorecard, fixed before any code existed, is measured on every snapshot, so drift shows as a red cell.</a:t>
+              <a:t>There are many of them. Eight decisions a year make a hit rate neither predictable nor repeatable as a measure of a tool. We judge ours on a pre-registered process: is the same answer produced from the same evidence, can every claim be traced, does a shock move the number the right way.</a:t>
             </a:r>
             <a:endParaRPr lang="en-US" sz="950" dirty="0"/>
           </a:p>
@@ -3519,30 +3568,21 @@
         </p:nvSpPr>
         <p:spPr>
           <a:xfrm>
-            <a:off x="7909560" y="3474720"/>
-            <a:ext cx="3730752" cy="1353312"/>
-          </a:xfrm>
-          <a:prstGeom prst="roundRect">
-            <a:avLst>
-              <a:gd name="adj" fmla="val 8108"/>
-            </a:avLst>
+            <a:off x="7315200" y="3675888"/>
+            <a:ext cx="384048" cy="384048"/>
+          </a:xfrm>
+          <a:prstGeom prst="ellipse">
+            <a:avLst/>
           </a:prstGeom>
           <a:solidFill>
-            <a:srgbClr val="EEF2F7"/>
+            <a:srgbClr val="1E2761"/>
           </a:solidFill>
           <a:ln w="12700">
             <a:solidFill>
-              <a:srgbClr val="EEF2F7"/>
+              <a:srgbClr val="1E2761"/>
             </a:solidFill>
             <a:prstDash val="solid"/>
           </a:ln>
-          <a:effectLst>
-            <a:outerShdw sx="100000" sy="100000" kx="0" ky="0" algn="bl" rotWithShape="0" blurRad="50800" dist="12700" dir="5400000">
-              <a:srgbClr val="000000">
-                <a:alpha val="8000"/>
-              </a:srgbClr>
-            </a:outerShdw>
-          </a:effectLst>
         </p:spPr>
       </p:sp>
       <p:sp>
@@ -3553,8 +3593,44 @@
         </p:nvSpPr>
         <p:spPr>
           <a:xfrm>
-            <a:off x="8110728" y="3584448"/>
-            <a:ext cx="3328416" cy="320040"/>
+            <a:off x="7315200" y="3675888"/>
+            <a:ext cx="384048" cy="384048"/>
+          </a:xfrm>
+          <a:prstGeom prst="rect">
+            <a:avLst/>
+          </a:prstGeom>
+          <a:noFill/>
+          <a:ln/>
+        </p:spPr>
+        <p:txBody>
+          <a:bodyPr wrap="square" lIns="0" tIns="0" rIns="0" bIns="0" rtlCol="0" anchor="ctr"/>
+          <a:lstStyle/>
+          <a:p>
+            <a:pPr algn="ctr" indent="0" marL="0">
+              <a:buNone/>
+            </a:pPr>
+            <a:r>
+              <a:rPr lang="en-US" sz="1400" b="1" dirty="0">
+                <a:solidFill>
+                  <a:schemeClr val="bg1"/>
+                </a:solidFill>
+              </a:rPr>
+              <a:t>2</a:t>
+            </a:r>
+            <a:endParaRPr lang="en-US" sz="1400" dirty="0"/>
+          </a:p>
+        </p:txBody>
+      </p:sp>
+      <p:sp>
+        <p:nvSpPr>
+          <p:cNvPr id="37" name="Text 34"/>
+          <p:cNvSpPr txBox="1"/>
+          <p:nvPr/>
+        </p:nvSpPr>
+        <p:spPr>
+          <a:xfrm>
+            <a:off x="7818120" y="3639312"/>
+            <a:ext cx="3822192" cy="365760"/>
           </a:xfrm>
           <a:prstGeom prst="rect">
             <a:avLst/>
@@ -3575,7 +3651,7 @@
                   <a:schemeClr val="tx2"/>
                 </a:solidFill>
               </a:rPr>
-              <a:t>Human judgement has a typed channel</a:t>
+              <a:t>Most lean too far one way</a:t>
             </a:r>
             <a:endParaRPr lang="en-US" sz="1200" dirty="0"/>
           </a:p>
@@ -3583,14 +3659,14 @@
       </p:sp>
       <p:sp>
         <p:nvSpPr>
-          <p:cNvPr id="37" name="Text 34"/>
-          <p:cNvSpPr txBox="1"/>
-          <p:nvPr/>
-        </p:nvSpPr>
-        <p:spPr>
-          <a:xfrm>
-            <a:off x="8110728" y="3904488"/>
-            <a:ext cx="3328416" cy="914400"/>
+          <p:cNvPr id="38" name="Text 35"/>
+          <p:cNvSpPr txBox="1"/>
+          <p:nvPr/>
+        </p:nvSpPr>
+        <p:spPr>
+          <a:xfrm>
+            <a:off x="7818120" y="4041648"/>
+            <a:ext cx="3822192" cy="960120"/>
           </a:xfrm>
           <a:prstGeom prst="rect">
             <a:avLst/>
@@ -3611,7 +3687,7 @@
                   <a:schemeClr val="tx1"/>
                 </a:solidFill>
               </a:rPr>
-              <a:t>None is active today. The channel exists because a desk's judgement belongs in the number, but only where it can be seen, bounded and scored afterwards: a view tilts the number by at most 10 points and expires; a watch-out must be answered by every analyst; a document or an odds entry becomes evidence.</a:t>
+              <a:t>Either empirical formulas and market prices alone, or everything thrown at a language model. Ours harmonises the three: empirical data, classic ML and a harnessed LLM, each with a stated role and a stated weight, combined by code.</a:t>
             </a:r>
             <a:endParaRPr lang="en-US" sz="950" dirty="0"/>
           </a:p>
@@ -3619,48 +3695,75 @@
       </p:sp>
       <p:sp>
         <p:nvSpPr>
-          <p:cNvPr id="38" name="Shape 35"/>
+          <p:cNvPr id="39" name="Shape 36"/>
           <p:cNvSpPr/>
           <p:nvPr/>
         </p:nvSpPr>
         <p:spPr>
           <a:xfrm>
-            <a:off x="7909560" y="4937760"/>
-            <a:ext cx="3730752" cy="1353312"/>
-          </a:xfrm>
-          <a:prstGeom prst="roundRect">
-            <a:avLst>
-              <a:gd name="adj" fmla="val 8108"/>
-            </a:avLst>
+            <a:off x="7315200" y="5047488"/>
+            <a:ext cx="384048" cy="384048"/>
+          </a:xfrm>
+          <a:prstGeom prst="ellipse">
+            <a:avLst/>
           </a:prstGeom>
           <a:solidFill>
-            <a:srgbClr val="EEF2F7"/>
+            <a:srgbClr val="1E2761"/>
           </a:solidFill>
           <a:ln w="12700">
             <a:solidFill>
-              <a:srgbClr val="EEF2F7"/>
+              <a:srgbClr val="1E2761"/>
             </a:solidFill>
             <a:prstDash val="solid"/>
           </a:ln>
-          <a:effectLst>
-            <a:outerShdw sx="100000" sy="100000" kx="0" ky="0" algn="bl" rotWithShape="0" blurRad="50800" dist="12700" dir="5400000">
-              <a:srgbClr val="000000">
-                <a:alpha val="8000"/>
-              </a:srgbClr>
-            </a:outerShdw>
-          </a:effectLst>
-        </p:spPr>
-      </p:sp>
-      <p:sp>
-        <p:nvSpPr>
-          <p:cNvPr id="39" name="Text 36"/>
-          <p:cNvSpPr txBox="1"/>
-          <p:nvPr/>
-        </p:nvSpPr>
-        <p:spPr>
-          <a:xfrm>
-            <a:off x="8110728" y="5047488"/>
-            <a:ext cx="3328416" cy="320040"/>
+        </p:spPr>
+      </p:sp>
+      <p:sp>
+        <p:nvSpPr>
+          <p:cNvPr id="40" name="Text 37"/>
+          <p:cNvSpPr txBox="1"/>
+          <p:nvPr/>
+        </p:nvSpPr>
+        <p:spPr>
+          <a:xfrm>
+            <a:off x="7315200" y="5047488"/>
+            <a:ext cx="384048" cy="384048"/>
+          </a:xfrm>
+          <a:prstGeom prst="rect">
+            <a:avLst/>
+          </a:prstGeom>
+          <a:noFill/>
+          <a:ln/>
+        </p:spPr>
+        <p:txBody>
+          <a:bodyPr wrap="square" lIns="0" tIns="0" rIns="0" bIns="0" rtlCol="0" anchor="ctr"/>
+          <a:lstStyle/>
+          <a:p>
+            <a:pPr algn="ctr" indent="0" marL="0">
+              <a:buNone/>
+            </a:pPr>
+            <a:r>
+              <a:rPr lang="en-US" sz="1400" b="1" dirty="0">
+                <a:solidFill>
+                  <a:schemeClr val="bg1"/>
+                </a:solidFill>
+              </a:rPr>
+              <a:t>3</a:t>
+            </a:r>
+            <a:endParaRPr lang="en-US" sz="1400" dirty="0"/>
+          </a:p>
+        </p:txBody>
+      </p:sp>
+      <p:sp>
+        <p:nvSpPr>
+          <p:cNvPr id="41" name="Text 38"/>
+          <p:cNvSpPr txBox="1"/>
+          <p:nvPr/>
+        </p:nvSpPr>
+        <p:spPr>
+          <a:xfrm>
+            <a:off x="7818120" y="5010912"/>
+            <a:ext cx="3822192" cy="365760"/>
           </a:xfrm>
           <a:prstGeom prst="rect">
             <a:avLst/>
@@ -3681,7 +3784,7 @@
                   <a:schemeClr val="tx2"/>
                 </a:solidFill>
               </a:rPr>
-              <a:t>All evidence is kept, so the path can be read back</a:t>
+              <a:t>What that buys</a:t>
             </a:r>
             <a:endParaRPr lang="en-US" sz="1200" dirty="0"/>
           </a:p>
@@ -3689,14 +3792,14 @@
       </p:sp>
       <p:sp>
         <p:nvSpPr>
-          <p:cNvPr id="40" name="Text 37"/>
-          <p:cNvSpPr txBox="1"/>
-          <p:nvPr/>
-        </p:nvSpPr>
-        <p:spPr>
-          <a:xfrm>
-            <a:off x="8110728" y="5367528"/>
-            <a:ext cx="3328416" cy="914400"/>
+          <p:cNvPr id="42" name="Text 39"/>
+          <p:cNvSpPr txBox="1"/>
+          <p:nvPr/>
+        </p:nvSpPr>
+        <p:spPr>
+          <a:xfrm>
+            <a:off x="7818120" y="5413248"/>
+            <a:ext cx="3822192" cy="960120"/>
           </a:xfrm>
           <a:prstGeom prst="rect">
             <a:avLst/>
@@ -3717,7 +3820,7 @@
                   <a:schemeClr val="tx1"/>
                 </a:solidFill>
               </a:rPr>
-              <a:t>Each pull is frozen and hash-chained to the forecast it produced. As new information arrives, the number and each model's contribution move, and the ledger shows exactly which input moved it: 62/33 on 15 October, 65/30 on 24 October, 71/23 on 26 October after the market odds were refreshed.</a:t>
+              <a:t>Auditability: every input visible, every forecast replayable. Evidence-based: every claim quoted and verified, nothing from memory. A harnessed LLM that cannot give random or spurious answers, and a naive LLM kept as the control that shows what the harness adds. Users can study how one piece of evidence moves the decision. The model can be scrutinised and improved, rather than hoping the LLM works.</a:t>
             </a:r>
             <a:endParaRPr lang="en-US" sz="950" dirty="0"/>
           </a:p>

</xml_diff>

<commit_message>
Short brief: owner's edits (photo, dates, wording) tidied in place
Co-Authored-By: Claude Fable 5.1 <noreply@anthropic.com>
</commit_message>
<xml_diff>
--- a/docs/FedCast_Fullerton_short.pptx
+++ b/docs/FedCast_Fullerton_short.pptx
@@ -4,14 +4,14 @@
   <p:sldMasterIdLst>
     <p:sldMasterId id="2147483648" r:id="rId1"/>
   </p:sldMasterIdLst>
+  <p:notesMasterIdLst>
+    <p:notesMasterId r:id="rId5"/>
+  </p:notesMasterIdLst>
   <p:sldIdLst>
     <p:sldId id="256" r:id="rId2"/>
     <p:sldId id="257" r:id="rId3"/>
     <p:sldId id="258" r:id="rId4"/>
   </p:sldIdLst>
-  <p:notesMasterIdLst>
-    <p:notesMasterId r:id="rId5"/>
-  </p:notesMasterIdLst>
   <p:sldSz cx="12192000" cy="6858000"/>
   <p:notesSz cx="6858000" cy="12192000"/>
   <p:defaultTextStyle>
@@ -109,7 +109,7 @@
   <p:extLst>
     <p:ext uri="{521415D9-36F7-43E2-AB2F-B90AF26B5E84}">
       <p14:sectionLst xmlns:p14="http://schemas.microsoft.com/office/powerpoint/2010/main">
-        <p14:section name="Brief" id="{cce3a166-3062-b012-acba-5b1b5710b73f}">
+        <p14:section name="Brief" id="{CCE3A166-3062-B012-ACBA-5B1B5710B73F}">
           <p14:sldIdLst>
             <p14:sldId id="256"/>
             <p14:sldId id="257"/>
@@ -147,234 +147,10 @@
           <a:chExt cx="0" cy="0"/>
         </a:xfrm>
       </p:grpSpPr>
-      <p:sp>
-        <p:nvSpPr>
-          <p:cNvPr id="2" name="Header Placeholder 1"/>
-          <p:cNvSpPr>
-            <a:spLocks noGrp="1"/>
-          </p:cNvSpPr>
-          <p:nvPr>
-            <p:ph type="hdr" sz="quarter"/>
-          </p:nvPr>
-        </p:nvSpPr>
-        <p:spPr>
-          <a:xfrm>
-            <a:off x="0" y="0"/>
-            <a:ext cx="2971800" cy="458788"/>
-          </a:xfrm>
-          <a:prstGeom prst="rect">
-            <a:avLst/>
-          </a:prstGeom>
-        </p:spPr>
-        <p:txBody>
-          <a:bodyPr vert="horz" lIns="91440" tIns="45720" rIns="91440" bIns="45720" rtlCol="0"/>
-          <a:lstStyle>
-            <a:lvl1pPr algn="l">
-              <a:defRPr sz="1200"/>
-            </a:lvl1pPr>
-          </a:lstStyle>
-          <a:p>
-            <a:endParaRPr lang="en-US"/>
-          </a:p>
-        </p:txBody>
-      </p:sp>
-      <p:sp>
-        <p:nvSpPr>
-          <p:cNvPr id="3" name="Date Placeholder 2"/>
-          <p:cNvSpPr>
-            <a:spLocks noGrp="1"/>
-          </p:cNvSpPr>
-          <p:nvPr>
-            <p:ph type="dt" idx="1"/>
-          </p:nvPr>
-        </p:nvSpPr>
-        <p:spPr>
-          <a:xfrm>
-            <a:off x="3884613" y="0"/>
-            <a:ext cx="2971800" cy="458788"/>
-          </a:xfrm>
-          <a:prstGeom prst="rect">
-            <a:avLst/>
-          </a:prstGeom>
-        </p:spPr>
-        <p:txBody>
-          <a:bodyPr vert="horz" lIns="91440" tIns="45720" rIns="91440" bIns="45720" rtlCol="0"/>
-          <a:lstStyle>
-            <a:lvl1pPr algn="r">
-              <a:defRPr sz="1200"/>
-            </a:lvl1pPr>
-          </a:lstStyle>
-          <a:p>
-            <a:fld id="{5282F153-3F37-0F45-9E97-73ACFA13230C}" type="datetimeFigureOut">
-              <a:rPr lang="en-US"/>
-              <a:t>7/23/19</a:t>
-            </a:fld>
-            <a:endParaRPr lang="en-US"/>
-          </a:p>
-        </p:txBody>
-      </p:sp>
-      <p:sp>
-        <p:nvSpPr>
-          <p:cNvPr id="4" name="Slide Image Placeholder 3"/>
-          <p:cNvSpPr>
-            <a:spLocks noGrp="1" noRot="1" noChangeAspect="1"/>
-          </p:cNvSpPr>
-          <p:nvPr>
-            <p:ph type="sldImg" idx="2"/>
-          </p:nvPr>
-        </p:nvSpPr>
-        <p:spPr>
-          <a:xfrm>
-            <a:off x="685800" y="1143000"/>
-            <a:ext cx="5486400" cy="3086100"/>
-          </a:xfrm>
-          <a:prstGeom prst="rect">
-            <a:avLst/>
-          </a:prstGeom>
-          <a:noFill/>
-          <a:ln w="12700">
-            <a:solidFill>
-              <a:prstClr val="black"/>
-            </a:solidFill>
-          </a:ln>
-        </p:spPr>
-        <p:txBody>
-          <a:bodyPr vert="horz" lIns="91440" tIns="45720" rIns="91440" bIns="45720" rtlCol="0" anchor="ctr"/>
-          <a:lstStyle/>
-          <a:p>
-            <a:endParaRPr lang="en-US"/>
-          </a:p>
-        </p:txBody>
-      </p:sp>
-      <p:sp>
-        <p:nvSpPr>
-          <p:cNvPr id="5" name="Notes Placeholder 4"/>
-          <p:cNvSpPr>
-            <a:spLocks noGrp="1"/>
-          </p:cNvSpPr>
-          <p:nvPr>
-            <p:ph type="body" sz="quarter" idx="3"/>
-          </p:nvPr>
-        </p:nvSpPr>
-        <p:spPr>
-          <a:xfrm>
-            <a:off x="685800" y="4400550"/>
-            <a:ext cx="5486400" cy="3600450"/>
-          </a:xfrm>
-          <a:prstGeom prst="rect">
-            <a:avLst/>
-          </a:prstGeom>
-        </p:spPr>
-        <p:txBody>
-          <a:bodyPr vert="horz" lIns="91440" tIns="45720" rIns="91440" bIns="45720" rtlCol="0"/>
-          <a:lstStyle/>
-          <a:p>
-            <a:pPr lvl="0"/>
-            <a:r>
-              <a:rPr lang="en-US"/>
-              <a:t>Click to edit Master text styles</a:t>
-            </a:r>
-          </a:p>
-          <a:p>
-            <a:pPr lvl="1"/>
-            <a:r>
-              <a:rPr lang="en-US"/>
-              <a:t>Second level</a:t>
-            </a:r>
-          </a:p>
-          <a:p>
-            <a:pPr lvl="2"/>
-            <a:r>
-              <a:rPr lang="en-US"/>
-              <a:t>Third level</a:t>
-            </a:r>
-          </a:p>
-          <a:p>
-            <a:pPr lvl="3"/>
-            <a:r>
-              <a:rPr lang="en-US"/>
-              <a:t>Fourth level</a:t>
-            </a:r>
-          </a:p>
-          <a:p>
-            <a:pPr lvl="4"/>
-            <a:r>
-              <a:rPr lang="en-US"/>
-              <a:t>Fifth level</a:t>
-            </a:r>
-          </a:p>
-        </p:txBody>
-      </p:sp>
-      <p:sp>
-        <p:nvSpPr>
-          <p:cNvPr id="6" name="Footer Placeholder 5"/>
-          <p:cNvSpPr>
-            <a:spLocks noGrp="1"/>
-          </p:cNvSpPr>
-          <p:nvPr>
-            <p:ph type="ftr" sz="quarter" idx="4"/>
-          </p:nvPr>
-        </p:nvSpPr>
-        <p:spPr>
-          <a:xfrm>
-            <a:off x="0" y="8685213"/>
-            <a:ext cx="2971800" cy="458787"/>
-          </a:xfrm>
-          <a:prstGeom prst="rect">
-            <a:avLst/>
-          </a:prstGeom>
-        </p:spPr>
-        <p:txBody>
-          <a:bodyPr vert="horz" lIns="91440" tIns="45720" rIns="91440" bIns="45720" rtlCol="0" anchor="b"/>
-          <a:lstStyle>
-            <a:lvl1pPr algn="l">
-              <a:defRPr sz="1200"/>
-            </a:lvl1pPr>
-          </a:lstStyle>
-          <a:p>
-            <a:endParaRPr lang="en-US"/>
-          </a:p>
-        </p:txBody>
-      </p:sp>
-      <p:sp>
-        <p:nvSpPr>
-          <p:cNvPr id="7" name="Slide Number Placeholder 6"/>
-          <p:cNvSpPr>
-            <a:spLocks noGrp="1"/>
-          </p:cNvSpPr>
-          <p:nvPr>
-            <p:ph type="sldNum" sz="quarter" idx="5"/>
-          </p:nvPr>
-        </p:nvSpPr>
-        <p:spPr>
-          <a:xfrm>
-            <a:off x="3884613" y="8685213"/>
-            <a:ext cx="2971800" cy="458787"/>
-          </a:xfrm>
-          <a:prstGeom prst="rect">
-            <a:avLst/>
-          </a:prstGeom>
-        </p:spPr>
-        <p:txBody>
-          <a:bodyPr vert="horz" lIns="91440" tIns="45720" rIns="91440" bIns="45720" rtlCol="0" anchor="b"/>
-          <a:lstStyle>
-            <a:lvl1pPr algn="r">
-              <a:defRPr sz="1200"/>
-            </a:lvl1pPr>
-          </a:lstStyle>
-          <a:p>
-            <a:fld id="{CE5E9CC1-C706-0F49-92D6-E571CC5EEA8F}" type="slidenum">
-              <a:rPr lang="en-US"/>
-              <a:t>‹#›</a:t>
-            </a:fld>
-            <a:endParaRPr lang="en-US"/>
-          </a:p>
-        </p:txBody>
-      </p:sp>
     </p:spTree>
     <p:extLst>
       <p:ext uri="{BB962C8B-B14F-4D97-AF65-F5344CB8AC3E}">
-        <p14:creationId xmlns:p14="http://schemas.microsoft.com/office/powerpoint/2010/main" val="1024086991"/>
+        <p14:creationId xmlns:p14="http://schemas.microsoft.com/office/powerpoint/2010/main" val="1729015408"/>
       </p:ext>
     </p:extLst>
   </p:cSld>
@@ -522,7 +298,6 @@
               <a:rPr lang="en-US" dirty="0"/>
               <a:t>One line: a language model inside an engineered harness gives forecasts that are measurably more repeatable and more faithful to evidence than the same model asked naively, and we prove it by measuring the process, not by waiting for eight decisions a year to come true.</a:t>
             </a:r>
-            <a:endParaRPr lang="en-US" dirty="0"/>
           </a:p>
         </p:txBody>
       </p:sp>
@@ -610,7 +385,6 @@
               <a:rPr lang="en-US" dirty="0"/>
               <a:t>One minute. The thread: every system on the right put a model's output in front of people making live decisions, and the hard part was never the model, it was earning trust in what it said. FedCast is that problem made explicit and measurable.</a:t>
             </a:r>
-            <a:endParaRPr lang="en-US" dirty="0"/>
           </a:p>
         </p:txBody>
       </p:sp>
@@ -698,7 +472,6 @@
               <a:rPr lang="en-US" dirty="0"/>
               <a:t>Left: what it is, in one line, the diagram, and four things it does. Right: the three reasons we built it. Spend the time on the right-hand side; the diagram is there so the room can see the four families and that code, not a model, combines them.</a:t>
             </a:r>
-            <a:endParaRPr lang="en-US" dirty="0"/>
           </a:p>
         </p:txBody>
       </p:sp>
@@ -776,6 +549,7 @@
         <a:solidFill>
           <a:srgbClr val="1E2761"/>
         </a:solidFill>
+        <a:effectLst/>
       </p:bgPr>
     </p:bg>
     <p:spTree>
@@ -795,9 +569,11 @@
       <p:sp>
         <p:nvSpPr>
           <p:cNvPr id="2" name="Text 0"/>
-          <p:cNvSpPr/>
+          <p:cNvSpPr>
+            <a:spLocks noGrp="1"/>
+          </p:cNvSpPr>
           <p:nvPr>
-            <p:ph idx="100" type="title" hasCustomPrompt="1"/>
+            <p:ph type="title" idx="100" hasCustomPrompt="1"/>
           </p:nvPr>
         </p:nvSpPr>
         <p:spPr>
@@ -814,7 +590,7 @@
         <p:txBody>
           <a:bodyPr wrap="square" rtlCol="0"/>
           <a:lstStyle>
-            <a:lvl1pPr algn="l" indent="0" marL="0">
+            <a:lvl1pPr marL="0" indent="0" algn="l">
               <a:buNone/>
               <a:defRPr lang="en-US" sz="4000" b="1" dirty="0">
                 <a:solidFill>
@@ -824,7 +600,7 @@
             </a:lvl1pPr>
           </a:lstStyle>
           <a:p>
-            <a:pPr algn="l" indent="0" marL="0">
+            <a:pPr marL="0" indent="0" algn="l">
               <a:buNone/>
             </a:pPr>
             <a:endParaRPr lang="en-US" sz="4000" dirty="0"/>
@@ -834,9 +610,11 @@
       <p:sp>
         <p:nvSpPr>
           <p:cNvPr id="3" name="Text 0"/>
-          <p:cNvSpPr/>
+          <p:cNvSpPr>
+            <a:spLocks noGrp="1"/>
+          </p:cNvSpPr>
           <p:nvPr>
-            <p:ph idx="101" type="body" hasCustomPrompt="1"/>
+            <p:ph type="body" idx="101" hasCustomPrompt="1"/>
           </p:nvPr>
         </p:nvSpPr>
         <p:spPr>
@@ -853,7 +631,7 @@
         <p:txBody>
           <a:bodyPr wrap="square" rtlCol="0"/>
           <a:lstStyle>
-            <a:lvl1pPr algn="l" indent="0" marL="0">
+            <a:lvl1pPr marL="0" indent="0" algn="l">
               <a:buNone/>
               <a:defRPr lang="en-US" sz="2000" dirty="0">
                 <a:solidFill>
@@ -863,7 +641,7 @@
             </a:lvl1pPr>
           </a:lstStyle>
           <a:p>
-            <a:pPr algn="l" indent="0" marL="0">
+            <a:pPr marL="0" indent="0" algn="l">
               <a:buNone/>
             </a:pPr>
             <a:endParaRPr lang="en-US" sz="2000" dirty="0"/>
@@ -886,6 +664,7 @@
         <a:solidFill>
           <a:srgbClr val="FFFFFF"/>
         </a:solidFill>
+        <a:effectLst/>
       </p:bgPr>
     </p:bg>
     <p:spTree>
@@ -905,9 +684,11 @@
       <p:sp>
         <p:nvSpPr>
           <p:cNvPr id="2" name="Text 0"/>
-          <p:cNvSpPr/>
+          <p:cNvSpPr>
+            <a:spLocks noGrp="1"/>
+          </p:cNvSpPr>
           <p:nvPr>
-            <p:ph idx="100" type="title" hasCustomPrompt="1"/>
+            <p:ph type="title" idx="100" hasCustomPrompt="1"/>
           </p:nvPr>
         </p:nvSpPr>
         <p:spPr>
@@ -924,7 +705,7 @@
         <p:txBody>
           <a:bodyPr wrap="square" rtlCol="0"/>
           <a:lstStyle>
-            <a:lvl1pPr algn="l" indent="0" marL="0">
+            <a:lvl1pPr marL="0" indent="0" algn="l">
               <a:buNone/>
               <a:defRPr lang="en-US" sz="3200" b="1" dirty="0">
                 <a:solidFill>
@@ -934,7 +715,7 @@
             </a:lvl1pPr>
           </a:lstStyle>
           <a:p>
-            <a:pPr algn="l" indent="0" marL="0">
+            <a:pPr marL="0" indent="0" algn="l">
               <a:buNone/>
             </a:pPr>
             <a:endParaRPr lang="en-US" sz="3200" dirty="0"/>
@@ -962,7 +743,7 @@
           <a:bodyPr wrap="square" lIns="0" tIns="0" rIns="0" bIns="0" rtlCol="0" anchor="ctr"/>
           <a:lstStyle/>
           <a:p>
-            <a:pPr indent="0" marL="0">
+            <a:pPr marL="0" indent="0">
               <a:buNone/>
             </a:pPr>
             <a:r>
@@ -997,7 +778,7 @@
           </a:prstGeom>
           <a:extLst>
             <a:ext uri="{C572A759-6A51-4108-AA02-DFA0A04FC94B}">
-              <ma14:wrappingTextBoxFlag xmlns:ma14="http://schemas.microsoft.com/office/mac/drawingml/2011/main" val="0"/>
+              <ma14:wrappingTextBoxFlag xmlns:ma14="http://schemas.microsoft.com/office/mac/drawingml/2011/main" xmlns="" val="0"/>
             </a:ext>
           </a:extLst>
         </p:spPr>
@@ -1015,8 +796,8 @@
           <a:p>
             <a:pPr algn="r"/>
             <a:fld id="{F7021451-1387-4CA6-816F-3879F97B5CBC}" type="slidenum">
-              <a:rPr b="0" lang="en-US"/>
-              <a:t>1003</a:t>
+              <a:rPr lang="en-US" b="0"/>
+              <a:t>‹#›</a:t>
             </a:fld>
             <a:endParaRPr lang="en-US"/>
           </a:p>
@@ -1033,6 +814,11 @@
 <file path=ppt/slideMasters/slideMaster1.xml><?xml version="1.0" encoding="utf-8"?>
 <p:sldMaster xmlns:a="http://schemas.openxmlformats.org/drawingml/2006/main" xmlns:r="http://schemas.openxmlformats.org/officeDocument/2006/relationships" xmlns:p="http://schemas.openxmlformats.org/presentationml/2006/main">
   <p:cSld>
+    <p:bg>
+      <p:bgRef idx="1001">
+        <a:schemeClr val="bg1"/>
+      </p:bgRef>
+    </p:bg>
     <p:spTree>
       <p:nvGrpSpPr>
         <p:cNvPr id="1" name=""/>
@@ -1067,7 +853,7 @@
           </a:prstGeom>
           <a:extLst>
             <a:ext uri="{C572A759-6A51-4108-AA02-DFA0A04FC94B}">
-              <ma14:wrappingTextBoxFlag xmlns:ma14="http://schemas.microsoft.com/office/mac/drawingml/2011/main" val="0"/>
+              <ma14:wrappingTextBoxFlag xmlns:ma14="http://schemas.microsoft.com/office/mac/drawingml/2011/main" xmlns="" val="0"/>
             </a:ext>
           </a:extLst>
         </p:spPr>
@@ -1085,8 +871,8 @@
           <a:p>
             <a:pPr algn="r"/>
             <a:fld id="{F7021451-1387-4CA6-816F-3879F97B5CBC}" type="slidenum">
-              <a:rPr b="0" lang="en-US"/>
-              <a:t>null</a:t>
+              <a:rPr lang="en-US" b="0"/>
+              <a:t>‹#›</a:t>
             </a:fld>
             <a:endParaRPr lang="en-US"/>
           </a:p>
@@ -1374,9 +1160,11 @@
       <p:sp>
         <p:nvSpPr>
           <p:cNvPr id="2" name="Text 0"/>
-          <p:cNvSpPr/>
+          <p:cNvSpPr>
+            <a:spLocks noGrp="1"/>
+          </p:cNvSpPr>
           <p:nvPr>
-            <p:ph idx="100" type="title" hasCustomPrompt="1"/>
+            <p:ph type="title" idx="100" hasCustomPrompt="1"/>
           </p:nvPr>
         </p:nvSpPr>
         <p:spPr>
@@ -1394,7 +1182,7 @@
           <a:bodyPr wrap="square" lIns="0" tIns="0" rIns="0" bIns="0" rtlCol="0" anchor="b"/>
           <a:lstStyle/>
           <a:p>
-            <a:pPr algn="l" indent="0" marL="0">
+            <a:pPr marL="0" indent="0" algn="l">
               <a:buNone/>
             </a:pPr>
             <a:r>
@@ -1412,9 +1200,11 @@
       <p:sp>
         <p:nvSpPr>
           <p:cNvPr id="3" name="Text 0"/>
-          <p:cNvSpPr/>
+          <p:cNvSpPr>
+            <a:spLocks noGrp="1"/>
+          </p:cNvSpPr>
           <p:nvPr>
-            <p:ph idx="101" type="body" hasCustomPrompt="1"/>
+            <p:ph type="body" idx="101" hasCustomPrompt="1"/>
           </p:nvPr>
         </p:nvSpPr>
         <p:spPr>
@@ -1432,7 +1222,7 @@
           <a:bodyPr wrap="square" lIns="0" tIns="0" rIns="0" bIns="0" rtlCol="0" anchor="t"/>
           <a:lstStyle/>
           <a:p>
-            <a:pPr algn="l" indent="0" marL="0">
+            <a:pPr marL="0" indent="0" algn="l">
               <a:buNone/>
             </a:pPr>
             <a:r>
@@ -1468,7 +1258,7 @@
           <a:bodyPr wrap="square" lIns="0" tIns="0" rIns="0" bIns="0" rtlCol="0" anchor="t"/>
           <a:lstStyle/>
           <a:p>
-            <a:pPr indent="0" marL="0">
+            <a:pPr marL="0" indent="0">
               <a:buNone/>
             </a:pPr>
             <a:r>
@@ -1511,9 +1301,11 @@
       <p:sp>
         <p:nvSpPr>
           <p:cNvPr id="2" name="Text 0"/>
-          <p:cNvSpPr/>
+          <p:cNvSpPr>
+            <a:spLocks noGrp="1"/>
+          </p:cNvSpPr>
           <p:nvPr>
-            <p:ph idx="100" type="title" hasCustomPrompt="1"/>
+            <p:ph type="title" idx="100" hasCustomPrompt="1"/>
           </p:nvPr>
         </p:nvSpPr>
         <p:spPr>
@@ -1531,7 +1323,7 @@
           <a:bodyPr wrap="square" lIns="0" tIns="0" rIns="0" bIns="0" rtlCol="0" anchor="ctr"/>
           <a:lstStyle/>
           <a:p>
-            <a:pPr algn="l" indent="0" marL="0">
+            <a:pPr marL="0" indent="0" algn="l">
               <a:buNone/>
             </a:pPr>
             <a:r>
@@ -1572,7 +1364,7 @@
             <a:prstDash val="solid"/>
           </a:ln>
           <a:effectLst>
-            <a:outerShdw sx="100000" sy="100000" kx="0" ky="0" algn="bl" rotWithShape="0" blurRad="50800" dist="12700" dir="5400000">
+            <a:outerShdw blurRad="50800" dist="12700" dir="5400000" algn="bl" rotWithShape="0">
               <a:srgbClr val="000000">
                 <a:alpha val="8000"/>
               </a:srgbClr>
@@ -1601,7 +1393,7 @@
           <a:bodyPr wrap="square" lIns="0" tIns="0" rIns="0" bIns="0" rtlCol="0" anchor="t"/>
           <a:lstStyle/>
           <a:p>
-            <a:pPr indent="0" marL="0">
+            <a:pPr marL="0" indent="0">
               <a:buNone/>
             </a:pPr>
             <a:r>
@@ -1640,7 +1432,7 @@
           <a:bodyPr wrap="square" lIns="0" tIns="0" rIns="0" bIns="0" rtlCol="0" anchor="t"/>
           <a:lstStyle/>
           <a:p>
-            <a:pPr indent="0" marL="0">
+            <a:pPr marL="0" indent="0">
               <a:buNone/>
             </a:pPr>
             <a:r>
@@ -1676,7 +1468,7 @@
           <a:bodyPr wrap="square" lIns="0" tIns="0" rIns="0" bIns="0" rtlCol="0" anchor="t"/>
           <a:lstStyle/>
           <a:p>
-            <a:pPr indent="0" marL="0">
+            <a:pPr marL="0" indent="0">
               <a:buNone/>
             </a:pPr>
             <a:r>
@@ -1770,7 +1562,7 @@
           <a:bodyPr wrap="square" lIns="0" tIns="0" rIns="0" bIns="0" rtlCol="0" anchor="t"/>
           <a:lstStyle/>
           <a:p>
-            <a:pPr indent="0" marL="0">
+            <a:pPr marL="0" indent="0">
               <a:buNone/>
             </a:pPr>
             <a:r>
@@ -1806,7 +1598,7 @@
           <a:bodyPr wrap="square" lIns="0" tIns="0" rIns="0" bIns="0" rtlCol="0" anchor="t"/>
           <a:lstStyle/>
           <a:p>
-            <a:pPr indent="0" marL="0">
+            <a:pPr marL="0" indent="0">
               <a:buNone/>
             </a:pPr>
             <a:r>
@@ -1842,7 +1634,7 @@
           <a:bodyPr wrap="square" lIns="0" tIns="0" rIns="0" bIns="0" rtlCol="0" anchor="t"/>
           <a:lstStyle/>
           <a:p>
-            <a:pPr indent="0" marL="0">
+            <a:pPr marL="0" indent="0">
               <a:buNone/>
             </a:pPr>
             <a:r>
@@ -1903,7 +1695,7 @@
           <a:bodyPr wrap="square" lIns="0" tIns="0" rIns="0" bIns="0" rtlCol="0" anchor="ctr"/>
           <a:lstStyle/>
           <a:p>
-            <a:pPr algn="ctr" indent="0" marL="0">
+            <a:pPr marL="0" indent="0" algn="ctr">
               <a:buNone/>
             </a:pPr>
             <a:r>
@@ -1939,7 +1731,7 @@
           <a:bodyPr wrap="square" lIns="0" tIns="0" rIns="0" bIns="0" rtlCol="0" anchor="t"/>
           <a:lstStyle/>
           <a:p>
-            <a:pPr indent="0" marL="0">
+            <a:pPr marL="0" indent="0">
               <a:buNone/>
             </a:pPr>
             <a:r>
@@ -1975,7 +1767,7 @@
           <a:bodyPr wrap="square" lIns="0" tIns="0" rIns="0" bIns="0" rtlCol="0" anchor="t"/>
           <a:lstStyle/>
           <a:p>
-            <a:pPr indent="0" marL="0">
+            <a:pPr marL="0" indent="0">
               <a:buNone/>
             </a:pPr>
             <a:r>
@@ -2036,7 +1828,7 @@
           <a:bodyPr wrap="square" lIns="0" tIns="0" rIns="0" bIns="0" rtlCol="0" anchor="ctr"/>
           <a:lstStyle/>
           <a:p>
-            <a:pPr algn="ctr" indent="0" marL="0">
+            <a:pPr marL="0" indent="0" algn="ctr">
               <a:buNone/>
             </a:pPr>
             <a:r>
@@ -2072,7 +1864,7 @@
           <a:bodyPr wrap="square" lIns="0" tIns="0" rIns="0" bIns="0" rtlCol="0" anchor="t"/>
           <a:lstStyle/>
           <a:p>
-            <a:pPr indent="0" marL="0">
+            <a:pPr marL="0" indent="0">
               <a:buNone/>
             </a:pPr>
             <a:r>
@@ -2108,7 +1900,7 @@
           <a:bodyPr wrap="square" lIns="0" tIns="0" rIns="0" bIns="0" rtlCol="0" anchor="t"/>
           <a:lstStyle/>
           <a:p>
-            <a:pPr indent="0" marL="0">
+            <a:pPr marL="0" indent="0">
               <a:buNone/>
             </a:pPr>
             <a:r>
@@ -2169,7 +1961,7 @@
           <a:bodyPr wrap="square" lIns="0" tIns="0" rIns="0" bIns="0" rtlCol="0" anchor="ctr"/>
           <a:lstStyle/>
           <a:p>
-            <a:pPr algn="ctr" indent="0" marL="0">
+            <a:pPr marL="0" indent="0" algn="ctr">
               <a:buNone/>
             </a:pPr>
             <a:r>
@@ -2205,7 +1997,7 @@
           <a:bodyPr wrap="square" lIns="0" tIns="0" rIns="0" bIns="0" rtlCol="0" anchor="t"/>
           <a:lstStyle/>
           <a:p>
-            <a:pPr indent="0" marL="0">
+            <a:pPr marL="0" indent="0">
               <a:buNone/>
             </a:pPr>
             <a:r>
@@ -2241,7 +2033,7 @@
           <a:bodyPr wrap="square" lIns="0" tIns="0" rIns="0" bIns="0" rtlCol="0" anchor="t"/>
           <a:lstStyle/>
           <a:p>
-            <a:pPr indent="0" marL="0">
+            <a:pPr marL="0" indent="0">
               <a:buNone/>
             </a:pPr>
             <a:r>
@@ -2302,7 +2094,7 @@
           <a:bodyPr wrap="square" lIns="0" tIns="0" rIns="0" bIns="0" rtlCol="0" anchor="ctr"/>
           <a:lstStyle/>
           <a:p>
-            <a:pPr algn="ctr" indent="0" marL="0">
+            <a:pPr marL="0" indent="0" algn="ctr">
               <a:buNone/>
             </a:pPr>
             <a:r>
@@ -2338,7 +2130,7 @@
           <a:bodyPr wrap="square" lIns="0" tIns="0" rIns="0" bIns="0" rtlCol="0" anchor="t"/>
           <a:lstStyle/>
           <a:p>
-            <a:pPr indent="0" marL="0">
+            <a:pPr marL="0" indent="0">
               <a:buNone/>
             </a:pPr>
             <a:r>
@@ -2374,7 +2166,7 @@
           <a:bodyPr wrap="square" lIns="0" tIns="0" rIns="0" bIns="0" rtlCol="0" anchor="t"/>
           <a:lstStyle/>
           <a:p>
-            <a:pPr indent="0" marL="0">
+            <a:pPr marL="0" indent="0">
               <a:buNone/>
             </a:pPr>
             <a:r>
@@ -2391,7 +2183,7 @@
       </p:sp>
       <p:sp>
         <p:nvSpPr>
-          <p:cNvPr id="25" name="Slide Number Placeholder 0"/>
+          <p:cNvPr id="3" name="Slide Number Placeholder 0"/>
           <p:cNvSpPr>
             <a:spLocks noGrp="1"/>
           </p:cNvSpPr>
@@ -2409,7 +2201,7 @@
           </a:prstGeom>
           <a:extLst>
             <a:ext uri="{C572A759-6A51-4108-AA02-DFA0A04FC94B}">
-              <ma14:wrappingTextBoxFlag xmlns:ma14="http://schemas.microsoft.com/office/mac/drawingml/2011/main" val="0"/>
+              <ma14:wrappingTextBoxFlag xmlns:ma14="http://schemas.microsoft.com/office/mac/drawingml/2011/main" xmlns="" val="0"/>
             </a:ext>
           </a:extLst>
         </p:spPr>
@@ -2427,13 +2219,43 @@
           <a:p>
             <a:pPr algn="r"/>
             <a:fld id="{F7021451-1387-4CA6-816F-3879F97B5CBC}" type="slidenum">
-              <a:rPr b="0" lang="en-US"/>
+              <a:rPr lang="en-US" b="0"/>
               <a:t>2</a:t>
             </a:fld>
             <a:endParaRPr lang="en-US"/>
           </a:p>
         </p:txBody>
       </p:sp>
+      <p:pic>
+        <p:nvPicPr>
+          <p:cNvPr id="28" name="Picture 27">
+            <a:extLst>
+              <a:ext uri="{FF2B5EF4-FFF2-40B4-BE49-F238E27FC236}">
+                <a16:creationId xmlns:a16="http://schemas.microsoft.com/office/drawing/2014/main" id="{4CEC26B7-4B44-7817-CE81-1D48CC958ABA}"/>
+              </a:ext>
+            </a:extLst>
+          </p:cNvPr>
+          <p:cNvPicPr>
+            <a:picLocks noChangeAspect="1"/>
+          </p:cNvPicPr>
+          <p:nvPr/>
+        </p:nvPicPr>
+        <p:blipFill>
+          <a:blip r:embed="rId3"/>
+          <a:stretch>
+            <a:fillRect/>
+          </a:stretch>
+        </p:blipFill>
+        <p:spPr>
+          <a:xfrm>
+            <a:off x="10307618" y="277682"/>
+            <a:ext cx="1232199" cy="1232199"/>
+          </a:xfrm>
+          <a:prstGeom prst="rect">
+            <a:avLst/>
+          </a:prstGeom>
+        </p:spPr>
+      </p:pic>
     </p:spTree>
   </p:cSld>
   <p:clrMapOvr>
@@ -2462,9 +2284,11 @@
       <p:sp>
         <p:nvSpPr>
           <p:cNvPr id="2" name="Text 0"/>
-          <p:cNvSpPr/>
+          <p:cNvSpPr>
+            <a:spLocks noGrp="1"/>
+          </p:cNvSpPr>
           <p:nvPr>
-            <p:ph idx="100" type="title" hasCustomPrompt="1"/>
+            <p:ph type="title" idx="100" hasCustomPrompt="1"/>
           </p:nvPr>
         </p:nvSpPr>
         <p:spPr>
@@ -2482,7 +2306,7 @@
           <a:bodyPr wrap="square" lIns="0" tIns="0" rIns="0" bIns="0" rtlCol="0" anchor="ctr"/>
           <a:lstStyle/>
           <a:p>
-            <a:pPr algn="l" indent="0" marL="0">
+            <a:pPr marL="0" indent="0" algn="l">
               <a:buNone/>
             </a:pPr>
             <a:r>
@@ -2518,7 +2342,7 @@
           <a:bodyPr wrap="square" lIns="0" tIns="0" rIns="0" bIns="0" rtlCol="0" anchor="t"/>
           <a:lstStyle/>
           <a:p>
-            <a:pPr indent="0" marL="0">
+            <a:pPr marL="0" indent="0">
               <a:buNone/>
             </a:pPr>
             <a:r>
@@ -2527,7 +2351,24 @@
                   <a:schemeClr val="tx1"/>
                 </a:solidFill>
               </a:rPr>
-              <a:t>A forecast of the next FOMC decision as probabilities over five outcomes, from one frozen snapshot of evidence. Today, for 28 October 2026: no change 71%, +25 bps 23%.</a:t>
+              <a:t>A forecast of the next FOMC decision as probabilities over five outcomes, from one frozen snapshot of evidence. </a:t>
+            </a:r>
+          </a:p>
+          <a:p>
+            <a:pPr marL="0" indent="0">
+              <a:buNone/>
+            </a:pPr>
+            <a:r>
+              <a:rPr lang="en-US" sz="1350" dirty="0"/>
+              <a:t>As of 27 October, for </a:t>
+            </a:r>
+            <a:r>
+              <a:rPr lang="en-US" sz="1350" dirty="0">
+                <a:solidFill>
+                  <a:schemeClr val="tx1"/>
+                </a:solidFill>
+              </a:rPr>
+              <a:t>28 October 2026: no change 71%, +25 bps 23%.</a:t>
             </a:r>
             <a:endParaRPr lang="en-US" sz="1350" dirty="0"/>
           </a:p>
@@ -2581,7 +2422,7 @@
           <a:bodyPr wrap="square" lIns="0" tIns="0" rIns="0" bIns="0" rtlCol="0" anchor="t"/>
           <a:lstStyle/>
           <a:p>
-            <a:pPr indent="0" marL="0">
+            <a:pPr marL="0" indent="0">
               <a:buNone/>
             </a:pPr>
             <a:r>
@@ -2617,7 +2458,7 @@
           <a:bodyPr wrap="square" lIns="0" tIns="0" rIns="0" bIns="0" rtlCol="0" anchor="t"/>
           <a:lstStyle/>
           <a:p>
-            <a:pPr indent="0" marL="0">
+            <a:pPr marL="0" indent="0">
               <a:buNone/>
             </a:pPr>
             <a:r>
@@ -2626,7 +2467,7 @@
                   <a:schemeClr val="bg1"/>
                 </a:solidFill>
               </a:rPr>
-              <a:t>Fed funds futures, the Fed's own Taylor rules, prediction-market odds</a:t>
+              <a:t>Fed funds futures, the Fed's own Taylor rules, Polymarket odds</a:t>
             </a:r>
             <a:endParaRPr lang="en-US" sz="850" dirty="0"/>
           </a:p>
@@ -2704,7 +2545,7 @@
           <a:bodyPr wrap="square" lIns="0" tIns="0" rIns="0" bIns="0" rtlCol="0" anchor="t"/>
           <a:lstStyle/>
           <a:p>
-            <a:pPr indent="0" marL="0">
+            <a:pPr marL="0" indent="0">
               <a:buNone/>
             </a:pPr>
             <a:r>
@@ -2740,7 +2581,7 @@
           <a:bodyPr wrap="square" lIns="0" tIns="0" rIns="0" bIns="0" rtlCol="0" anchor="t"/>
           <a:lstStyle/>
           <a:p>
-            <a:pPr indent="0" marL="0">
+            <a:pPr marL="0" indent="0">
               <a:buNone/>
             </a:pPr>
             <a:r>
@@ -2750,6 +2591,22 @@
                 </a:solidFill>
               </a:rPr>
               <a:t>What followed each kind of decision over 32 years of FOMC history</a:t>
+            </a:r>
+            <a:r>
+              <a:rPr lang="en-US" sz="850" dirty="0" err="1">
+                <a:solidFill>
+                  <a:schemeClr val="bg1"/>
+                </a:solidFill>
+              </a:rPr>
+              <a:t/>
+            </a:r>
+            <a:r>
+              <a:rPr lang="en-US" sz="850" dirty="0">
+                <a:solidFill>
+                  <a:schemeClr val="bg1"/>
+                </a:solidFill>
+              </a:rPr>
+              <a:t/>
             </a:r>
             <a:endParaRPr lang="en-US" sz="850" dirty="0"/>
           </a:p>
@@ -2827,7 +2684,7 @@
           <a:bodyPr wrap="square" lIns="0" tIns="0" rIns="0" bIns="0" rtlCol="0" anchor="t"/>
           <a:lstStyle/>
           <a:p>
-            <a:pPr indent="0" marL="0">
+            <a:pPr marL="0" indent="0">
               <a:buNone/>
             </a:pPr>
             <a:r>
@@ -2863,7 +2720,7 @@
           <a:bodyPr wrap="square" lIns="0" tIns="0" rIns="0" bIns="0" rtlCol="0" anchor="t"/>
           <a:lstStyle/>
           <a:p>
-            <a:pPr indent="0" marL="0">
+            <a:pPr marL="0" indent="0">
               <a:buNone/>
             </a:pPr>
             <a:r>
@@ -2950,7 +2807,7 @@
           <a:bodyPr wrap="square" lIns="0" tIns="0" rIns="0" bIns="0" rtlCol="0" anchor="t"/>
           <a:lstStyle/>
           <a:p>
-            <a:pPr indent="0" marL="0">
+            <a:pPr marL="0" indent="0">
               <a:buNone/>
             </a:pPr>
             <a:r>
@@ -2986,7 +2843,7 @@
           <a:bodyPr wrap="square" lIns="0" tIns="0" rIns="0" bIns="0" rtlCol="0" anchor="t"/>
           <a:lstStyle/>
           <a:p>
-            <a:pPr indent="0" marL="0">
+            <a:pPr marL="0" indent="0">
               <a:buNone/>
             </a:pPr>
             <a:r>
@@ -3073,7 +2930,7 @@
           <a:bodyPr wrap="square" lIns="0" tIns="0" rIns="0" bIns="0" rtlCol="0" anchor="t"/>
           <a:lstStyle/>
           <a:p>
-            <a:pPr algn="ctr" indent="0" marL="0">
+            <a:pPr marL="0" indent="0" algn="ctr">
               <a:buNone/>
             </a:pPr>
             <a:r>
@@ -3109,7 +2966,7 @@
           <a:bodyPr wrap="square" lIns="0" tIns="0" rIns="0" bIns="0" rtlCol="0" anchor="t"/>
           <a:lstStyle/>
           <a:p>
-            <a:pPr algn="ctr" indent="0" marL="0">
+            <a:pPr marL="0" indent="0" algn="ctr">
               <a:buNone/>
             </a:pPr>
             <a:r>
@@ -3196,7 +3053,7 @@
           <a:bodyPr wrap="square" lIns="0" tIns="0" rIns="0" bIns="0" rtlCol="0" anchor="t"/>
           <a:lstStyle/>
           <a:p>
-            <a:pPr algn="ctr" indent="0" marL="0">
+            <a:pPr marL="0" indent="0" algn="ctr">
               <a:buNone/>
             </a:pPr>
             <a:r>
@@ -3205,7 +3062,7 @@
                   <a:schemeClr val="bg1"/>
                 </a:solidFill>
               </a:rPr>
-              <a:t>Forecast</a:t>
+              <a:t>Forecast, as of 27 October</a:t>
             </a:r>
             <a:endParaRPr lang="en-US" sz="1300" dirty="0"/>
           </a:p>
@@ -3232,7 +3089,7 @@
           <a:bodyPr wrap="square" lIns="0" tIns="0" rIns="0" bIns="0" rtlCol="0" anchor="t"/>
           <a:lstStyle/>
           <a:p>
-            <a:pPr algn="ctr" indent="0" marL="0">
+            <a:pPr marL="0" indent="0" algn="ctr">
               <a:buNone/>
             </a:pPr>
             <a:r>
@@ -3246,7 +3103,7 @@
             <a:endParaRPr lang="en-US" sz="1050" dirty="0"/>
           </a:p>
           <a:p>
-            <a:pPr algn="ctr" indent="0" marL="0">
+            <a:pPr marL="0" indent="0" algn="ctr">
               <a:buNone/>
             </a:pPr>
             <a:r>
@@ -3282,7 +3139,7 @@
           <a:bodyPr wrap="square" lIns="0" tIns="0" rIns="0" bIns="0" rtlCol="0" anchor="t"/>
           <a:lstStyle/>
           <a:p>
-            <a:pPr indent="0" marL="0">
+            <a:pPr marL="0" indent="0">
               <a:buNone/>
             </a:pPr>
             <a:r>
@@ -3349,7 +3206,7 @@
                   <a:schemeClr val="tx1"/>
                 </a:solidFill>
               </a:rPr>
-              <a:t>Enforces repeatability: five identical runs per analyst, tools off, every quote checked by code, a pre-registered scorecard on every snapshot.</a:t>
+              <a:t>Enforces repeatability: five identical runs per analyst, tools off, every quote/output checked by code, a pre-registered scorecard on every snapshot.</a:t>
             </a:r>
             <a:endParaRPr lang="en-US" sz="950" dirty="0"/>
           </a:p>
@@ -3412,7 +3269,7 @@
           <a:bodyPr wrap="square" lIns="0" tIns="0" rIns="0" bIns="0" rtlCol="0" anchor="t"/>
           <a:lstStyle/>
           <a:p>
-            <a:pPr indent="0" marL="0">
+            <a:pPr marL="0" indent="0">
               <a:buNone/>
             </a:pPr>
             <a:r>
@@ -3473,7 +3330,7 @@
           <a:bodyPr wrap="square" lIns="0" tIns="0" rIns="0" bIns="0" rtlCol="0" anchor="ctr"/>
           <a:lstStyle/>
           <a:p>
-            <a:pPr algn="ctr" indent="0" marL="0">
+            <a:pPr marL="0" indent="0" algn="ctr">
               <a:buNone/>
             </a:pPr>
             <a:r>
@@ -3509,7 +3366,7 @@
           <a:bodyPr wrap="square" lIns="0" tIns="0" rIns="0" bIns="0" rtlCol="0" anchor="t"/>
           <a:lstStyle/>
           <a:p>
-            <a:pPr indent="0" marL="0">
+            <a:pPr marL="0" indent="0">
               <a:buNone/>
             </a:pPr>
             <a:r>
@@ -3545,16 +3402,34 @@
           <a:bodyPr wrap="square" lIns="0" tIns="0" rIns="0" bIns="0" rtlCol="0" anchor="t"/>
           <a:lstStyle/>
           <a:p>
-            <a:pPr indent="0" marL="0">
-              <a:buNone/>
-            </a:pPr>
             <a:r>
               <a:rPr lang="en-US" sz="950" dirty="0">
                 <a:solidFill>
                   <a:schemeClr val="tx1"/>
                 </a:solidFill>
               </a:rPr>
-              <a:t>There are many of them. Eight decisions a year make a hit rate neither predictable nor repeatable as a measure of a tool. We judge ours on a pre-registered process: is the same answer produced from the same evidence, can every claim be traced, does a shock move the number the right way.</a:t>
+              <a:t>Many Fed tools exist. With only eight decisions a year, </a:t>
+            </a:r>
+            <a:r>
+              <a:rPr lang="en-US" sz="950" dirty="0"/>
+              <a:t>a hit rate cannot separate luck from skill, and next year is a different draw. </a:t>
+            </a:r>
+            <a:r>
+              <a:rPr lang="en-US" sz="950" b="1" dirty="0"/>
+              <a:t>We believe a robust process requires repeatability.</a:t>
+            </a:r>
+          </a:p>
+          <a:p>
+            <a:pPr marL="0" indent="0">
+              <a:buNone/>
+            </a:pPr>
+            <a:r>
+              <a:rPr lang="en-US" sz="950" dirty="0">
+                <a:solidFill>
+                  <a:schemeClr val="tx1"/>
+                </a:solidFill>
+              </a:rPr>
+              <a:t>So we judge ours on a pre-registered process: does the same evidence give the same answer, can every claim be traced, does a shock move the number the right way.</a:t>
             </a:r>
             <a:endParaRPr lang="en-US" sz="950" dirty="0"/>
           </a:p>
@@ -3606,7 +3481,7 @@
           <a:bodyPr wrap="square" lIns="0" tIns="0" rIns="0" bIns="0" rtlCol="0" anchor="ctr"/>
           <a:lstStyle/>
           <a:p>
-            <a:pPr algn="ctr" indent="0" marL="0">
+            <a:pPr marL="0" indent="0" algn="ctr">
               <a:buNone/>
             </a:pPr>
             <a:r>
@@ -3642,7 +3517,7 @@
           <a:bodyPr wrap="square" lIns="0" tIns="0" rIns="0" bIns="0" rtlCol="0" anchor="t"/>
           <a:lstStyle/>
           <a:p>
-            <a:pPr indent="0" marL="0">
+            <a:pPr marL="0" indent="0">
               <a:buNone/>
             </a:pPr>
             <a:r>
@@ -3678,7 +3553,7 @@
           <a:bodyPr wrap="square" lIns="0" tIns="0" rIns="0" bIns="0" rtlCol="0" anchor="t"/>
           <a:lstStyle/>
           <a:p>
-            <a:pPr indent="0" marL="0">
+            <a:pPr marL="0" indent="0">
               <a:buNone/>
             </a:pPr>
             <a:r>
@@ -3687,7 +3562,55 @@
                   <a:schemeClr val="tx1"/>
                 </a:solidFill>
               </a:rPr>
-              <a:t>Either empirical formulas and market prices alone, or everything thrown at a language model. Ours harmonises the three: empirical data, classic ML and a harnessed LLM, each with a stated role and a stated weight, combined by code.</a:t>
+              <a:t>Either empirical formulas and market prices alone, or everything thrown at a language model. Ours combines the three: </a:t>
+            </a:r>
+            <a:r>
+              <a:rPr lang="en-US" sz="950" b="1" dirty="0">
+                <a:solidFill>
+                  <a:schemeClr val="tx1"/>
+                </a:solidFill>
+              </a:rPr>
+              <a:t>empirical data</a:t>
+            </a:r>
+            <a:r>
+              <a:rPr lang="en-US" sz="950" dirty="0">
+                <a:solidFill>
+                  <a:schemeClr val="tx1"/>
+                </a:solidFill>
+              </a:rPr>
+              <a:t>, </a:t>
+            </a:r>
+            <a:r>
+              <a:rPr lang="en-US" sz="950" b="1" dirty="0">
+                <a:solidFill>
+                  <a:schemeClr val="tx1"/>
+                </a:solidFill>
+              </a:rPr>
+              <a:t>classic ML</a:t>
+            </a:r>
+            <a:r>
+              <a:rPr lang="en-US" sz="950" dirty="0">
+                <a:solidFill>
+                  <a:schemeClr val="tx1"/>
+                </a:solidFill>
+              </a:rPr>
+              <a:t> and a </a:t>
+            </a:r>
+            <a:r>
+              <a:rPr lang="en-US" sz="950" b="1" dirty="0">
+                <a:solidFill>
+                  <a:schemeClr val="tx1"/>
+                </a:solidFill>
+              </a:rPr>
+              <a:t>harnessed LLM</a:t>
+            </a:r>
+            <a:r>
+              <a:rPr lang="en-US" sz="950" dirty="0">
+                <a:solidFill>
+                  <a:schemeClr val="tx1"/>
+                </a:solidFill>
+              </a:rPr>
+              <a:t>, each with a stated role and a stated weight, combined by code.</a:t>
             </a:r>
             <a:endParaRPr lang="en-US" sz="950" dirty="0"/>
           </a:p>
@@ -3739,7 +3662,7 @@
           <a:bodyPr wrap="square" lIns="0" tIns="0" rIns="0" bIns="0" rtlCol="0" anchor="ctr"/>
           <a:lstStyle/>
           <a:p>
-            <a:pPr algn="ctr" indent="0" marL="0">
+            <a:pPr marL="0" indent="0" algn="ctr">
               <a:buNone/>
             </a:pPr>
             <a:r>
@@ -3775,7 +3698,7 @@
           <a:bodyPr wrap="square" lIns="0" tIns="0" rIns="0" bIns="0" rtlCol="0" anchor="t"/>
           <a:lstStyle/>
           <a:p>
-            <a:pPr indent="0" marL="0">
+            <a:pPr marL="0" indent="0">
               <a:buNone/>
             </a:pPr>
             <a:r>
@@ -3784,7 +3707,7 @@
                   <a:schemeClr val="tx2"/>
                 </a:solidFill>
               </a:rPr>
-              <a:t>What that buys</a:t>
+              <a:t>What this model offers</a:t>
             </a:r>
             <a:endParaRPr lang="en-US" sz="1200" dirty="0"/>
           </a:p>
@@ -3798,8 +3721,8 @@
         </p:nvSpPr>
         <p:spPr>
           <a:xfrm>
-            <a:off x="7818120" y="5413248"/>
-            <a:ext cx="3822192" cy="960120"/>
+            <a:off x="7818119" y="5413248"/>
+            <a:ext cx="3934609" cy="960120"/>
           </a:xfrm>
           <a:prstGeom prst="rect">
             <a:avLst/>
@@ -3811,16 +3734,70 @@
           <a:bodyPr wrap="square" lIns="0" tIns="0" rIns="0" bIns="0" rtlCol="0" anchor="t"/>
           <a:lstStyle/>
           <a:p>
-            <a:pPr indent="0" marL="0">
-              <a:buNone/>
-            </a:pPr>
+            <a:pPr marL="0" indent="0">
+              <a:buNone/>
+            </a:pPr>
+            <a:r>
+              <a:rPr lang="en-US" sz="950" b="1" dirty="0">
+                <a:solidFill>
+                  <a:schemeClr val="tx1"/>
+                </a:solidFill>
+              </a:rPr>
+              <a:t>Auditability</a:t>
+            </a:r>
             <a:r>
               <a:rPr lang="en-US" sz="950" dirty="0">
                 <a:solidFill>
                   <a:schemeClr val="tx1"/>
                 </a:solidFill>
               </a:rPr>
-              <a:t>Auditability: every input visible, every forecast replayable. Evidence-based: every claim quoted and verified, nothing from memory. A harnessed LLM that cannot give random or spurious answers, and a naive LLM kept as the control that shows what the harness adds. Users can study how one piece of evidence moves the decision. The model can be scrutinised and improved, rather than hoping the LLM works.</a:t>
+              <a:t>: every input visible, every forecast replayable. </a:t>
+            </a:r>
+          </a:p>
+          <a:p>
+            <a:pPr marL="0" indent="0">
+              <a:buNone/>
+            </a:pPr>
+            <a:r>
+              <a:rPr lang="en-US" sz="950" b="1" dirty="0">
+                <a:solidFill>
+                  <a:schemeClr val="tx1"/>
+                </a:solidFill>
+              </a:rPr>
+              <a:t>Evidence-based</a:t>
+            </a:r>
+            <a:r>
+              <a:rPr lang="en-US" sz="950" dirty="0">
+                <a:solidFill>
+                  <a:schemeClr val="tx1"/>
+                </a:solidFill>
+              </a:rPr>
+              <a:t>: every claim quoted and verified, nothing from memory. A harnessed LLM cannot give random or spurious answers; a naive LLM is kept as the control, so what the harness adds is measured, not assumed. Anyone can see how one piece of evidence moves the decision. </a:t>
+            </a:r>
+          </a:p>
+          <a:p>
+            <a:pPr marL="0" indent="0">
+              <a:buNone/>
+            </a:pPr>
+            <a:r>
+              <a:rPr lang="en-US" sz="950" b="1" dirty="0" err="1"/>
+              <a:t>Backtest</a:t>
+            </a:r>
+            <a:r>
+              <a:rPr lang="en-US" sz="950" b="1" dirty="0"/>
+              <a:t>-able</a:t>
+            </a:r>
+            <a:r>
+              <a:rPr lang="en-US" sz="950" dirty="0"/>
+              <a:t>: </a:t>
+            </a:r>
+            <a:r>
+              <a:rPr lang="en-US" sz="950" dirty="0">
+                <a:solidFill>
+                  <a:schemeClr val="tx1"/>
+                </a:solidFill>
+              </a:rPr>
+              <a:t>the model can be scrutinised and improved, instead of hoping the LLM works.</a:t>
             </a:r>
             <a:endParaRPr lang="en-US" sz="950" dirty="0"/>
           </a:p>
@@ -3828,7 +3805,7 @@
       </p:sp>
       <p:sp>
         <p:nvSpPr>
-          <p:cNvPr id="25" name="Slide Number Placeholder 0"/>
+          <p:cNvPr id="3" name="Slide Number Placeholder 0"/>
           <p:cNvSpPr>
             <a:spLocks noGrp="1"/>
           </p:cNvSpPr>
@@ -3846,7 +3823,7 @@
           </a:prstGeom>
           <a:extLst>
             <a:ext uri="{C572A759-6A51-4108-AA02-DFA0A04FC94B}">
-              <ma14:wrappingTextBoxFlag xmlns:ma14="http://schemas.microsoft.com/office/mac/drawingml/2011/main" val="0"/>
+              <ma14:wrappingTextBoxFlag xmlns:ma14="http://schemas.microsoft.com/office/mac/drawingml/2011/main" xmlns="" val="0"/>
             </a:ext>
           </a:extLst>
         </p:spPr>
@@ -3864,7 +3841,7 @@
           <a:p>
             <a:pPr algn="r"/>
             <a:fld id="{F7021451-1387-4CA6-816F-3879F97B5CBC}" type="slidenum">
-              <a:rPr b="0" lang="en-US"/>
+              <a:rPr lang="en-US" b="0"/>
               <a:t>3</a:t>
             </a:fld>
             <a:endParaRPr lang="en-US"/>
@@ -4172,4 +4149,299 @@
     </a:ext>
   </a:extLst>
 </a:theme>
+</file>
+
+<file path=ppt/theme/theme2.xml><?xml version="1.0" encoding="utf-8"?>
+<a:theme xmlns:a="http://schemas.openxmlformats.org/drawingml/2006/main" name="Office Theme">
+  <a:themeElements>
+    <a:clrScheme name="Office">
+      <a:dk1>
+        <a:sysClr val="windowText" lastClr="000000"/>
+      </a:dk1>
+      <a:lt1>
+        <a:sysClr val="window" lastClr="FFFFFF"/>
+      </a:lt1>
+      <a:dk2>
+        <a:srgbClr val="44546A"/>
+      </a:dk2>
+      <a:lt2>
+        <a:srgbClr val="E7E6E6"/>
+      </a:lt2>
+      <a:accent1>
+        <a:srgbClr val="4472C4"/>
+      </a:accent1>
+      <a:accent2>
+        <a:srgbClr val="ED7D31"/>
+      </a:accent2>
+      <a:accent3>
+        <a:srgbClr val="A5A5A5"/>
+      </a:accent3>
+      <a:accent4>
+        <a:srgbClr val="FFC000"/>
+      </a:accent4>
+      <a:accent5>
+        <a:srgbClr val="5B9BD5"/>
+      </a:accent5>
+      <a:accent6>
+        <a:srgbClr val="70AD47"/>
+      </a:accent6>
+      <a:hlink>
+        <a:srgbClr val="0563C1"/>
+      </a:hlink>
+      <a:folHlink>
+        <a:srgbClr val="954F72"/>
+      </a:folHlink>
+    </a:clrScheme>
+    <a:fontScheme name="Office">
+      <a:majorFont>
+        <a:latin typeface="Calibri Light" panose="020F0302020204030204"/>
+        <a:ea typeface=""/>
+        <a:cs typeface=""/>
+        <a:font script="Jpan" typeface="游ゴシック Light"/>
+        <a:font script="Hang" typeface="맑은 고딕"/>
+        <a:font script="Hans" typeface="等线 Light"/>
+        <a:font script="Hant" typeface="新細明體"/>
+        <a:font script="Arab" typeface="Times New Roman"/>
+        <a:font script="Hebr" typeface="Times New Roman"/>
+        <a:font script="Thai" typeface="Angsana New"/>
+        <a:font script="Ethi" typeface="Nyala"/>
+        <a:font script="Beng" typeface="Vrinda"/>
+        <a:font script="Gujr" typeface="Shruti"/>
+        <a:font script="Khmr" typeface="MoolBoran"/>
+        <a:font script="Knda" typeface="Tunga"/>
+        <a:font script="Guru" typeface="Raavi"/>
+        <a:font script="Cans" typeface="Euphemia"/>
+        <a:font script="Cher" typeface="Plantagenet Cherokee"/>
+        <a:font script="Yiii" typeface="Microsoft Yi Baiti"/>
+        <a:font script="Tibt" typeface="Microsoft Himalaya"/>
+        <a:font script="Thaa" typeface="MV Boli"/>
+        <a:font script="Deva" typeface="Mangal"/>
+        <a:font script="Telu" typeface="Gautami"/>
+        <a:font script="Taml" typeface="Latha"/>
+        <a:font script="Syrc" typeface="Estrangelo Edessa"/>
+        <a:font script="Orya" typeface="Kalinga"/>
+        <a:font script="Mlym" typeface="Kartika"/>
+        <a:font script="Laoo" typeface="DokChampa"/>
+        <a:font script="Sinh" typeface="Iskoola Pota"/>
+        <a:font script="Mong" typeface="Mongolian Baiti"/>
+        <a:font script="Viet" typeface="Times New Roman"/>
+        <a:font script="Uigh" typeface="Microsoft Uighur"/>
+        <a:font script="Geor" typeface="Sylfaen"/>
+        <a:font script="Armn" typeface="Arial"/>
+        <a:font script="Bugi" typeface="Leelawadee UI"/>
+        <a:font script="Bopo" typeface="Microsoft JhengHei"/>
+        <a:font script="Java" typeface="Javanese Text"/>
+        <a:font script="Lisu" typeface="Segoe UI"/>
+        <a:font script="Mymr" typeface="Myanmar Text"/>
+        <a:font script="Nkoo" typeface="Ebrima"/>
+        <a:font script="Olck" typeface="Nirmala UI"/>
+        <a:font script="Osma" typeface="Ebrima"/>
+        <a:font script="Phag" typeface="Phagspa"/>
+        <a:font script="Syrn" typeface="Estrangelo Edessa"/>
+        <a:font script="Syrj" typeface="Estrangelo Edessa"/>
+        <a:font script="Syre" typeface="Estrangelo Edessa"/>
+        <a:font script="Sora" typeface="Nirmala UI"/>
+        <a:font script="Tale" typeface="Microsoft Tai Le"/>
+        <a:font script="Talu" typeface="Microsoft New Tai Lue"/>
+        <a:font script="Tfng" typeface="Ebrima"/>
+      </a:majorFont>
+      <a:minorFont>
+        <a:latin typeface="Calibri" panose="020F0502020204030204"/>
+        <a:ea typeface=""/>
+        <a:cs typeface=""/>
+        <a:font script="Jpan" typeface="游ゴシック"/>
+        <a:font script="Hang" typeface="맑은 고딕"/>
+        <a:font script="Hans" typeface="等线"/>
+        <a:font script="Hant" typeface="新細明體"/>
+        <a:font script="Arab" typeface="Arial"/>
+        <a:font script="Hebr" typeface="Arial"/>
+        <a:font script="Thai" typeface="Cordia New"/>
+        <a:font script="Ethi" typeface="Nyala"/>
+        <a:font script="Beng" typeface="Vrinda"/>
+        <a:font script="Gujr" typeface="Shruti"/>
+        <a:font script="Khmr" typeface="DaunPenh"/>
+        <a:font script="Knda" typeface="Tunga"/>
+        <a:font script="Guru" typeface="Raavi"/>
+        <a:font script="Cans" typeface="Euphemia"/>
+        <a:font script="Cher" typeface="Plantagenet Cherokee"/>
+        <a:font script="Yiii" typeface="Microsoft Yi Baiti"/>
+        <a:font script="Tibt" typeface="Microsoft Himalaya"/>
+        <a:font script="Thaa" typeface="MV Boli"/>
+        <a:font script="Deva" typeface="Mangal"/>
+        <a:font script="Telu" typeface="Gautami"/>
+        <a:font script="Taml" typeface="Latha"/>
+        <a:font script="Syrc" typeface="Estrangelo Edessa"/>
+        <a:font script="Orya" typeface="Kalinga"/>
+        <a:font script="Mlym" typeface="Kartika"/>
+        <a:font script="Laoo" typeface="DokChampa"/>
+        <a:font script="Sinh" typeface="Iskoola Pota"/>
+        <a:font script="Mong" typeface="Mongolian Baiti"/>
+        <a:font script="Viet" typeface="Arial"/>
+        <a:font script="Uigh" typeface="Microsoft Uighur"/>
+        <a:font script="Geor" typeface="Sylfaen"/>
+        <a:font script="Armn" typeface="Arial"/>
+        <a:font script="Bugi" typeface="Leelawadee UI"/>
+        <a:font script="Bopo" typeface="Microsoft JhengHei"/>
+        <a:font script="Java" typeface="Javanese Text"/>
+        <a:font script="Lisu" typeface="Segoe UI"/>
+        <a:font script="Mymr" typeface="Myanmar Text"/>
+        <a:font script="Nkoo" typeface="Ebrima"/>
+        <a:font script="Olck" typeface="Nirmala UI"/>
+        <a:font script="Osma" typeface="Ebrima"/>
+        <a:font script="Phag" typeface="Phagspa"/>
+        <a:font script="Syrn" typeface="Estrangelo Edessa"/>
+        <a:font script="Syrj" typeface="Estrangelo Edessa"/>
+        <a:font script="Syre" typeface="Estrangelo Edessa"/>
+        <a:font script="Sora" typeface="Nirmala UI"/>
+        <a:font script="Tale" typeface="Microsoft Tai Le"/>
+        <a:font script="Talu" typeface="Microsoft New Tai Lue"/>
+        <a:font script="Tfng" typeface="Ebrima"/>
+      </a:minorFont>
+    </a:fontScheme>
+    <a:fmtScheme name="Office">
+      <a:fillStyleLst>
+        <a:solidFill>
+          <a:schemeClr val="phClr"/>
+        </a:solidFill>
+        <a:gradFill rotWithShape="1">
+          <a:gsLst>
+            <a:gs pos="0">
+              <a:schemeClr val="phClr">
+                <a:lumMod val="110000"/>
+                <a:satMod val="105000"/>
+                <a:tint val="67000"/>
+              </a:schemeClr>
+            </a:gs>
+            <a:gs pos="50000">
+              <a:schemeClr val="phClr">
+                <a:lumMod val="105000"/>
+                <a:satMod val="103000"/>
+                <a:tint val="73000"/>
+              </a:schemeClr>
+            </a:gs>
+            <a:gs pos="100000">
+              <a:schemeClr val="phClr">
+                <a:lumMod val="105000"/>
+                <a:satMod val="109000"/>
+                <a:tint val="81000"/>
+              </a:schemeClr>
+            </a:gs>
+          </a:gsLst>
+          <a:lin ang="5400000" scaled="0"/>
+        </a:gradFill>
+        <a:gradFill rotWithShape="1">
+          <a:gsLst>
+            <a:gs pos="0">
+              <a:schemeClr val="phClr">
+                <a:satMod val="103000"/>
+                <a:lumMod val="102000"/>
+                <a:tint val="94000"/>
+              </a:schemeClr>
+            </a:gs>
+            <a:gs pos="50000">
+              <a:schemeClr val="phClr">
+                <a:satMod val="110000"/>
+                <a:lumMod val="100000"/>
+                <a:shade val="100000"/>
+              </a:schemeClr>
+            </a:gs>
+            <a:gs pos="100000">
+              <a:schemeClr val="phClr">
+                <a:lumMod val="99000"/>
+                <a:satMod val="120000"/>
+                <a:shade val="78000"/>
+              </a:schemeClr>
+            </a:gs>
+          </a:gsLst>
+          <a:lin ang="5400000" scaled="0"/>
+        </a:gradFill>
+      </a:fillStyleLst>
+      <a:lnStyleLst>
+        <a:ln w="6350" cap="flat" cmpd="sng" algn="ctr">
+          <a:solidFill>
+            <a:schemeClr val="phClr"/>
+          </a:solidFill>
+          <a:prstDash val="solid"/>
+          <a:miter lim="800000"/>
+        </a:ln>
+        <a:ln w="12700" cap="flat" cmpd="sng" algn="ctr">
+          <a:solidFill>
+            <a:schemeClr val="phClr"/>
+          </a:solidFill>
+          <a:prstDash val="solid"/>
+          <a:miter lim="800000"/>
+        </a:ln>
+        <a:ln w="19050" cap="flat" cmpd="sng" algn="ctr">
+          <a:solidFill>
+            <a:schemeClr val="phClr"/>
+          </a:solidFill>
+          <a:prstDash val="solid"/>
+          <a:miter lim="800000"/>
+        </a:ln>
+      </a:lnStyleLst>
+      <a:effectStyleLst>
+        <a:effectStyle>
+          <a:effectLst/>
+        </a:effectStyle>
+        <a:effectStyle>
+          <a:effectLst/>
+        </a:effectStyle>
+        <a:effectStyle>
+          <a:effectLst>
+            <a:outerShdw blurRad="57150" dist="19050" dir="5400000" algn="ctr" rotWithShape="0">
+              <a:srgbClr val="000000">
+                <a:alpha val="63000"/>
+              </a:srgbClr>
+            </a:outerShdw>
+          </a:effectLst>
+        </a:effectStyle>
+      </a:effectStyleLst>
+      <a:bgFillStyleLst>
+        <a:solidFill>
+          <a:schemeClr val="phClr"/>
+        </a:solidFill>
+        <a:solidFill>
+          <a:schemeClr val="phClr">
+            <a:tint val="95000"/>
+            <a:satMod val="170000"/>
+          </a:schemeClr>
+        </a:solidFill>
+        <a:gradFill rotWithShape="1">
+          <a:gsLst>
+            <a:gs pos="0">
+              <a:schemeClr val="phClr">
+                <a:tint val="93000"/>
+                <a:satMod val="150000"/>
+                <a:shade val="98000"/>
+                <a:lumMod val="102000"/>
+              </a:schemeClr>
+            </a:gs>
+            <a:gs pos="50000">
+              <a:schemeClr val="phClr">
+                <a:tint val="98000"/>
+                <a:satMod val="130000"/>
+                <a:shade val="90000"/>
+                <a:lumMod val="103000"/>
+              </a:schemeClr>
+            </a:gs>
+            <a:gs pos="100000">
+              <a:schemeClr val="phClr">
+                <a:shade val="63000"/>
+                <a:satMod val="120000"/>
+              </a:schemeClr>
+            </a:gs>
+          </a:gsLst>
+          <a:lin ang="5400000" scaled="0"/>
+        </a:gradFill>
+      </a:bgFillStyleLst>
+    </a:fmtScheme>
+  </a:themeElements>
+  <a:objectDefaults/>
+  <a:extraClrSchemeLst/>
+  <a:extLst>
+    <a:ext uri="{05A4C25C-085E-4340-85A3-A5531E510DB2}">
+      <thm15:themeFamily xmlns:thm15="http://schemas.microsoft.com/office/thememl/2012/main" name="Office Theme" id="{62F939B6-93AF-4DB8-9C6B-D6C7DFDC589F}" vid="{4A3C46E8-61CC-4603-A589-7422A47A8E4A}"/>
+    </a:ext>
+  </a:extLst>
+</a:theme>
 </file>
</xml_diff>

<commit_message>
Short brief: 'What it does' (auditable, harnessed and laddered, human channels, a working tool) and 'What that gives you' without overlap
Co-Authored-By: Claude Fable 5.1 <noreply@anthropic.com>
</commit_message>
<xml_diff>
--- a/docs/FedCast_Fullerton_short.pptx
+++ b/docs/FedCast_Fullerton_short.pptx
@@ -3126,7 +3126,7 @@
         </p:nvSpPr>
         <p:spPr>
           <a:xfrm>
-            <a:off x="548640" y="4983480"/>
+            <a:off x="548640" y="4846320"/>
             <a:ext cx="6400800" cy="274320"/>
           </a:xfrm>
           <a:prstGeom prst="rect">
@@ -3162,8 +3162,8 @@
         </p:nvSpPr>
         <p:spPr>
           <a:xfrm>
-            <a:off x="548640" y="5257800"/>
-            <a:ext cx="6492240" cy="1097280"/>
+            <a:off x="548640" y="5074920"/>
+            <a:ext cx="6492240" cy="1280160"/>
           </a:xfrm>
           <a:prstGeom prst="rect">
             <a:avLst/>
@@ -3175,7 +3175,7 @@
           <a:bodyPr wrap="square" lIns="0" tIns="0" rIns="0" bIns="0" rtlCol="0" anchor="t"/>
           <a:lstStyle/>
           <a:p>
-            <a:pPr marL="342900" indent="-342900">
+            <a:pPr marL="228600" indent="-228600">
               <a:spcAft>
                 <a:spcPts val="200"/>
               </a:spcAft>
@@ -3183,17 +3183,24 @@
               <a:buChar char="•"/>
             </a:pPr>
             <a:r>
+              <a:rPr lang="en-US" sz="950" b="1" dirty="0">
+                <a:solidFill>
+                  <a:schemeClr val="tx1"/>
+                </a:solidFill>
+              </a:rPr>
+              <a:t>Auditable by construction. </a:t>
+            </a:r>
+            <a:r>
               <a:rPr lang="en-US" sz="950" dirty="0">
                 <a:solidFill>
                   <a:schemeClr val="tx1"/>
                 </a:solidFill>
               </a:rPr>
-              <a:t>Freezes one fingerprinted snapshot of evidence per forecast; nothing outside it may be read.</a:t>
-            </a:r>
-            <a:endParaRPr lang="en-US" sz="950" dirty="0"/>
-          </a:p>
-          <a:p>
-            <a:pPr marL="342900" indent="-342900">
+              <a:t>Every analyst claim carries a verbatim quote and its source item; code matches the quote and flags any number not in the evidence. Every forecast is frozen with its snapshot in a hash-chained ledger and recomputes exactly.</a:t>
+            </a:r>
+          </a:p>
+          <a:p>
+            <a:pPr marL="228600" indent="-228600">
               <a:spcAft>
                 <a:spcPts val="200"/>
               </a:spcAft>
@@ -3201,17 +3208,24 @@
               <a:buChar char="•"/>
             </a:pPr>
             <a:r>
+              <a:rPr lang="en-US" sz="950" b="1" dirty="0">
+                <a:solidFill>
+                  <a:schemeClr val="tx1"/>
+                </a:solidFill>
+              </a:rPr>
+              <a:t>The LLM is harnessed, then laddered. </a:t>
+            </a:r>
+            <a:r>
               <a:rPr lang="en-US" sz="950" dirty="0">
                 <a:solidFill>
                   <a:schemeClr val="tx1"/>
                 </a:solidFill>
               </a:rPr>
-              <a:t>Enforces repeatability: five identical runs per analyst, tools off, every quote/output checked by code, a pre-registered scorecard on every snapshot.</a:t>
-            </a:r>
-            <a:endParaRPr lang="en-US" sz="950" dirty="0"/>
-          </a:p>
-          <a:p>
-            <a:pPr marL="342900" indent="-342900">
+              <a:t>Tools off, one slice of evidence, a fixed answer shape, five identical runs. The same model also runs with no harness, with evidence only and with structure only, so each technique's value is measured on a pre-registered scorecard.</a:t>
+            </a:r>
+          </a:p>
+          <a:p>
+            <a:pPr marL="228600" indent="-228600">
               <a:spcAft>
                 <a:spcPts val="200"/>
               </a:spcAft>
@@ -3219,17 +3233,24 @@
               <a:buChar char="•"/>
             </a:pPr>
             <a:r>
+              <a:rPr lang="en-US" sz="950" b="1" dirty="0">
+                <a:solidFill>
+                  <a:schemeClr val="tx1"/>
+                </a:solidFill>
+              </a:rPr>
+              <a:t>Human judgement through typed channels. </a:t>
+            </a:r>
+            <a:r>
               <a:rPr lang="en-US" sz="950" dirty="0">
                 <a:solidFill>
                   <a:schemeClr val="tx1"/>
                 </a:solidFill>
               </a:rPr>
-              <a:t>Offers typed channels for human judgement (views, watch-outs, documents, odds): bounded, recorded, scored afterwards. None active today.</a:t>
-            </a:r>
-            <a:endParaRPr lang="en-US" sz="950" dirty="0"/>
-          </a:p>
-          <a:p>
-            <a:pPr marL="342900" indent="-342900">
+              <a:t>Views tilt the number by a capped amount and expire; watch-outs must be answered by every analyst; documents and odds enter as evidence. All recorded and scored afterwards. None active today.</a:t>
+            </a:r>
+          </a:p>
+          <a:p>
+            <a:pPr marL="228600" indent="-228600">
               <a:spcAft>
                 <a:spcPts val="200"/>
               </a:spcAft>
@@ -3237,14 +3258,21 @@
               <a:buChar char="•"/>
             </a:pPr>
             <a:r>
+              <a:rPr lang="en-US" sz="950" b="1" dirty="0">
+                <a:solidFill>
+                  <a:schemeClr val="tx1"/>
+                </a:solidFill>
+              </a:rPr>
+              <a:t>A working tool. </a:t>
+            </a:r>
+            <a:r>
               <a:rPr lang="en-US" sz="950" dirty="0">
                 <a:solidFill>
                   <a:schemeClr val="tx1"/>
                 </a:solidFill>
               </a:rPr>
-              <a:t>Keeps every snapshot and forecast in a hash-chained ledger, so the number's path can be read back as information arrived.</a:t>
-            </a:r>
-            <a:endParaRPr lang="en-US" sz="950" dirty="0"/>
+              <a:t>A local app: pull evidence, run the forecast, read each analyst's claims, check the scorecard, score the decision once known. Runs anywhere from the repository.</a:t>
+            </a:r>
           </a:p>
         </p:txBody>
       </p:sp>
@@ -3707,7 +3735,7 @@
                   <a:schemeClr val="tx2"/>
                 </a:solidFill>
               </a:rPr>
-              <a:t>What this model offers</a:t>
+              <a:t>What that gives you</a:t>
             </a:r>
             <a:endParaRPr lang="en-US" sz="1200" dirty="0"/>
           </a:p>
@@ -3743,7 +3771,7 @@
                   <a:schemeClr val="tx1"/>
                 </a:solidFill>
               </a:rPr>
-              <a:t>Auditability</a:t>
+              <a:t>A number you can challenge: </a:t>
             </a:r>
             <a:r>
               <a:rPr lang="en-US" sz="950" dirty="0">
@@ -3751,7 +3779,7 @@
                   <a:schemeClr val="tx1"/>
                 </a:solidFill>
               </a:rPr>
-              <a:t>: every input visible, every forecast replayable. </a:t>
+              <a:t>when it moves, you can see which input moved it, and by how much.</a:t>
             </a:r>
           </a:p>
           <a:p>
@@ -3764,7 +3792,7 @@
                   <a:schemeClr val="tx1"/>
                 </a:solidFill>
               </a:rPr>
-              <a:t>Evidence-based</a:t>
+              <a:t>Nothing from memory: </a:t>
             </a:r>
             <a:r>
               <a:rPr lang="en-US" sz="950" dirty="0">
@@ -3772,7 +3800,7 @@
                   <a:schemeClr val="tx1"/>
                 </a:solidFill>
               </a:rPr>
-              <a:t>: every claim quoted and verified, nothing from memory. A harnessed LLM cannot give random or spurious answers; a naive LLM is kept as the control, so what the harness adds is measured, not assumed. Anyone can see how one piece of evidence moves the decision. </a:t>
+              <a:t>every claim traces to frozen evidence.</a:t>
             </a:r>
           </a:p>
           <a:p>
@@ -3780,16 +3808,12 @@
               <a:buNone/>
             </a:pPr>
             <a:r>
-              <a:rPr lang="en-US" sz="950" b="1" dirty="0" err="1"/>
-              <a:t>Backtest</a:t>
-            </a:r>
-            <a:r>
-              <a:rPr lang="en-US" sz="950" b="1" dirty="0"/>
-              <a:t>-able</a:t>
-            </a:r>
-            <a:r>
-              <a:rPr lang="en-US" sz="950" dirty="0"/>
-              <a:t>: </a:t>
+              <a:rPr lang="en-US" sz="950" b="1" dirty="0">
+                <a:solidFill>
+                  <a:schemeClr val="tx1"/>
+                </a:solidFill>
+              </a:rPr>
+              <a:t>Proof of what the harness adds, </a:t>
             </a:r>
             <a:r>
               <a:rPr lang="en-US" sz="950" dirty="0">
@@ -3797,9 +3821,50 @@
                   <a:schemeClr val="tx1"/>
                 </a:solidFill>
               </a:rPr>
-              <a:t>the model can be scrutinised and improved, instead of hoping the LLM works.</a:t>
-            </a:r>
-            <a:endParaRPr lang="en-US" sz="950" dirty="0"/>
+              <a:t>from the naive control.</a:t>
+            </a:r>
+          </a:p>
+          <a:p>
+            <a:pPr marL="0" indent="0">
+              <a:buNone/>
+            </a:pPr>
+            <a:r>
+              <a:rPr lang="en-US" sz="950" b="1" dirty="0">
+                <a:solidFill>
+                  <a:schemeClr val="tx1"/>
+                </a:solidFill>
+              </a:rPr>
+              <a:t>A model that can be scrutinised and improved, </a:t>
+            </a:r>
+            <a:r>
+              <a:rPr lang="en-US" sz="950" dirty="0">
+                <a:solidFill>
+                  <a:schemeClr val="tx1"/>
+                </a:solidFill>
+              </a:rPr>
+              <a:t>instead of hoping the LLM works.</a:t>
+            </a:r>
+          </a:p>
+          <a:p>
+            <a:pPr marL="0" indent="0">
+              <a:buNone/>
+            </a:pPr>
+            <a:r>
+              <a:rPr lang="en-US" sz="950" b="1" dirty="0">
+                <a:solidFill>
+                  <a:schemeClr val="tx1"/>
+                </a:solidFill>
+              </a:rPr>
+              <a:t>A record that starts this week: </a:t>
+            </a:r>
+            <a:r>
+              <a:rPr lang="en-US" sz="950" dirty="0">
+                <a:solidFill>
+                  <a:schemeClr val="tx1"/>
+                </a:solidFill>
+              </a:rPr>
+              <a:t>the first live decision is scored.</a:t>
+            </a:r>
           </a:p>
         </p:txBody>
       </p:sp>

</xml_diff>

<commit_message>
Long deck: About-me slide taken from the short brief (owner's edited version with photo); apply_about.ps1 keeps it on rebuild
Co-Authored-By: Claude Fable 5.1 <noreply@anthropic.com>
</commit_message>
<xml_diff>
--- a/docs/FedCast_Fullerton_short.pptx
+++ b/docs/FedCast_Fullerton_short.pptx
@@ -778,7 +778,7 @@
           </a:prstGeom>
           <a:extLst>
             <a:ext uri="{C572A759-6A51-4108-AA02-DFA0A04FC94B}">
-              <ma14:wrappingTextBoxFlag xmlns:ma14="http://schemas.microsoft.com/office/mac/drawingml/2011/main" xmlns="" val="0"/>
+              <ma14:wrappingTextBoxFlag xmlns="" xmlns:ma14="http://schemas.microsoft.com/office/mac/drawingml/2011/main" val="0"/>
             </a:ext>
           </a:extLst>
         </p:spPr>
@@ -853,7 +853,7 @@
           </a:prstGeom>
           <a:extLst>
             <a:ext uri="{C572A759-6A51-4108-AA02-DFA0A04FC94B}">
-              <ma14:wrappingTextBoxFlag xmlns:ma14="http://schemas.microsoft.com/office/mac/drawingml/2011/main" xmlns="" val="0"/>
+              <ma14:wrappingTextBoxFlag xmlns="" xmlns:ma14="http://schemas.microsoft.com/office/mac/drawingml/2011/main" val="0"/>
             </a:ext>
           </a:extLst>
         </p:spPr>
@@ -1441,9 +1441,12 @@
                   <a:schemeClr val="tx1"/>
                 </a:solidFill>
               </a:rPr>
-              <a:t>Senior AI, Data and Technology Consultant, seconded to Temasek Holdings, Digital Innovation (2023 to now)</a:t>
-            </a:r>
-            <a:endParaRPr lang="en-US" sz="1250" dirty="0"/>
+              <a:t>Senior AI, Data and Technology Consultant, seconded to </a:t>
+            </a:r>
+            <a:r>
+              <a:rPr lang="en-US" sz="1250" dirty="0"/>
+              <a:t>Sovereign Wealth Fund. </a:t>
+            </a:r>
           </a:p>
         </p:txBody>
       </p:sp>
@@ -1517,7 +1520,19 @@
                   <a:schemeClr val="tx1"/>
                 </a:solidFill>
               </a:rPr>
-              <a:t>Data scientist, RSAF Data Office: authored the Air Force's AI strategy, set up its first digital unit</a:t>
+              <a:t>Data scientist, RSAF Data Office: </a:t>
+            </a:r>
+            <a:r>
+              <a:rPr lang="en-US" sz="1150" dirty="0"/>
+              <a:t>contributed to RSAF AI Strategy</a:t>
+            </a:r>
+            <a:r>
+              <a:rPr lang="en-US" sz="1150" dirty="0">
+                <a:solidFill>
+                  <a:schemeClr val="tx1"/>
+                </a:solidFill>
+              </a:rPr>
+              <a:t>, set up its first digital unit</a:t>
             </a:r>
             <a:endParaRPr lang="en-US" sz="1150" dirty="0"/>
           </a:p>
@@ -1643,7 +1658,7 @@
                   <a:schemeClr val="tx2"/>
                 </a:solidFill>
               </a:rPr>
-              <a:t>Things I have built that models had to earn trust in</a:t>
+              <a:t>Things I have built that models/Applications in</a:t>
             </a:r>
             <a:endParaRPr lang="en-US" sz="1600" dirty="0"/>
           </a:p>
@@ -1740,7 +1755,7 @@
                   <a:schemeClr val="tx2"/>
                 </a:solidFill>
               </a:rPr>
-              <a:t>Investment analytics at Temasek</a:t>
+              <a:t>Investment analytics, valuation and execution</a:t>
             </a:r>
             <a:endParaRPr lang="en-US" sz="1300" dirty="0"/>
           </a:p>
@@ -1754,7 +1769,7 @@
         </p:nvSpPr>
         <p:spPr>
           <a:xfrm>
-            <a:off x="5897880" y="2286000"/>
+            <a:off x="5879592" y="2234363"/>
             <a:ext cx="5760720" cy="713232"/>
           </a:xfrm>
           <a:prstGeom prst="rect">
@@ -1767,30 +1782,49 @@
           <a:bodyPr wrap="square" lIns="0" tIns="0" rIns="0" bIns="0" rtlCol="0" anchor="t"/>
           <a:lstStyle/>
           <a:p>
-            <a:pPr marL="0" indent="0">
-              <a:buNone/>
-            </a:pPr>
-            <a:r>
-              <a:rPr lang="en-US" sz="1050" dirty="0">
-                <a:solidFill>
-                  <a:schemeClr val="tx1"/>
-                </a:solidFill>
-              </a:rPr>
-              <a:t>An AI-assisted analyst performance and attribution platform for 50+ investment professionals, with an LLM signal tracker for high-conviction ideas; signal cadence moved from monthly to daily, every recommendation logged in real time.</a:t>
-            </a:r>
-            <a:endParaRPr lang="en-US" sz="1050" dirty="0"/>
-          </a:p>
-        </p:txBody>
-      </p:sp>
-      <p:sp>
-        <p:nvSpPr>
-          <p:cNvPr id="16" name="Shape 13"/>
+            <a:pPr lvl="0"/>
+            <a:r>
+              <a:rPr lang="en-US" sz="1050" b="1" dirty="0"/>
+              <a:t>Investment analytics:</a:t>
+            </a:r>
+            <a:r>
+              <a:rPr lang="en-US" sz="1050" dirty="0"/>
+              <a:t> AI-assisted performance attribution and idea tracking for an investment team.</a:t>
+            </a:r>
+          </a:p>
+          <a:p>
+            <a:pPr lvl="0"/>
+            <a:r>
+              <a:rPr lang="en-US" sz="1050" b="1" dirty="0"/>
+              <a:t>Valuation:</a:t>
+            </a:r>
+            <a:r>
+              <a:rPr lang="en-US" sz="1050" dirty="0"/>
+              <a:t> Machine-learning valuation for illiquid assets.</a:t>
+            </a:r>
+          </a:p>
+          <a:p>
+            <a:pPr lvl="0"/>
+            <a:r>
+              <a:rPr lang="en-US" sz="1050" b="1" dirty="0"/>
+              <a:t>Execution:</a:t>
+            </a:r>
+            <a:r>
+              <a:rPr lang="en-US" sz="1050" dirty="0"/>
+              <a:t> Trade workflow automation for investment teams.</a:t>
+            </a:r>
+          </a:p>
+        </p:txBody>
+      </p:sp>
+      <p:sp>
+        <p:nvSpPr>
+          <p:cNvPr id="20" name="Shape 17"/>
           <p:cNvSpPr/>
           <p:nvPr/>
         </p:nvSpPr>
         <p:spPr>
           <a:xfrm>
-            <a:off x="5394960" y="3035808"/>
+            <a:off x="5394960" y="3377722"/>
             <a:ext cx="384048" cy="384048"/>
           </a:xfrm>
           <a:prstGeom prst="ellipse">
@@ -1809,13 +1843,13 @@
       </p:sp>
       <p:sp>
         <p:nvSpPr>
-          <p:cNvPr id="17" name="Text 14"/>
+          <p:cNvPr id="21" name="Text 18"/>
           <p:cNvSpPr txBox="1"/>
           <p:nvPr/>
         </p:nvSpPr>
         <p:spPr>
           <a:xfrm>
-            <a:off x="5394960" y="3035808"/>
+            <a:off x="5394960" y="3377722"/>
             <a:ext cx="384048" cy="384048"/>
           </a:xfrm>
           <a:prstGeom prst="rect">
@@ -1845,13 +1879,13 @@
       </p:sp>
       <p:sp>
         <p:nvSpPr>
-          <p:cNvPr id="18" name="Text 15"/>
+          <p:cNvPr id="22" name="Text 19"/>
           <p:cNvSpPr txBox="1"/>
           <p:nvPr/>
         </p:nvSpPr>
         <p:spPr>
           <a:xfrm>
-            <a:off x="5897880" y="2990088"/>
+            <a:off x="5897880" y="3332002"/>
             <a:ext cx="5760720" cy="320040"/>
           </a:xfrm>
           <a:prstGeom prst="rect">
@@ -1873,7 +1907,7 @@
                   <a:schemeClr val="tx2"/>
                 </a:solidFill>
               </a:rPr>
-              <a:t>Valuation and execution</a:t>
+              <a:t>Data Science </a:t>
             </a:r>
             <a:endParaRPr lang="en-US" sz="1300" dirty="0"/>
           </a:p>
@@ -1881,13 +1915,13 @@
       </p:sp>
       <p:sp>
         <p:nvSpPr>
-          <p:cNvPr id="19" name="Text 16"/>
+          <p:cNvPr id="23" name="Text 20"/>
           <p:cNvSpPr txBox="1"/>
           <p:nvPr/>
         </p:nvSpPr>
         <p:spPr>
           <a:xfrm>
-            <a:off x="5897880" y="3310128"/>
+            <a:off x="5897880" y="3652042"/>
             <a:ext cx="5760720" cy="713232"/>
           </a:xfrm>
           <a:prstGeom prst="rect">
@@ -1909,7 +1943,44 @@
                   <a:schemeClr val="tx1"/>
                 </a:solidFill>
               </a:rPr>
-              <a:t>A machine-learning mark-to-market for private holdings, systematic and reproducible; and an AI-driven order management system on AWS processing about S$30m a day, replacing an email-based workflow.</a:t>
+              <a:t>- 4th of 160+ teams (MIT, DoD, USAF) in the 2023 USAF AI Accelerator, predicting pilot flying difficulty from physiology; </a:t>
+            </a:r>
+          </a:p>
+          <a:p>
+            <a:pPr marL="0" indent="0">
+              <a:buNone/>
+            </a:pPr>
+            <a:r>
+              <a:rPr lang="en-US" sz="1050" dirty="0"/>
+              <a:t>- A</a:t>
+            </a:r>
+            <a:r>
+              <a:rPr lang="en-US" sz="1050" dirty="0">
+                <a:solidFill>
+                  <a:schemeClr val="tx1"/>
+                </a:solidFill>
+              </a:rPr>
+              <a:t>n ammunition recommender (quantile LightGBM) that cut wastage with no shortfall</a:t>
+            </a:r>
+            <a:r>
+              <a:rPr lang="en-US" sz="1050" dirty="0"/>
+              <a:t> -&gt; </a:t>
+            </a:r>
+            <a:r>
+              <a:rPr lang="en-US" sz="1050" dirty="0" err="1">
+                <a:solidFill>
+                  <a:schemeClr val="tx1"/>
+                </a:solidFill>
+              </a:rPr>
+              <a:t>Defence</a:t>
+            </a:r>
+            <a:r>
+              <a:rPr lang="en-US" sz="1050" dirty="0">
+                <a:solidFill>
+                  <a:schemeClr val="tx1"/>
+                </a:solidFill>
+              </a:rPr>
+              <a:t> Manpower Committee Innovation Award 2022.</a:t>
             </a:r>
             <a:endParaRPr lang="en-US" sz="1050" dirty="0"/>
           </a:p>
@@ -1917,13 +1988,13 @@
       </p:sp>
       <p:sp>
         <p:nvSpPr>
-          <p:cNvPr id="20" name="Shape 17"/>
+          <p:cNvPr id="24" name="Shape 21"/>
           <p:cNvSpPr/>
           <p:nvPr/>
         </p:nvSpPr>
         <p:spPr>
           <a:xfrm>
-            <a:off x="5394960" y="4059936"/>
+            <a:off x="5394960" y="4809744"/>
             <a:ext cx="384048" cy="384048"/>
           </a:xfrm>
           <a:prstGeom prst="ellipse">
@@ -1942,146 +2013,13 @@
       </p:sp>
       <p:sp>
         <p:nvSpPr>
-          <p:cNvPr id="21" name="Text 18"/>
-          <p:cNvSpPr txBox="1"/>
-          <p:nvPr/>
-        </p:nvSpPr>
-        <p:spPr>
-          <a:xfrm>
-            <a:off x="5394960" y="4059936"/>
-            <a:ext cx="384048" cy="384048"/>
-          </a:xfrm>
-          <a:prstGeom prst="rect">
-            <a:avLst/>
-          </a:prstGeom>
-          <a:noFill/>
-          <a:ln/>
-        </p:spPr>
-        <p:txBody>
-          <a:bodyPr wrap="square" lIns="0" tIns="0" rIns="0" bIns="0" rtlCol="0" anchor="ctr"/>
-          <a:lstStyle/>
-          <a:p>
-            <a:pPr marL="0" indent="0" algn="ctr">
-              <a:buNone/>
-            </a:pPr>
-            <a:r>
-              <a:rPr lang="en-US" sz="1400" b="1" dirty="0">
-                <a:solidFill>
-                  <a:schemeClr val="bg1"/>
-                </a:solidFill>
-              </a:rPr>
-              <a:t>3</a:t>
-            </a:r>
-            <a:endParaRPr lang="en-US" sz="1400" dirty="0"/>
-          </a:p>
-        </p:txBody>
-      </p:sp>
-      <p:sp>
-        <p:nvSpPr>
-          <p:cNvPr id="22" name="Text 19"/>
-          <p:cNvSpPr txBox="1"/>
-          <p:nvPr/>
-        </p:nvSpPr>
-        <p:spPr>
-          <a:xfrm>
-            <a:off x="5897880" y="4014216"/>
-            <a:ext cx="5760720" cy="320040"/>
-          </a:xfrm>
-          <a:prstGeom prst="rect">
-            <a:avLst/>
-          </a:prstGeom>
-          <a:noFill/>
-          <a:ln/>
-        </p:spPr>
-        <p:txBody>
-          <a:bodyPr wrap="square" lIns="0" tIns="0" rIns="0" bIns="0" rtlCol="0" anchor="t"/>
-          <a:lstStyle/>
-          <a:p>
-            <a:pPr marL="0" indent="0">
-              <a:buNone/>
-            </a:pPr>
-            <a:r>
-              <a:rPr lang="en-US" sz="1300" b="1" dirty="0">
-                <a:solidFill>
-                  <a:schemeClr val="tx2"/>
-                </a:solidFill>
-              </a:rPr>
-              <a:t>Forecasting under a scoreboard</a:t>
-            </a:r>
-            <a:endParaRPr lang="en-US" sz="1300" dirty="0"/>
-          </a:p>
-        </p:txBody>
-      </p:sp>
-      <p:sp>
-        <p:nvSpPr>
-          <p:cNvPr id="23" name="Text 20"/>
-          <p:cNvSpPr txBox="1"/>
-          <p:nvPr/>
-        </p:nvSpPr>
-        <p:spPr>
-          <a:xfrm>
-            <a:off x="5897880" y="4334256"/>
-            <a:ext cx="5760720" cy="713232"/>
-          </a:xfrm>
-          <a:prstGeom prst="rect">
-            <a:avLst/>
-          </a:prstGeom>
-          <a:noFill/>
-          <a:ln/>
-        </p:spPr>
-        <p:txBody>
-          <a:bodyPr wrap="square" lIns="0" tIns="0" rIns="0" bIns="0" rtlCol="0" anchor="t"/>
-          <a:lstStyle/>
-          <a:p>
-            <a:pPr marL="0" indent="0">
-              <a:buNone/>
-            </a:pPr>
-            <a:r>
-              <a:rPr lang="en-US" sz="1050" dirty="0">
-                <a:solidFill>
-                  <a:schemeClr val="tx1"/>
-                </a:solidFill>
-              </a:rPr>
-              <a:t>4th of 160+ teams (MIT, DoD, USAF) in the 2023 USAF AI Accelerator, predicting pilot flying difficulty from physiology; an ammunition recommender (quantile LightGBM) that cut wastage with no shortfall, Defence Manpower Committee Innovation Award 2022.</a:t>
-            </a:r>
-            <a:endParaRPr lang="en-US" sz="1050" dirty="0"/>
-          </a:p>
-        </p:txBody>
-      </p:sp>
-      <p:sp>
-        <p:nvSpPr>
-          <p:cNvPr id="24" name="Shape 21"/>
-          <p:cNvSpPr/>
-          <p:nvPr/>
-        </p:nvSpPr>
-        <p:spPr>
-          <a:xfrm>
-            <a:off x="5394960" y="5084064"/>
-            <a:ext cx="384048" cy="384048"/>
-          </a:xfrm>
-          <a:prstGeom prst="ellipse">
-            <a:avLst/>
-          </a:prstGeom>
-          <a:solidFill>
-            <a:srgbClr val="1E2761"/>
-          </a:solidFill>
-          <a:ln w="12700">
-            <a:solidFill>
-              <a:srgbClr val="1E2761"/>
-            </a:solidFill>
-            <a:prstDash val="solid"/>
-          </a:ln>
-        </p:spPr>
-      </p:sp>
-      <p:sp>
-        <p:nvSpPr>
           <p:cNvPr id="25" name="Text 22"/>
           <p:cNvSpPr txBox="1"/>
           <p:nvPr/>
         </p:nvSpPr>
         <p:spPr>
           <a:xfrm>
-            <a:off x="5394960" y="5084064"/>
+            <a:off x="5394960" y="4809744"/>
             <a:ext cx="384048" cy="384048"/>
           </a:xfrm>
           <a:prstGeom prst="rect">
@@ -2103,7 +2041,7 @@
                   <a:schemeClr val="bg1"/>
                 </a:solidFill>
               </a:rPr>
-              <a:t>4</a:t>
+              <a:t>3</a:t>
             </a:r>
             <a:endParaRPr lang="en-US" sz="1400" dirty="0"/>
           </a:p>
@@ -2117,7 +2055,7 @@
         </p:nvSpPr>
         <p:spPr>
           <a:xfrm>
-            <a:off x="5897880" y="5038344"/>
+            <a:off x="5897880" y="4764024"/>
             <a:ext cx="5760720" cy="320040"/>
           </a:xfrm>
           <a:prstGeom prst="rect">
@@ -2153,7 +2091,7 @@
         </p:nvSpPr>
         <p:spPr>
           <a:xfrm>
-            <a:off x="5897880" y="5358384"/>
+            <a:off x="5897880" y="5084064"/>
             <a:ext cx="5760720" cy="713232"/>
           </a:xfrm>
           <a:prstGeom prst="rect">
@@ -2201,7 +2139,7 @@
           </a:prstGeom>
           <a:extLst>
             <a:ext uri="{C572A759-6A51-4108-AA02-DFA0A04FC94B}">
-              <ma14:wrappingTextBoxFlag xmlns:ma14="http://schemas.microsoft.com/office/mac/drawingml/2011/main" xmlns="" val="0"/>
+              <ma14:wrappingTextBoxFlag xmlns="" xmlns:ma14="http://schemas.microsoft.com/office/mac/drawingml/2011/main" val="0"/>
             </a:ext>
           </a:extLst>
         </p:spPr>
@@ -2248,12 +2186,16 @@
         </p:blipFill>
         <p:spPr>
           <a:xfrm>
-            <a:off x="10307618" y="277682"/>
+            <a:off x="10339174" y="536044"/>
             <a:ext cx="1232199" cy="1232199"/>
           </a:xfrm>
-          <a:prstGeom prst="rect">
-            <a:avLst/>
-          </a:prstGeom>
+          <a:prstGeom prst="ellipse">
+            <a:avLst/>
+          </a:prstGeom>
+          <a:ln w="63500" cap="rnd">
+            <a:noFill/>
+          </a:ln>
+          <a:effectLst/>
         </p:spPr>
       </p:pic>
     </p:spTree>
@@ -2592,22 +2534,6 @@
               </a:rPr>
               <a:t>What followed each kind of decision over 32 years of FOMC history</a:t>
             </a:r>
-            <a:r>
-              <a:rPr lang="en-US" sz="850" dirty="0" err="1">
-                <a:solidFill>
-                  <a:schemeClr val="bg1"/>
-                </a:solidFill>
-              </a:rPr>
-              <a:t/>
-            </a:r>
-            <a:r>
-              <a:rPr lang="en-US" sz="850" dirty="0">
-                <a:solidFill>
-                  <a:schemeClr val="bg1"/>
-                </a:solidFill>
-              </a:rPr>
-              <a:t/>
-            </a:r>
             <a:endParaRPr lang="en-US" sz="850" dirty="0"/>
           </a:p>
         </p:txBody>
@@ -3196,7 +3122,7 @@
                   <a:schemeClr val="tx1"/>
                 </a:solidFill>
               </a:rPr>
-              <a:t>Every analyst claim carries a verbatim quote and its source item; code matches the quote and flags any number not in the evidence. Every forecast is frozen with its snapshot in a hash-chained ledger and recomputes exactly.</a:t>
+              <a:t>Every analyst claim carries a verbatim quote and its source item; code checks the quote and flags any number not in the evidence. Every forecast is frozen with its snapshot in a hash-chained ledger and recomputes exactly.</a:t>
             </a:r>
           </a:p>
           <a:p>
@@ -3448,6 +3374,9 @@
             </a:r>
           </a:p>
           <a:p>
+            <a:endParaRPr lang="en-US" sz="950" b="1" dirty="0"/>
+          </a:p>
+          <a:p>
             <a:pPr marL="0" indent="0">
               <a:buNone/>
             </a:pPr>
@@ -3471,7 +3400,7 @@
         </p:nvSpPr>
         <p:spPr>
           <a:xfrm>
-            <a:off x="7315200" y="3675888"/>
+            <a:off x="7315200" y="3840480"/>
             <a:ext cx="384048" cy="384048"/>
           </a:xfrm>
           <a:prstGeom prst="ellipse">
@@ -3496,7 +3425,7 @@
         </p:nvSpPr>
         <p:spPr>
           <a:xfrm>
-            <a:off x="7315200" y="3675888"/>
+            <a:off x="7315200" y="3854196"/>
             <a:ext cx="384048" cy="384048"/>
           </a:xfrm>
           <a:prstGeom prst="rect">
@@ -3532,7 +3461,7 @@
         </p:nvSpPr>
         <p:spPr>
           <a:xfrm>
-            <a:off x="7818120" y="3639312"/>
+            <a:off x="7818120" y="3817620"/>
             <a:ext cx="3822192" cy="365760"/>
           </a:xfrm>
           <a:prstGeom prst="rect">
@@ -3568,7 +3497,7 @@
         </p:nvSpPr>
         <p:spPr>
           <a:xfrm>
-            <a:off x="7818120" y="4041648"/>
+            <a:off x="7818120" y="4014216"/>
             <a:ext cx="3822192" cy="960120"/>
           </a:xfrm>
           <a:prstGeom prst="rect">
@@ -3590,7 +3519,7 @@
                   <a:schemeClr val="tx1"/>
                 </a:solidFill>
               </a:rPr>
-              <a:t>Either empirical formulas and market prices alone, or everything thrown at a language model. Ours combines the three: </a:t>
+              <a:t>Most fed predictors either empirical formulas and market prices alone, or everything thrown at a language model. Ours combines the three: </a:t>
             </a:r>
             <a:r>
               <a:rPr lang="en-US" sz="950" b="1" dirty="0">
@@ -3749,7 +3678,7 @@
         </p:nvSpPr>
         <p:spPr>
           <a:xfrm>
-            <a:off x="7818119" y="5413248"/>
+            <a:off x="7818119" y="5239512"/>
             <a:ext cx="3934609" cy="960120"/>
           </a:xfrm>
           <a:prstGeom prst="rect">
@@ -3771,7 +3700,7 @@
                   <a:schemeClr val="tx1"/>
                 </a:solidFill>
               </a:rPr>
-              <a:t>A number you can challenge: </a:t>
+              <a:t>Explainability: </a:t>
             </a:r>
             <a:r>
               <a:rPr lang="en-US" sz="950" dirty="0">
@@ -3792,7 +3721,7 @@
                   <a:schemeClr val="tx1"/>
                 </a:solidFill>
               </a:rPr>
-              <a:t>Nothing from memory: </a:t>
+              <a:t>Auditable: </a:t>
             </a:r>
             <a:r>
               <a:rPr lang="en-US" sz="950" dirty="0">
@@ -3813,7 +3742,7 @@
                   <a:schemeClr val="tx1"/>
                 </a:solidFill>
               </a:rPr>
-              <a:t>Proof of what the harness adds, </a:t>
+              <a:t>Proof of what the harness adds: </a:t>
             </a:r>
             <a:r>
               <a:rPr lang="en-US" sz="950" dirty="0">
@@ -3834,7 +3763,11 @@
                   <a:schemeClr val="tx1"/>
                 </a:solidFill>
               </a:rPr>
-              <a:t>A model that can be scrutinised and improved, </a:t>
+              <a:t>A model that can be scrutinized and improved:</a:t>
+            </a:r>
+            <a:r>
+              <a:rPr lang="en-US" sz="950" b="1" dirty="0"/>
+              <a:t> I</a:t>
             </a:r>
             <a:r>
               <a:rPr lang="en-US" sz="950" dirty="0">
@@ -3842,28 +3775,7 @@
                   <a:schemeClr val="tx1"/>
                 </a:solidFill>
               </a:rPr>
-              <a:t>instead of hoping the LLM works.</a:t>
-            </a:r>
-          </a:p>
-          <a:p>
-            <a:pPr marL="0" indent="0">
-              <a:buNone/>
-            </a:pPr>
-            <a:r>
-              <a:rPr lang="en-US" sz="950" b="1" dirty="0">
-                <a:solidFill>
-                  <a:schemeClr val="tx1"/>
-                </a:solidFill>
-              </a:rPr>
-              <a:t>A record that starts this week: </a:t>
-            </a:r>
-            <a:r>
-              <a:rPr lang="en-US" sz="950" dirty="0">
-                <a:solidFill>
-                  <a:schemeClr val="tx1"/>
-                </a:solidFill>
-              </a:rPr>
-              <a:t>the first live decision is scored.</a:t>
+              <a:t>nstead of hoping the LLM works.</a:t>
             </a:r>
           </a:p>
         </p:txBody>
@@ -3888,7 +3800,7 @@
           </a:prstGeom>
           <a:extLst>
             <a:ext uri="{C572A759-6A51-4108-AA02-DFA0A04FC94B}">
-              <ma14:wrappingTextBoxFlag xmlns:ma14="http://schemas.microsoft.com/office/mac/drawingml/2011/main" xmlns="" val="0"/>
+              <ma14:wrappingTextBoxFlag xmlns="" xmlns:ma14="http://schemas.microsoft.com/office/mac/drawingml/2011/main" val="0"/>
             </a:ext>
           </a:extLst>
         </p:spPr>

</xml_diff>